<commit_message>
Rework lab-2 slides: language colors, pipeline row, implementation snippets
Languages in graph figures and HTML views now use violet/yellow/aqua so that
orange/blue keep meaning before/after in the deck. The pipeline row no longer
hyphenates step names and centers the arrows. Stage slides show one-line code
snippets of how each stage is implemented.

Co-Authored-By: Claude Opus 5.5 <noreply@anthropic.com>
</commit_message>
<xml_diff>
--- a/1-graph/lab-2/results/presentation.pptx
+++ b/1-graph/lab-2/results/presentation.pptx
@@ -6075,8 +6075,8 @@
         </p:nvSpPr>
         <p:spPr>
           <a:xfrm>
-            <a:off x="548640" y="1755648"/>
-            <a:ext cx="1554480" cy="457200"/>
+            <a:off x="548640" y="1828800"/>
+            <a:ext cx="1280160" cy="365760"/>
           </a:xfrm>
           <a:prstGeom prst="rect">
             <a:avLst/>
@@ -6114,8 +6114,8 @@
         </p:nvSpPr>
         <p:spPr>
           <a:xfrm>
-            <a:off x="2148840" y="1645920"/>
-            <a:ext cx="1481328" cy="658368"/>
+            <a:off x="1920240" y="1645920"/>
+            <a:ext cx="1170432" cy="658368"/>
           </a:xfrm>
           <a:prstGeom prst="roundRect">
             <a:avLst>
@@ -6147,18 +6147,18 @@
           </a:fontRef>
         </p:style>
         <p:txBody>
-          <a:bodyPr rtlCol="0" anchor="ctr" lIns="36576" rIns="36576"/>
+          <a:bodyPr rtlCol="0" anchor="ctr" lIns="18288" rIns="18288" wrap="none"/>
           <a:lstStyle/>
           <a:p>
             <a:pPr algn="ctr"/>
             <a:r>
-              <a:rPr sz="1200">
+              <a:rPr sz="1100">
                 <a:solidFill>
                   <a:srgbClr val="1F2328"/>
                 </a:solidFill>
                 <a:latin typeface="Calibri"/>
               </a:rPr>
-              <a:t>PDF</a:t>
+              <a:t>MinerU</a:t>
             </a:r>
           </a:p>
         </p:txBody>
@@ -6171,8 +6171,8 @@
         </p:nvSpPr>
         <p:spPr>
           <a:xfrm>
-            <a:off x="3630168" y="1773936"/>
-            <a:ext cx="228600" cy="365760"/>
+            <a:off x="3090672" y="1645920"/>
+            <a:ext cx="237744" cy="658368"/>
           </a:xfrm>
           <a:prstGeom prst="rect">
             <a:avLst/>
@@ -6180,7 +6180,7 @@
           <a:noFill/>
         </p:spPr>
         <p:txBody>
-          <a:bodyPr wrap="square" lIns="0" rIns="0" tIns="0" bIns="0">
+          <a:bodyPr wrap="square" lIns="0" rIns="0" tIns="0" bIns="0" anchor="ctr">
             <a:spAutoFit/>
           </a:bodyPr>
           <a:lstStyle/>
@@ -6191,7 +6191,7 @@
               </a:spcAft>
             </a:pPr>
             <a:r>
-              <a:rPr sz="1600" b="0">
+              <a:rPr sz="1400" b="0">
                 <a:solidFill>
                   <a:srgbClr val="5F5E5A"/>
                 </a:solidFill>
@@ -6210,8 +6210,8 @@
         </p:nvSpPr>
         <p:spPr>
           <a:xfrm>
-            <a:off x="3858768" y="1645920"/>
-            <a:ext cx="1481328" cy="658368"/>
+            <a:off x="3328416" y="1645920"/>
+            <a:ext cx="1170432" cy="658368"/>
           </a:xfrm>
           <a:prstGeom prst="roundRect">
             <a:avLst>
@@ -6243,18 +6243,18 @@
           </a:fontRef>
         </p:style>
         <p:txBody>
-          <a:bodyPr rtlCol="0" anchor="ctr" lIns="36576" rIns="36576"/>
+          <a:bodyPr rtlCol="0" anchor="ctr" lIns="18288" rIns="18288" wrap="none"/>
           <a:lstStyle/>
           <a:p>
             <a:pPr algn="ctr"/>
             <a:r>
-              <a:rPr sz="1200">
+              <a:rPr sz="1100">
                 <a:solidFill>
                   <a:srgbClr val="1F2328"/>
                 </a:solidFill>
                 <a:latin typeface="Calibri"/>
               </a:rPr>
-              <a:t>MinerU</a:t>
+              <a:t>GraphRAG</a:t>
             </a:r>
           </a:p>
         </p:txBody>
@@ -6267,8 +6267,8 @@
         </p:nvSpPr>
         <p:spPr>
           <a:xfrm>
-            <a:off x="5340096" y="1773936"/>
-            <a:ext cx="228600" cy="365760"/>
+            <a:off x="548640" y="2926080"/>
+            <a:ext cx="1280160" cy="365760"/>
           </a:xfrm>
           <a:prstGeom prst="rect">
             <a:avLst/>
@@ -6281,102 +6281,6 @@
           </a:bodyPr>
           <a:lstStyle/>
           <a:p>
-            <a:pPr algn="ctr">
-              <a:spcAft>
-                <a:spcPts val="600"/>
-              </a:spcAft>
-            </a:pPr>
-            <a:r>
-              <a:rPr sz="1600" b="0">
-                <a:solidFill>
-                  <a:srgbClr val="5F5E5A"/>
-                </a:solidFill>
-                <a:latin typeface="Calibri"/>
-              </a:rPr>
-              <a:t>→</a:t>
-            </a:r>
-          </a:p>
-        </p:txBody>
-      </p:sp>
-      <p:sp>
-        <p:nvSpPr>
-          <p:cNvPr id="8" name="Rounded Rectangle 7"/>
-          <p:cNvSpPr/>
-          <p:nvPr/>
-        </p:nvSpPr>
-        <p:spPr>
-          <a:xfrm>
-            <a:off x="5568696" y="1645920"/>
-            <a:ext cx="1481328" cy="658368"/>
-          </a:xfrm>
-          <a:prstGeom prst="roundRect">
-            <a:avLst>
-              <a:gd name="adj" fmla="val 15000"/>
-            </a:avLst>
-          </a:prstGeom>
-          <a:solidFill>
-            <a:srgbClr val="F1F4F8"/>
-          </a:solidFill>
-          <a:ln w="15875">
-            <a:solidFill>
-              <a:srgbClr val="EB6834"/>
-            </a:solidFill>
-          </a:ln>
-          <a:effectLst/>
-        </p:spPr>
-        <p:style>
-          <a:lnRef idx="1">
-            <a:schemeClr val="accent1"/>
-          </a:lnRef>
-          <a:fillRef idx="3">
-            <a:schemeClr val="accent1"/>
-          </a:fillRef>
-          <a:effectRef idx="2">
-            <a:schemeClr val="accent1"/>
-          </a:effectRef>
-          <a:fontRef idx="minor">
-            <a:schemeClr val="lt1"/>
-          </a:fontRef>
-        </p:style>
-        <p:txBody>
-          <a:bodyPr rtlCol="0" anchor="ctr" lIns="36576" rIns="36576"/>
-          <a:lstStyle/>
-          <a:p>
-            <a:pPr algn="ctr"/>
-            <a:r>
-              <a:rPr sz="1200">
-                <a:solidFill>
-                  <a:srgbClr val="1F2328"/>
-                </a:solidFill>
-                <a:latin typeface="Calibri"/>
-              </a:rPr>
-              <a:t>GraphRAG</a:t>
-            </a:r>
-          </a:p>
-        </p:txBody>
-      </p:sp>
-      <p:sp>
-        <p:nvSpPr>
-          <p:cNvPr id="9" name="TextBox 8"/>
-          <p:cNvSpPr txBox="1"/>
-          <p:nvPr/>
-        </p:nvSpPr>
-        <p:spPr>
-          <a:xfrm>
-            <a:off x="548640" y="2852928"/>
-            <a:ext cx="1554480" cy="457200"/>
-          </a:xfrm>
-          <a:prstGeom prst="rect">
-            <a:avLst/>
-          </a:prstGeom>
-          <a:noFill/>
-        </p:spPr>
-        <p:txBody>
-          <a:bodyPr wrap="square" lIns="0" rIns="0" tIns="0" bIns="0">
-            <a:spAutoFit/>
-          </a:bodyPr>
-          <a:lstStyle/>
-          <a:p>
             <a:pPr algn="l">
               <a:spcAft>
                 <a:spcPts val="600"/>
@@ -6396,14 +6300,14 @@
       </p:sp>
       <p:sp>
         <p:nvSpPr>
-          <p:cNvPr id="10" name="Rounded Rectangle 9"/>
+          <p:cNvPr id="8" name="Rounded Rectangle 7"/>
           <p:cNvSpPr/>
           <p:nvPr/>
         </p:nvSpPr>
         <p:spPr>
           <a:xfrm>
-            <a:off x="2148840" y="2743200"/>
-            <a:ext cx="988695" cy="658368"/>
+            <a:off x="1920240" y="2743200"/>
+            <a:ext cx="1170432" cy="658368"/>
           </a:xfrm>
           <a:prstGeom prst="roundRect">
             <a:avLst>
@@ -6435,32 +6339,32 @@
           </a:fontRef>
         </p:style>
         <p:txBody>
-          <a:bodyPr rtlCol="0" anchor="ctr" lIns="36576" rIns="36576"/>
+          <a:bodyPr rtlCol="0" anchor="ctr" lIns="18288" rIns="18288" wrap="none"/>
           <a:lstStyle/>
           <a:p>
             <a:pPr algn="ctr"/>
             <a:r>
-              <a:rPr sz="1200">
+              <a:rPr sz="1100">
                 <a:solidFill>
                   <a:srgbClr val="1F2328"/>
                 </a:solidFill>
                 <a:latin typeface="Calibri"/>
               </a:rPr>
-              <a:t>PDF</a:t>
-            </a:r>
-          </a:p>
-        </p:txBody>
-      </p:sp>
-      <p:sp>
-        <p:nvSpPr>
-          <p:cNvPr id="11" name="TextBox 10"/>
+              <a:t>MinerU</a:t>
+            </a:r>
+          </a:p>
+        </p:txBody>
+      </p:sp>
+      <p:sp>
+        <p:nvSpPr>
+          <p:cNvPr id="9" name="TextBox 8"/>
           <p:cNvSpPr txBox="1"/>
           <p:nvPr/>
         </p:nvSpPr>
         <p:spPr>
           <a:xfrm>
-            <a:off x="3137535" y="2871216"/>
-            <a:ext cx="228600" cy="365760"/>
+            <a:off x="3090672" y="2743200"/>
+            <a:ext cx="237744" cy="658368"/>
           </a:xfrm>
           <a:prstGeom prst="rect">
             <a:avLst/>
@@ -6468,7 +6372,7 @@
           <a:noFill/>
         </p:spPr>
         <p:txBody>
-          <a:bodyPr wrap="square" lIns="0" rIns="0" tIns="0" bIns="0">
+          <a:bodyPr wrap="square" lIns="0" rIns="0" tIns="0" bIns="0" anchor="ctr">
             <a:spAutoFit/>
           </a:bodyPr>
           <a:lstStyle/>
@@ -6479,7 +6383,7 @@
               </a:spcAft>
             </a:pPr>
             <a:r>
-              <a:rPr sz="1600" b="0">
+              <a:rPr sz="1400" b="0">
                 <a:solidFill>
                   <a:srgbClr val="5F5E5A"/>
                 </a:solidFill>
@@ -6492,14 +6396,14 @@
       </p:sp>
       <p:sp>
         <p:nvSpPr>
-          <p:cNvPr id="12" name="Rounded Rectangle 11"/>
+          <p:cNvPr id="10" name="Rounded Rectangle 9"/>
           <p:cNvSpPr/>
           <p:nvPr/>
         </p:nvSpPr>
         <p:spPr>
           <a:xfrm>
-            <a:off x="3366135" y="2743200"/>
-            <a:ext cx="988695" cy="658368"/>
+            <a:off x="3328416" y="2743200"/>
+            <a:ext cx="1170432" cy="658368"/>
           </a:xfrm>
           <a:prstGeom prst="roundRect">
             <a:avLst>
@@ -6531,32 +6435,32 @@
           </a:fontRef>
         </p:style>
         <p:txBody>
-          <a:bodyPr rtlCol="0" anchor="ctr" lIns="36576" rIns="36576"/>
+          <a:bodyPr rtlCol="0" anchor="ctr" lIns="18288" rIns="18288" wrap="none"/>
           <a:lstStyle/>
           <a:p>
             <a:pPr algn="ctr"/>
             <a:r>
-              <a:rPr sz="1200">
+              <a:rPr sz="1100">
                 <a:solidFill>
                   <a:srgbClr val="1F2328"/>
                 </a:solidFill>
                 <a:latin typeface="Calibri"/>
               </a:rPr>
-              <a:t>MinerU</a:t>
-            </a:r>
-          </a:p>
-        </p:txBody>
-      </p:sp>
-      <p:sp>
-        <p:nvSpPr>
-          <p:cNvPr id="13" name="TextBox 12"/>
+              <a:t>Chunking</a:t>
+            </a:r>
+          </a:p>
+        </p:txBody>
+      </p:sp>
+      <p:sp>
+        <p:nvSpPr>
+          <p:cNvPr id="11" name="TextBox 10"/>
           <p:cNvSpPr txBox="1"/>
           <p:nvPr/>
         </p:nvSpPr>
         <p:spPr>
           <a:xfrm>
-            <a:off x="4354830" y="2871216"/>
-            <a:ext cx="228600" cy="365760"/>
+            <a:off x="4498848" y="2743200"/>
+            <a:ext cx="237744" cy="658368"/>
           </a:xfrm>
           <a:prstGeom prst="rect">
             <a:avLst/>
@@ -6564,7 +6468,7 @@
           <a:noFill/>
         </p:spPr>
         <p:txBody>
-          <a:bodyPr wrap="square" lIns="0" rIns="0" tIns="0" bIns="0">
+          <a:bodyPr wrap="square" lIns="0" rIns="0" tIns="0" bIns="0" anchor="ctr">
             <a:spAutoFit/>
           </a:bodyPr>
           <a:lstStyle/>
@@ -6575,7 +6479,7 @@
               </a:spcAft>
             </a:pPr>
             <a:r>
-              <a:rPr sz="1600" b="0">
+              <a:rPr sz="1400" b="0">
                 <a:solidFill>
                   <a:srgbClr val="5F5E5A"/>
                 </a:solidFill>
@@ -6588,14 +6492,14 @@
       </p:sp>
       <p:sp>
         <p:nvSpPr>
-          <p:cNvPr id="14" name="Rounded Rectangle 13"/>
+          <p:cNvPr id="12" name="Rounded Rectangle 11"/>
           <p:cNvSpPr/>
           <p:nvPr/>
         </p:nvSpPr>
         <p:spPr>
           <a:xfrm>
-            <a:off x="4583430" y="2743200"/>
-            <a:ext cx="988695" cy="658368"/>
+            <a:off x="4736592" y="2743200"/>
+            <a:ext cx="1170432" cy="658368"/>
           </a:xfrm>
           <a:prstGeom prst="roundRect">
             <a:avLst>
@@ -6627,32 +6531,32 @@
           </a:fontRef>
         </p:style>
         <p:txBody>
-          <a:bodyPr rtlCol="0" anchor="ctr" lIns="36576" rIns="36576"/>
+          <a:bodyPr rtlCol="0" anchor="ctr" lIns="18288" rIns="18288" wrap="none"/>
           <a:lstStyle/>
           <a:p>
             <a:pPr algn="ctr"/>
             <a:r>
-              <a:rPr sz="1200">
+              <a:rPr sz="1100">
                 <a:solidFill>
                   <a:srgbClr val="1F2328"/>
                 </a:solidFill>
                 <a:latin typeface="Calibri"/>
               </a:rPr>
-              <a:t>Chunking</a:t>
-            </a:r>
-          </a:p>
-        </p:txBody>
-      </p:sp>
-      <p:sp>
-        <p:nvSpPr>
-          <p:cNvPr id="15" name="TextBox 14"/>
+              <a:t>Очистка</a:t>
+            </a:r>
+          </a:p>
+        </p:txBody>
+      </p:sp>
+      <p:sp>
+        <p:nvSpPr>
+          <p:cNvPr id="13" name="TextBox 12"/>
           <p:cNvSpPr txBox="1"/>
           <p:nvPr/>
         </p:nvSpPr>
         <p:spPr>
           <a:xfrm>
-            <a:off x="5572125" y="2871216"/>
-            <a:ext cx="228600" cy="365760"/>
+            <a:off x="5907024" y="2743200"/>
+            <a:ext cx="237744" cy="658368"/>
           </a:xfrm>
           <a:prstGeom prst="rect">
             <a:avLst/>
@@ -6660,7 +6564,7 @@
           <a:noFill/>
         </p:spPr>
         <p:txBody>
-          <a:bodyPr wrap="square" lIns="0" rIns="0" tIns="0" bIns="0">
+          <a:bodyPr wrap="square" lIns="0" rIns="0" tIns="0" bIns="0" anchor="ctr">
             <a:spAutoFit/>
           </a:bodyPr>
           <a:lstStyle/>
@@ -6671,7 +6575,7 @@
               </a:spcAft>
             </a:pPr>
             <a:r>
-              <a:rPr sz="1600" b="0">
+              <a:rPr sz="1400" b="0">
                 <a:solidFill>
                   <a:srgbClr val="5F5E5A"/>
                 </a:solidFill>
@@ -6684,14 +6588,14 @@
       </p:sp>
       <p:sp>
         <p:nvSpPr>
-          <p:cNvPr id="16" name="Rounded Rectangle 15"/>
+          <p:cNvPr id="14" name="Rounded Rectangle 13"/>
           <p:cNvSpPr/>
           <p:nvPr/>
         </p:nvSpPr>
         <p:spPr>
           <a:xfrm>
-            <a:off x="5800725" y="2743200"/>
-            <a:ext cx="988695" cy="658368"/>
+            <a:off x="6144768" y="2743200"/>
+            <a:ext cx="1170432" cy="658368"/>
           </a:xfrm>
           <a:prstGeom prst="roundRect">
             <a:avLst>
@@ -6723,32 +6627,32 @@
           </a:fontRef>
         </p:style>
         <p:txBody>
-          <a:bodyPr rtlCol="0" anchor="ctr" lIns="36576" rIns="36576"/>
+          <a:bodyPr rtlCol="0" anchor="ctr" lIns="18288" rIns="18288" wrap="none"/>
           <a:lstStyle/>
           <a:p>
             <a:pPr algn="ctr"/>
             <a:r>
-              <a:rPr sz="1200">
+              <a:rPr sz="1100">
                 <a:solidFill>
                   <a:srgbClr val="1F2328"/>
                 </a:solidFill>
                 <a:latin typeface="Calibri"/>
               </a:rPr>
-              <a:t>Очистка</a:t>
-            </a:r>
-          </a:p>
-        </p:txBody>
-      </p:sp>
-      <p:sp>
-        <p:nvSpPr>
-          <p:cNvPr id="17" name="TextBox 16"/>
+              <a:t>Нормализация</a:t>
+            </a:r>
+          </a:p>
+        </p:txBody>
+      </p:sp>
+      <p:sp>
+        <p:nvSpPr>
+          <p:cNvPr id="15" name="TextBox 14"/>
           <p:cNvSpPr txBox="1"/>
           <p:nvPr/>
         </p:nvSpPr>
         <p:spPr>
           <a:xfrm>
-            <a:off x="6789420" y="2871216"/>
-            <a:ext cx="228600" cy="365760"/>
+            <a:off x="7315200" y="2743200"/>
+            <a:ext cx="237744" cy="658368"/>
           </a:xfrm>
           <a:prstGeom prst="rect">
             <a:avLst/>
@@ -6756,7 +6660,7 @@
           <a:noFill/>
         </p:spPr>
         <p:txBody>
-          <a:bodyPr wrap="square" lIns="0" rIns="0" tIns="0" bIns="0">
+          <a:bodyPr wrap="square" lIns="0" rIns="0" tIns="0" bIns="0" anchor="ctr">
             <a:spAutoFit/>
           </a:bodyPr>
           <a:lstStyle/>
@@ -6767,7 +6671,7 @@
               </a:spcAft>
             </a:pPr>
             <a:r>
-              <a:rPr sz="1600" b="0">
+              <a:rPr sz="1400" b="0">
                 <a:solidFill>
                   <a:srgbClr val="5F5E5A"/>
                 </a:solidFill>
@@ -6780,14 +6684,14 @@
       </p:sp>
       <p:sp>
         <p:nvSpPr>
-          <p:cNvPr id="18" name="Rounded Rectangle 17"/>
+          <p:cNvPr id="16" name="Rounded Rectangle 15"/>
           <p:cNvSpPr/>
           <p:nvPr/>
         </p:nvSpPr>
         <p:spPr>
           <a:xfrm>
-            <a:off x="7018020" y="2743200"/>
-            <a:ext cx="988695" cy="658368"/>
+            <a:off x="7552944" y="2743200"/>
+            <a:ext cx="1170432" cy="658368"/>
           </a:xfrm>
           <a:prstGeom prst="roundRect">
             <a:avLst>
@@ -6819,33 +6723,32 @@
           </a:fontRef>
         </p:style>
         <p:txBody>
-          <a:bodyPr rtlCol="0" anchor="ctr" lIns="36576" rIns="36576"/>
+          <a:bodyPr rtlCol="0" anchor="ctr" lIns="18288" rIns="18288" wrap="none"/>
           <a:lstStyle/>
           <a:p>
             <a:pPr algn="ctr"/>
             <a:r>
-              <a:rPr sz="1200">
+              <a:rPr sz="1100">
                 <a:solidFill>
                   <a:srgbClr val="1F2328"/>
                 </a:solidFill>
                 <a:latin typeface="Calibri"/>
               </a:rPr>
-              <a:t>Нормали-
-зация</a:t>
-            </a:r>
-          </a:p>
-        </p:txBody>
-      </p:sp>
-      <p:sp>
-        <p:nvSpPr>
-          <p:cNvPr id="19" name="TextBox 18"/>
+              <a:t>Токенизация</a:t>
+            </a:r>
+          </a:p>
+        </p:txBody>
+      </p:sp>
+      <p:sp>
+        <p:nvSpPr>
+          <p:cNvPr id="17" name="TextBox 16"/>
           <p:cNvSpPr txBox="1"/>
           <p:nvPr/>
         </p:nvSpPr>
         <p:spPr>
           <a:xfrm>
-            <a:off x="8006715" y="2871216"/>
-            <a:ext cx="228600" cy="365760"/>
+            <a:off x="8723376" y="2743200"/>
+            <a:ext cx="237744" cy="658368"/>
           </a:xfrm>
           <a:prstGeom prst="rect">
             <a:avLst/>
@@ -6853,7 +6756,7 @@
           <a:noFill/>
         </p:spPr>
         <p:txBody>
-          <a:bodyPr wrap="square" lIns="0" rIns="0" tIns="0" bIns="0">
+          <a:bodyPr wrap="square" lIns="0" rIns="0" tIns="0" bIns="0" anchor="ctr">
             <a:spAutoFit/>
           </a:bodyPr>
           <a:lstStyle/>
@@ -6864,7 +6767,7 @@
               </a:spcAft>
             </a:pPr>
             <a:r>
-              <a:rPr sz="1600" b="0">
+              <a:rPr sz="1400" b="0">
                 <a:solidFill>
                   <a:srgbClr val="5F5E5A"/>
                 </a:solidFill>
@@ -6877,14 +6780,14 @@
       </p:sp>
       <p:sp>
         <p:nvSpPr>
-          <p:cNvPr id="20" name="Rounded Rectangle 19"/>
+          <p:cNvPr id="18" name="Rounded Rectangle 17"/>
           <p:cNvSpPr/>
           <p:nvPr/>
         </p:nvSpPr>
         <p:spPr>
           <a:xfrm>
-            <a:off x="8235315" y="2743200"/>
-            <a:ext cx="988695" cy="658368"/>
+            <a:off x="8961120" y="2743200"/>
+            <a:ext cx="1170432" cy="658368"/>
           </a:xfrm>
           <a:prstGeom prst="roundRect">
             <a:avLst>
@@ -6916,33 +6819,32 @@
           </a:fontRef>
         </p:style>
         <p:txBody>
-          <a:bodyPr rtlCol="0" anchor="ctr" lIns="36576" rIns="36576"/>
+          <a:bodyPr rtlCol="0" anchor="ctr" lIns="18288" rIns="18288" wrap="none"/>
           <a:lstStyle/>
           <a:p>
             <a:pPr algn="ctr"/>
             <a:r>
-              <a:rPr sz="1200">
+              <a:rPr sz="1100">
                 <a:solidFill>
                   <a:srgbClr val="1F2328"/>
                 </a:solidFill>
                 <a:latin typeface="Calibri"/>
               </a:rPr>
-              <a:t>Токени-
-зация</a:t>
-            </a:r>
-          </a:p>
-        </p:txBody>
-      </p:sp>
-      <p:sp>
-        <p:nvSpPr>
-          <p:cNvPr id="21" name="TextBox 20"/>
+              <a:t>Векторизация</a:t>
+            </a:r>
+          </a:p>
+        </p:txBody>
+      </p:sp>
+      <p:sp>
+        <p:nvSpPr>
+          <p:cNvPr id="19" name="TextBox 18"/>
           <p:cNvSpPr txBox="1"/>
           <p:nvPr/>
         </p:nvSpPr>
         <p:spPr>
           <a:xfrm>
-            <a:off x="9224010" y="2871216"/>
-            <a:ext cx="228600" cy="365760"/>
+            <a:off x="10131552" y="2743200"/>
+            <a:ext cx="237744" cy="658368"/>
           </a:xfrm>
           <a:prstGeom prst="rect">
             <a:avLst/>
@@ -6950,7 +6852,7 @@
           <a:noFill/>
         </p:spPr>
         <p:txBody>
-          <a:bodyPr wrap="square" lIns="0" rIns="0" tIns="0" bIns="0">
+          <a:bodyPr wrap="square" lIns="0" rIns="0" tIns="0" bIns="0" anchor="ctr">
             <a:spAutoFit/>
           </a:bodyPr>
           <a:lstStyle/>
@@ -6961,7 +6863,7 @@
               </a:spcAft>
             </a:pPr>
             <a:r>
-              <a:rPr sz="1600" b="0">
+              <a:rPr sz="1400" b="0">
                 <a:solidFill>
                   <a:srgbClr val="5F5E5A"/>
                 </a:solidFill>
@@ -6974,14 +6876,14 @@
       </p:sp>
       <p:sp>
         <p:nvSpPr>
-          <p:cNvPr id="22" name="Rounded Rectangle 21"/>
+          <p:cNvPr id="20" name="Rounded Rectangle 19"/>
           <p:cNvSpPr/>
           <p:nvPr/>
         </p:nvSpPr>
         <p:spPr>
           <a:xfrm>
-            <a:off x="9452610" y="2743200"/>
-            <a:ext cx="988695" cy="658368"/>
+            <a:off x="10369296" y="2743200"/>
+            <a:ext cx="1170432" cy="658368"/>
           </a:xfrm>
           <a:prstGeom prst="roundRect">
             <a:avLst>
@@ -7013,109 +6915,12 @@
           </a:fontRef>
         </p:style>
         <p:txBody>
-          <a:bodyPr rtlCol="0" anchor="ctr" lIns="36576" rIns="36576"/>
+          <a:bodyPr rtlCol="0" anchor="ctr" lIns="18288" rIns="18288" wrap="none"/>
           <a:lstStyle/>
           <a:p>
             <a:pPr algn="ctr"/>
             <a:r>
-              <a:rPr sz="1200">
-                <a:solidFill>
-                  <a:srgbClr val="1F2328"/>
-                </a:solidFill>
-                <a:latin typeface="Calibri"/>
-              </a:rPr>
-              <a:t>Вектори-
-зация</a:t>
-            </a:r>
-          </a:p>
-        </p:txBody>
-      </p:sp>
-      <p:sp>
-        <p:nvSpPr>
-          <p:cNvPr id="23" name="TextBox 22"/>
-          <p:cNvSpPr txBox="1"/>
-          <p:nvPr/>
-        </p:nvSpPr>
-        <p:spPr>
-          <a:xfrm>
-            <a:off x="10441305" y="2871216"/>
-            <a:ext cx="228600" cy="365760"/>
-          </a:xfrm>
-          <a:prstGeom prst="rect">
-            <a:avLst/>
-          </a:prstGeom>
-          <a:noFill/>
-        </p:spPr>
-        <p:txBody>
-          <a:bodyPr wrap="square" lIns="0" rIns="0" tIns="0" bIns="0">
-            <a:spAutoFit/>
-          </a:bodyPr>
-          <a:lstStyle/>
-          <a:p>
-            <a:pPr algn="ctr">
-              <a:spcAft>
-                <a:spcPts val="600"/>
-              </a:spcAft>
-            </a:pPr>
-            <a:r>
-              <a:rPr sz="1600" b="0">
-                <a:solidFill>
-                  <a:srgbClr val="5F5E5A"/>
-                </a:solidFill>
-                <a:latin typeface="Calibri"/>
-              </a:rPr>
-              <a:t>→</a:t>
-            </a:r>
-          </a:p>
-        </p:txBody>
-      </p:sp>
-      <p:sp>
-        <p:nvSpPr>
-          <p:cNvPr id="24" name="Rounded Rectangle 23"/>
-          <p:cNvSpPr/>
-          <p:nvPr/>
-        </p:nvSpPr>
-        <p:spPr>
-          <a:xfrm>
-            <a:off x="10669905" y="2743200"/>
-            <a:ext cx="988695" cy="658368"/>
-          </a:xfrm>
-          <a:prstGeom prst="roundRect">
-            <a:avLst>
-              <a:gd name="adj" fmla="val 15000"/>
-            </a:avLst>
-          </a:prstGeom>
-          <a:solidFill>
-            <a:srgbClr val="F1F4F8"/>
-          </a:solidFill>
-          <a:ln w="15875">
-            <a:solidFill>
-              <a:srgbClr val="2A78D6"/>
-            </a:solidFill>
-          </a:ln>
-          <a:effectLst/>
-        </p:spPr>
-        <p:style>
-          <a:lnRef idx="1">
-            <a:schemeClr val="accent1"/>
-          </a:lnRef>
-          <a:fillRef idx="3">
-            <a:schemeClr val="accent1"/>
-          </a:fillRef>
-          <a:effectRef idx="2">
-            <a:schemeClr val="accent1"/>
-          </a:effectRef>
-          <a:fontRef idx="minor">
-            <a:schemeClr val="lt1"/>
-          </a:fontRef>
-        </p:style>
-        <p:txBody>
-          <a:bodyPr rtlCol="0" anchor="ctr" lIns="36576" rIns="36576"/>
-          <a:lstStyle/>
-          <a:p>
-            <a:pPr algn="ctr"/>
-            <a:r>
-              <a:rPr sz="1200">
+              <a:rPr sz="1100">
                 <a:solidFill>
                   <a:srgbClr val="1F2328"/>
                 </a:solidFill>
@@ -7128,7 +6933,7 @@
       </p:sp>
       <p:sp>
         <p:nvSpPr>
-          <p:cNvPr id="25" name="TextBox 24"/>
+          <p:cNvPr id="21" name="TextBox 20"/>
           <p:cNvSpPr txBox="1"/>
           <p:nvPr/>
         </p:nvSpPr>
@@ -7160,7 +6965,7 @@
                 </a:solidFill>
                 <a:latin typeface="Calibri"/>
               </a:rPr>
-              <a:t>Одинаковые: модели, промпты, типы сущностей, размер чанка 1200 токенов, кластеризация.</a:t>
+              <a:t>Общий вход: PDF → MinerU → markdown. Одинаковые модели, промпты, типы сущностей, чанк 1200 токенов.</a:t>
             </a:r>
           </a:p>
           <a:p>
@@ -7585,6 +7390,107 @@
           </a:p>
         </p:txBody>
       </p:sp>
+      <p:sp>
+        <p:nvSpPr>
+          <p:cNvPr id="11" name="Rounded Rectangle 10"/>
+          <p:cNvSpPr/>
+          <p:nvPr/>
+        </p:nvSpPr>
+        <p:spPr>
+          <a:xfrm>
+            <a:off x="548640" y="5623560"/>
+            <a:ext cx="11064240" cy="859536"/>
+          </a:xfrm>
+          <a:prstGeom prst="roundRect">
+            <a:avLst>
+              <a:gd name="adj" fmla="val 8000"/>
+            </a:avLst>
+          </a:prstGeom>
+          <a:solidFill>
+            <a:srgbClr val="F4F4F2"/>
+          </a:solidFill>
+          <a:ln>
+            <a:noFill/>
+          </a:ln>
+          <a:effectLst/>
+        </p:spPr>
+        <p:style>
+          <a:lnRef idx="1">
+            <a:schemeClr val="accent1"/>
+          </a:lnRef>
+          <a:fillRef idx="3">
+            <a:schemeClr val="accent1"/>
+          </a:fillRef>
+          <a:effectRef idx="2">
+            <a:schemeClr val="accent1"/>
+          </a:effectRef>
+          <a:fontRef idx="minor">
+            <a:schemeClr val="lt1"/>
+          </a:fontRef>
+        </p:style>
+        <p:txBody>
+          <a:bodyPr rtlCol="0" anchor="ctr"/>
+          <a:lstStyle/>
+          <a:p>
+            <a:pPr algn="ctr"/>
+          </a:p>
+        </p:txBody>
+      </p:sp>
+      <p:sp>
+        <p:nvSpPr>
+          <p:cNvPr id="12" name="TextBox 11"/>
+          <p:cNvSpPr txBox="1"/>
+          <p:nvPr/>
+        </p:nvSpPr>
+        <p:spPr>
+          <a:xfrm>
+            <a:off x="777240" y="5760720"/>
+            <a:ext cx="10698480" cy="676656"/>
+          </a:xfrm>
+          <a:prstGeom prst="rect">
+            <a:avLst/>
+          </a:prstGeom>
+          <a:noFill/>
+        </p:spPr>
+        <p:txBody>
+          <a:bodyPr wrap="square" lIns="0" rIns="0" tIns="0" bIns="0">
+            <a:spAutoFit/>
+          </a:bodyPr>
+          <a:lstStyle/>
+          <a:p>
+            <a:pPr algn="l">
+              <a:spcAft>
+                <a:spcPts val="200"/>
+              </a:spcAft>
+            </a:pPr>
+            <a:r>
+              <a:rPr sz="1200" b="0">
+                <a:solidFill>
+                  <a:srgbClr val="1F2328"/>
+                </a:solidFill>
+                <a:latin typeface="Consolas"/>
+              </a:rPr>
+              <a:t>blocks = parse_blocks(markdown)  →  разделы по заголовкам, формулы $$…$$ и &lt;table&gt; — неделимые блоки</a:t>
+            </a:r>
+          </a:p>
+          <a:p>
+            <a:pPr algn="l">
+              <a:spcAft>
+                <a:spcPts val="200"/>
+              </a:spcAft>
+            </a:pPr>
+            <a:r>
+              <a:rPr sz="1200" b="0">
+                <a:solidFill>
+                  <a:srgbClr val="1F2328"/>
+                </a:solidFill>
+                <a:latin typeface="Consolas"/>
+              </a:rPr>
+              <a:t>cut = последняя граница, где tokens(left) ≤ 900 и ends_sentence(left) and not starts_lowercase(right)</a:t>
+            </a:r>
+          </a:p>
+        </p:txBody>
+      </p:sp>
     </p:spTree>
   </p:cSld>
   <p:clrMapOvr>
@@ -8062,7 +7968,7 @@
         <p:spPr>
           <a:xfrm>
             <a:off x="548640" y="3337560"/>
-            <a:ext cx="11064240" cy="2651760"/>
+            <a:ext cx="11064240" cy="2148840"/>
           </a:xfrm>
           <a:prstGeom prst="roundRect">
             <a:avLst>
@@ -8147,7 +8053,7 @@
         <p:spPr>
           <a:xfrm>
             <a:off x="822960" y="3977639"/>
-            <a:ext cx="10515600" cy="1920240"/>
+            <a:ext cx="10515600" cy="1463040"/>
           </a:xfrm>
           <a:prstGeom prst="rect">
             <a:avLst/>
@@ -8221,6 +8127,107 @@
                 <a:latin typeface="Consolas"/>
               </a:rPr>
               <a:t>PII (авторы, аффилиации): 127 → 0;  числа, формулы, ячейки таблиц: 100% / 100% / 100% сохранено</a:t>
+            </a:r>
+          </a:p>
+        </p:txBody>
+      </p:sp>
+      <p:sp>
+        <p:nvSpPr>
+          <p:cNvPr id="15" name="Rounded Rectangle 14"/>
+          <p:cNvSpPr/>
+          <p:nvPr/>
+        </p:nvSpPr>
+        <p:spPr>
+          <a:xfrm>
+            <a:off x="548640" y="5623560"/>
+            <a:ext cx="11064240" cy="859536"/>
+          </a:xfrm>
+          <a:prstGeom prst="roundRect">
+            <a:avLst>
+              <a:gd name="adj" fmla="val 8000"/>
+            </a:avLst>
+          </a:prstGeom>
+          <a:solidFill>
+            <a:srgbClr val="F4F4F2"/>
+          </a:solidFill>
+          <a:ln>
+            <a:noFill/>
+          </a:ln>
+          <a:effectLst/>
+        </p:spPr>
+        <p:style>
+          <a:lnRef idx="1">
+            <a:schemeClr val="accent1"/>
+          </a:lnRef>
+          <a:fillRef idx="3">
+            <a:schemeClr val="accent1"/>
+          </a:fillRef>
+          <a:effectRef idx="2">
+            <a:schemeClr val="accent1"/>
+          </a:effectRef>
+          <a:fontRef idx="minor">
+            <a:schemeClr val="lt1"/>
+          </a:fontRef>
+        </p:style>
+        <p:txBody>
+          <a:bodyPr rtlCol="0" anchor="ctr"/>
+          <a:lstStyle/>
+          <a:p>
+            <a:pPr algn="ctr"/>
+          </a:p>
+        </p:txBody>
+      </p:sp>
+      <p:sp>
+        <p:nvSpPr>
+          <p:cNvPr id="16" name="TextBox 15"/>
+          <p:cNvSpPr txBox="1"/>
+          <p:nvPr/>
+        </p:nvSpPr>
+        <p:spPr>
+          <a:xfrm>
+            <a:off x="777240" y="5760720"/>
+            <a:ext cx="10698480" cy="676656"/>
+          </a:xfrm>
+          <a:prstGeom prst="rect">
+            <a:avLst/>
+          </a:prstGeom>
+          <a:noFill/>
+        </p:spPr>
+        <p:txBody>
+          <a:bodyPr wrap="square" lIns="0" rIns="0" tIns="0" bIns="0">
+            <a:spAutoFit/>
+          </a:bodyPr>
+          <a:lstStyle/>
+          <a:p>
+            <a:pPr algn="l">
+              <a:spcAft>
+                <a:spcPts val="200"/>
+              </a:spcAft>
+            </a:pPr>
+            <a:r>
+              <a:rPr sz="1200" b="0">
+                <a:solidFill>
+                  <a:srgbClr val="1F2328"/>
+                </a:solidFill>
+                <a:latin typeface="Consolas"/>
+              </a:rPr>
+              <a:t>re.sub(r"&lt;/?(?:strong|u|b|i|em)&gt;", "", text);   re.sub(r"\s*\$\^\{[\d,\s–-]+\}\$", "", text)</a:t>
+            </a:r>
+          </a:p>
+          <a:p>
+            <a:pPr algn="l">
+              <a:spcAft>
+                <a:spcPts val="200"/>
+              </a:spcAft>
+            </a:pPr>
+            <a:r>
+              <a:rPr sz="1200" b="0">
+                <a:solidFill>
+                  <a:srgbClr val="1F2328"/>
+                </a:solidFill>
+                <a:latin typeface="Consolas"/>
+              </a:rPr>
+              <a:t>re.sub(r"([^\W\d_]+)-\s+([а-яё]+)", r"\1\2", text);   блоки = колонтитулы ∪ r"^\d{1,3}$" → удалить</a:t>
             </a:r>
           </a:p>
         </p:txBody>
@@ -8793,6 +8800,107 @@
                 <a:latin typeface="Calibri"/>
               </a:rPr>
               <a:t>Английский в скобках после русского модель игнорирует — проверено на промпте GraphRAG.</a:t>
+            </a:r>
+          </a:p>
+        </p:txBody>
+      </p:sp>
+      <p:sp>
+        <p:nvSpPr>
+          <p:cNvPr id="15" name="Rounded Rectangle 14"/>
+          <p:cNvSpPr/>
+          <p:nvPr/>
+        </p:nvSpPr>
+        <p:spPr>
+          <a:xfrm>
+            <a:off x="548640" y="5577840"/>
+            <a:ext cx="11064240" cy="859536"/>
+          </a:xfrm>
+          <a:prstGeom prst="roundRect">
+            <a:avLst>
+              <a:gd name="adj" fmla="val 8000"/>
+            </a:avLst>
+          </a:prstGeom>
+          <a:solidFill>
+            <a:srgbClr val="F4F4F2"/>
+          </a:solidFill>
+          <a:ln>
+            <a:noFill/>
+          </a:ln>
+          <a:effectLst/>
+        </p:spPr>
+        <p:style>
+          <a:lnRef idx="1">
+            <a:schemeClr val="accent1"/>
+          </a:lnRef>
+          <a:fillRef idx="3">
+            <a:schemeClr val="accent1"/>
+          </a:fillRef>
+          <a:effectRef idx="2">
+            <a:schemeClr val="accent1"/>
+          </a:effectRef>
+          <a:fontRef idx="minor">
+            <a:schemeClr val="lt1"/>
+          </a:fontRef>
+        </p:style>
+        <p:txBody>
+          <a:bodyPr rtlCol="0" anchor="ctr"/>
+          <a:lstStyle/>
+          <a:p>
+            <a:pPr algn="ctr"/>
+          </a:p>
+        </p:txBody>
+      </p:sp>
+      <p:sp>
+        <p:nvSpPr>
+          <p:cNvPr id="16" name="TextBox 15"/>
+          <p:cNvSpPr txBox="1"/>
+          <p:nvPr/>
+        </p:nvSpPr>
+        <p:spPr>
+          <a:xfrm>
+            <a:off x="777240" y="5715000"/>
+            <a:ext cx="10698480" cy="676656"/>
+          </a:xfrm>
+          <a:prstGeom prst="rect">
+            <a:avLst/>
+          </a:prstGeom>
+          <a:noFill/>
+        </p:spPr>
+        <p:txBody>
+          <a:bodyPr wrap="square" lIns="0" rIns="0" tIns="0" bIns="0">
+            <a:spAutoFit/>
+          </a:bodyPr>
+          <a:lstStyle/>
+          <a:p>
+            <a:pPr algn="l">
+              <a:spcAft>
+                <a:spcPts val="200"/>
+              </a:spcAft>
+            </a:pPr>
+            <a:r>
+              <a:rPr sz="1200" b="0">
+                <a:solidFill>
+                  <a:srgbClr val="1F2328"/>
+                </a:solidFill>
+                <a:latin typeface="Consolas"/>
+              </a:rPr>
+              <a:t>re.sub(r"&lt;sup&gt;\s*[0o°]\s*&lt;/sup&gt;\s*[СC]", " °C", text)</a:t>
+            </a:r>
+          </a:p>
+          <a:p>
+            <a:pPr algn="l">
+              <a:spcAft>
+                <a:spcPts val="200"/>
+              </a:spcAft>
+            </a:pPr>
+            <a:r>
+              <a:rPr sz="1200" b="0">
+                <a:solidFill>
+                  <a:srgbClr val="1F2328"/>
+                </a:solidFill>
+                <a:latin typeface="Consolas"/>
+              </a:rPr>
+              <a:t>re.sub(r"\bконтролируем\w* прокатк\w*", lambda m: f"controlled rolling ({m[0]})", text, count=1)   ← glossary.yaml</a:t>
             </a:r>
           </a:p>
         </p:txBody>
@@ -9516,6 +9624,107 @@
                 <a:latin typeface="Calibri"/>
               </a:rPr>
               <a:t>около 40% роста межъязыкового сходства дают вставленные английские термины.</a:t>
+            </a:r>
+          </a:p>
+        </p:txBody>
+      </p:sp>
+      <p:sp>
+        <p:nvSpPr>
+          <p:cNvPr id="5" name="Rounded Rectangle 4"/>
+          <p:cNvSpPr/>
+          <p:nvPr/>
+        </p:nvSpPr>
+        <p:spPr>
+          <a:xfrm>
+            <a:off x="548640" y="5486400"/>
+            <a:ext cx="11064240" cy="859536"/>
+          </a:xfrm>
+          <a:prstGeom prst="roundRect">
+            <a:avLst>
+              <a:gd name="adj" fmla="val 8000"/>
+            </a:avLst>
+          </a:prstGeom>
+          <a:solidFill>
+            <a:srgbClr val="F4F4F2"/>
+          </a:solidFill>
+          <a:ln>
+            <a:noFill/>
+          </a:ln>
+          <a:effectLst/>
+        </p:spPr>
+        <p:style>
+          <a:lnRef idx="1">
+            <a:schemeClr val="accent1"/>
+          </a:lnRef>
+          <a:fillRef idx="3">
+            <a:schemeClr val="accent1"/>
+          </a:fillRef>
+          <a:effectRef idx="2">
+            <a:schemeClr val="accent1"/>
+          </a:effectRef>
+          <a:fontRef idx="minor">
+            <a:schemeClr val="lt1"/>
+          </a:fontRef>
+        </p:style>
+        <p:txBody>
+          <a:bodyPr rtlCol="0" anchor="ctr"/>
+          <a:lstStyle/>
+          <a:p>
+            <a:pPr algn="ctr"/>
+          </a:p>
+        </p:txBody>
+      </p:sp>
+      <p:sp>
+        <p:nvSpPr>
+          <p:cNvPr id="6" name="TextBox 5"/>
+          <p:cNvSpPr txBox="1"/>
+          <p:nvPr/>
+        </p:nvSpPr>
+        <p:spPr>
+          <a:xfrm>
+            <a:off x="777240" y="5623560"/>
+            <a:ext cx="10698480" cy="676656"/>
+          </a:xfrm>
+          <a:prstGeom prst="rect">
+            <a:avLst/>
+          </a:prstGeom>
+          <a:noFill/>
+        </p:spPr>
+        <p:txBody>
+          <a:bodyPr wrap="square" lIns="0" rIns="0" tIns="0" bIns="0">
+            <a:spAutoFit/>
+          </a:bodyPr>
+          <a:lstStyle/>
+          <a:p>
+            <a:pPr algn="l">
+              <a:spcAft>
+                <a:spcPts val="200"/>
+              </a:spcAft>
+            </a:pPr>
+            <a:r>
+              <a:rPr sz="1200" b="0">
+                <a:solidFill>
+                  <a:srgbClr val="1F2328"/>
+                </a:solidFill>
+                <a:latin typeface="Consolas"/>
+              </a:rPr>
+              <a:t>oov = [w for w in re.findall(r"[^\W\d_]+", text) if zipf_frequency(w, lang) == 0 and w not in glossary]</a:t>
+            </a:r>
+          </a:p>
+          <a:p>
+            <a:pPr algn="l">
+              <a:spcAft>
+                <a:spcPts val="200"/>
+              </a:spcAft>
+            </a:pPr>
+            <a:r>
+              <a:rPr sz="1200" b="0">
+                <a:solidFill>
+                  <a:srgbClr val="1F2328"/>
+                </a:solidFill>
+                <a:latin typeface="Consolas"/>
+              </a:rPr>
+              <a:t>SentenceTransformer("BAAI/bge-m3").encode(chunks);   TfidfVectorizer().fit_transform(windows_300)</a:t>
             </a:r>
           </a:p>
         </p:txBody>

</xml_diff>

<commit_message>
Put a faded clean-graph background and smaller text on the lab-2 conclusions slide
Co-Authored-By: Claude Opus 5.5 <noreply@anthropic.com>
</commit_message>
<xml_diff>
--- a/1-graph/lab-2/results/presentation.pptx
+++ b/1-graph/lab-2/results/presentation.pptx
@@ -5852,6 +5852,30 @@
         <p:nvPr/>
       </p:nvGrpSpPr>
       <p:grpSpPr/>
+      <p:pic>
+        <p:nvPicPr>
+          <p:cNvPr id="3" name="Picture 2" descr="clean_graph_background.png"/>
+          <p:cNvPicPr>
+            <a:picLocks noChangeAspect="1"/>
+          </p:cNvPicPr>
+          <p:nvPr/>
+        </p:nvPicPr>
+        <p:blipFill>
+          <a:blip r:embed="rId3"/>
+          <a:stretch>
+            <a:fillRect/>
+          </a:stretch>
+        </p:blipFill>
+        <p:spPr>
+          <a:xfrm>
+            <a:off x="0" y="0"/>
+            <a:ext cx="12191695" cy="6858000"/>
+          </a:xfrm>
+          <a:prstGeom prst="rect">
+            <a:avLst/>
+          </a:prstGeom>
+        </p:spPr>
+      </p:pic>
       <p:sp>
         <p:nvSpPr>
           <p:cNvPr id="2" name="TextBox 1"/>
@@ -5893,7 +5917,7 @@
       </p:sp>
       <p:sp>
         <p:nvSpPr>
-          <p:cNvPr id="3" name="TextBox 2"/>
+          <p:cNvPr id="4" name="TextBox 3"/>
           <p:cNvSpPr txBox="1"/>
           <p:nvPr/>
         </p:nvSpPr>
@@ -5915,11 +5939,11 @@
           <a:p>
             <a:pPr algn="l">
               <a:spcAft>
-                <a:spcPts val="1600"/>
+                <a:spcPts val="1200"/>
               </a:spcAft>
             </a:pPr>
             <a:r>
-              <a:rPr sz="2000" b="0">
+              <a:rPr sz="1600" b="0">
                 <a:solidFill>
                   <a:srgbClr val="1F2328"/>
                 </a:solidFill>
@@ -5931,11 +5955,11 @@
           <a:p>
             <a:pPr algn="l">
               <a:spcAft>
-                <a:spcPts val="1600"/>
+                <a:spcPts val="1200"/>
               </a:spcAft>
             </a:pPr>
             <a:r>
-              <a:rPr sz="2000" b="0">
+              <a:rPr sz="1600" b="0">
                 <a:solidFill>
                   <a:srgbClr val="1F2328"/>
                 </a:solidFill>
@@ -5947,11 +5971,11 @@
           <a:p>
             <a:pPr algn="l">
               <a:spcAft>
-                <a:spcPts val="1600"/>
+                <a:spcPts val="1200"/>
               </a:spcAft>
             </a:pPr>
             <a:r>
-              <a:rPr sz="2000" b="0">
+              <a:rPr sz="1600" b="0">
                 <a:solidFill>
                   <a:srgbClr val="1F2328"/>
                 </a:solidFill>
@@ -5963,11 +5987,11 @@
           <a:p>
             <a:pPr algn="l">
               <a:spcAft>
-                <a:spcPts val="1600"/>
+                <a:spcPts val="1200"/>
               </a:spcAft>
             </a:pPr>
             <a:r>
-              <a:rPr sz="2000" b="0">
+              <a:rPr sz="1600" b="0">
                 <a:solidFill>
                   <a:srgbClr val="1F2328"/>
                 </a:solidFill>
@@ -5979,11 +6003,11 @@
           <a:p>
             <a:pPr algn="l">
               <a:spcAft>
-                <a:spcPts val="1600"/>
+                <a:spcPts val="1200"/>
               </a:spcAft>
             </a:pPr>
             <a:r>
-              <a:rPr sz="2000" b="0">
+              <a:rPr sz="1600" b="0">
                 <a:solidFill>
                   <a:srgbClr val="1F2328"/>
                 </a:solidFill>
@@ -5995,11 +6019,11 @@
           <a:p>
             <a:pPr algn="l">
               <a:spcAft>
-                <a:spcPts val="1600"/>
+                <a:spcPts val="1200"/>
               </a:spcAft>
             </a:pPr>
             <a:r>
-              <a:rPr sz="2000" b="0">
+              <a:rPr sz="1600" b="0">
                 <a:solidFill>
                   <a:srgbClr val="1F2328"/>
                 </a:solidFill>

</xml_diff>

<commit_message>
Number the lab-2 slides and clarify the domain coverage label
Co-Authored-By: Claude Opus 5.5 <noreply@anthropic.com>
</commit_message>
<xml_diff>
--- a/1-graph/lab-2/results/presentation.pptx
+++ b/1-graph/lab-2/results/presentation.pptx
@@ -4871,6 +4871,45 @@
                 <a:latin typeface="Calibri"/>
               </a:rPr>
               <a:t>tanaka1981 (EN, 28 с.) + stat3 (RU, 10 с.) · MinerU → GraphRAG · gpt-4o-mini, bge-m3 · судья gpt-4.1</a:t>
+            </a:r>
+          </a:p>
+        </p:txBody>
+      </p:sp>
+      <p:sp>
+        <p:nvSpPr>
+          <p:cNvPr id="5" name="TextBox 4"/>
+          <p:cNvSpPr txBox="1"/>
+          <p:nvPr/>
+        </p:nvSpPr>
+        <p:spPr>
+          <a:xfrm>
+            <a:off x="10725912" y="6528816"/>
+            <a:ext cx="914400" cy="237744"/>
+          </a:xfrm>
+          <a:prstGeom prst="rect">
+            <a:avLst/>
+          </a:prstGeom>
+          <a:noFill/>
+        </p:spPr>
+        <p:txBody>
+          <a:bodyPr wrap="square" lIns="0" rIns="0" tIns="0" bIns="0">
+            <a:spAutoFit/>
+          </a:bodyPr>
+          <a:lstStyle/>
+          <a:p>
+            <a:pPr algn="r">
+              <a:spcAft>
+                <a:spcPts val="600"/>
+              </a:spcAft>
+            </a:pPr>
+            <a:r>
+              <a:rPr sz="1100" b="0">
+                <a:solidFill>
+                  <a:srgbClr val="5F5E5A"/>
+                </a:solidFill>
+                <a:latin typeface="Calibri"/>
+              </a:rPr>
+              <a:t>1 / 11</a:t>
             </a:r>
           </a:p>
         </p:txBody>
@@ -5834,6 +5873,45 @@
           </a:p>
         </p:txBody>
       </p:sp>
+      <p:sp>
+        <p:nvSpPr>
+          <p:cNvPr id="7" name="TextBox 6"/>
+          <p:cNvSpPr txBox="1"/>
+          <p:nvPr/>
+        </p:nvSpPr>
+        <p:spPr>
+          <a:xfrm>
+            <a:off x="10725912" y="6528816"/>
+            <a:ext cx="914400" cy="237744"/>
+          </a:xfrm>
+          <a:prstGeom prst="rect">
+            <a:avLst/>
+          </a:prstGeom>
+          <a:noFill/>
+        </p:spPr>
+        <p:txBody>
+          <a:bodyPr wrap="square" lIns="0" rIns="0" tIns="0" bIns="0">
+            <a:spAutoFit/>
+          </a:bodyPr>
+          <a:lstStyle/>
+          <a:p>
+            <a:pPr algn="r">
+              <a:spcAft>
+                <a:spcPts val="600"/>
+              </a:spcAft>
+            </a:pPr>
+            <a:r>
+              <a:rPr sz="1100" b="0">
+                <a:solidFill>
+                  <a:srgbClr val="5F5E5A"/>
+                </a:solidFill>
+                <a:latin typeface="Calibri"/>
+              </a:rPr>
+              <a:t>10 / 11</a:t>
+            </a:r>
+          </a:p>
+        </p:txBody>
+      </p:sp>
     </p:spTree>
   </p:cSld>
   <p:clrMapOvr>
@@ -6034,6 +6112,45 @@
           </a:p>
         </p:txBody>
       </p:sp>
+      <p:sp>
+        <p:nvSpPr>
+          <p:cNvPr id="5" name="TextBox 4"/>
+          <p:cNvSpPr txBox="1"/>
+          <p:nvPr/>
+        </p:nvSpPr>
+        <p:spPr>
+          <a:xfrm>
+            <a:off x="10725912" y="6528816"/>
+            <a:ext cx="914400" cy="237744"/>
+          </a:xfrm>
+          <a:prstGeom prst="rect">
+            <a:avLst/>
+          </a:prstGeom>
+          <a:noFill/>
+        </p:spPr>
+        <p:txBody>
+          <a:bodyPr wrap="square" lIns="0" rIns="0" tIns="0" bIns="0">
+            <a:spAutoFit/>
+          </a:bodyPr>
+          <a:lstStyle/>
+          <a:p>
+            <a:pPr algn="r">
+              <a:spcAft>
+                <a:spcPts val="600"/>
+              </a:spcAft>
+            </a:pPr>
+            <a:r>
+              <a:rPr sz="1100" b="0">
+                <a:solidFill>
+                  <a:srgbClr val="5F5E5A"/>
+                </a:solidFill>
+                <a:latin typeface="Calibri"/>
+              </a:rPr>
+              <a:t>11 / 11</a:t>
+            </a:r>
+          </a:p>
+        </p:txBody>
+      </p:sp>
     </p:spTree>
   </p:cSld>
   <p:clrMapOvr>
@@ -7026,6 +7143,45 @@
           </a:p>
         </p:txBody>
       </p:sp>
+      <p:sp>
+        <p:nvSpPr>
+          <p:cNvPr id="22" name="TextBox 21"/>
+          <p:cNvSpPr txBox="1"/>
+          <p:nvPr/>
+        </p:nvSpPr>
+        <p:spPr>
+          <a:xfrm>
+            <a:off x="10725912" y="6528816"/>
+            <a:ext cx="914400" cy="237744"/>
+          </a:xfrm>
+          <a:prstGeom prst="rect">
+            <a:avLst/>
+          </a:prstGeom>
+          <a:noFill/>
+        </p:spPr>
+        <p:txBody>
+          <a:bodyPr wrap="square" lIns="0" rIns="0" tIns="0" bIns="0">
+            <a:spAutoFit/>
+          </a:bodyPr>
+          <a:lstStyle/>
+          <a:p>
+            <a:pPr algn="r">
+              <a:spcAft>
+                <a:spcPts val="600"/>
+              </a:spcAft>
+            </a:pPr>
+            <a:r>
+              <a:rPr sz="1100" b="0">
+                <a:solidFill>
+                  <a:srgbClr val="5F5E5A"/>
+                </a:solidFill>
+                <a:latin typeface="Calibri"/>
+              </a:rPr>
+              <a:t>2 / 11</a:t>
+            </a:r>
+          </a:p>
+        </p:txBody>
+      </p:sp>
     </p:spTree>
   </p:cSld>
   <p:clrMapOvr>
@@ -7515,6 +7671,45 @@
           </a:p>
         </p:txBody>
       </p:sp>
+      <p:sp>
+        <p:nvSpPr>
+          <p:cNvPr id="13" name="TextBox 12"/>
+          <p:cNvSpPr txBox="1"/>
+          <p:nvPr/>
+        </p:nvSpPr>
+        <p:spPr>
+          <a:xfrm>
+            <a:off x="10725912" y="6528816"/>
+            <a:ext cx="914400" cy="237744"/>
+          </a:xfrm>
+          <a:prstGeom prst="rect">
+            <a:avLst/>
+          </a:prstGeom>
+          <a:noFill/>
+        </p:spPr>
+        <p:txBody>
+          <a:bodyPr wrap="square" lIns="0" rIns="0" tIns="0" bIns="0">
+            <a:spAutoFit/>
+          </a:bodyPr>
+          <a:lstStyle/>
+          <a:p>
+            <a:pPr algn="r">
+              <a:spcAft>
+                <a:spcPts val="600"/>
+              </a:spcAft>
+            </a:pPr>
+            <a:r>
+              <a:rPr sz="1100" b="0">
+                <a:solidFill>
+                  <a:srgbClr val="5F5E5A"/>
+                </a:solidFill>
+                <a:latin typeface="Calibri"/>
+              </a:rPr>
+              <a:t>3 / 11</a:t>
+            </a:r>
+          </a:p>
+        </p:txBody>
+      </p:sp>
     </p:spTree>
   </p:cSld>
   <p:clrMapOvr>
@@ -8256,6 +8451,45 @@
           </a:p>
         </p:txBody>
       </p:sp>
+      <p:sp>
+        <p:nvSpPr>
+          <p:cNvPr id="17" name="TextBox 16"/>
+          <p:cNvSpPr txBox="1"/>
+          <p:nvPr/>
+        </p:nvSpPr>
+        <p:spPr>
+          <a:xfrm>
+            <a:off x="10725912" y="6528816"/>
+            <a:ext cx="914400" cy="237744"/>
+          </a:xfrm>
+          <a:prstGeom prst="rect">
+            <a:avLst/>
+          </a:prstGeom>
+          <a:noFill/>
+        </p:spPr>
+        <p:txBody>
+          <a:bodyPr wrap="square" lIns="0" rIns="0" tIns="0" bIns="0">
+            <a:spAutoFit/>
+          </a:bodyPr>
+          <a:lstStyle/>
+          <a:p>
+            <a:pPr algn="r">
+              <a:spcAft>
+                <a:spcPts val="600"/>
+              </a:spcAft>
+            </a:pPr>
+            <a:r>
+              <a:rPr sz="1100" b="0">
+                <a:solidFill>
+                  <a:srgbClr val="5F5E5A"/>
+                </a:solidFill>
+                <a:latin typeface="Calibri"/>
+              </a:rPr>
+              <a:t>4 / 11</a:t>
+            </a:r>
+          </a:p>
+        </p:txBody>
+      </p:sp>
     </p:spTree>
   </p:cSld>
   <p:clrMapOvr>
@@ -8925,6 +9159,45 @@
                 <a:latin typeface="Consolas"/>
               </a:rPr>
               <a:t>re.sub(r"\bконтролируем\w* прокатк\w*", lambda m: f"controlled rolling ({m[0]})", text, count=1)   ← glossary.yaml</a:t>
+            </a:r>
+          </a:p>
+        </p:txBody>
+      </p:sp>
+      <p:sp>
+        <p:nvSpPr>
+          <p:cNvPr id="17" name="TextBox 16"/>
+          <p:cNvSpPr txBox="1"/>
+          <p:nvPr/>
+        </p:nvSpPr>
+        <p:spPr>
+          <a:xfrm>
+            <a:off x="10725912" y="6528816"/>
+            <a:ext cx="914400" cy="237744"/>
+          </a:xfrm>
+          <a:prstGeom prst="rect">
+            <a:avLst/>
+          </a:prstGeom>
+          <a:noFill/>
+        </p:spPr>
+        <p:txBody>
+          <a:bodyPr wrap="square" lIns="0" rIns="0" tIns="0" bIns="0">
+            <a:spAutoFit/>
+          </a:bodyPr>
+          <a:lstStyle/>
+          <a:p>
+            <a:pPr algn="r">
+              <a:spcAft>
+                <a:spcPts val="600"/>
+              </a:spcAft>
+            </a:pPr>
+            <a:r>
+              <a:rPr sz="1100" b="0">
+                <a:solidFill>
+                  <a:srgbClr val="5F5E5A"/>
+                </a:solidFill>
+                <a:latin typeface="Calibri"/>
+              </a:rPr>
+              <a:t>5 / 11</a:t>
             </a:r>
           </a:p>
         </p:txBody>
@@ -9753,6 +10026,45 @@
           </a:p>
         </p:txBody>
       </p:sp>
+      <p:sp>
+        <p:nvSpPr>
+          <p:cNvPr id="7" name="TextBox 6"/>
+          <p:cNvSpPr txBox="1"/>
+          <p:nvPr/>
+        </p:nvSpPr>
+        <p:spPr>
+          <a:xfrm>
+            <a:off x="10725912" y="6528816"/>
+            <a:ext cx="914400" cy="237744"/>
+          </a:xfrm>
+          <a:prstGeom prst="rect">
+            <a:avLst/>
+          </a:prstGeom>
+          <a:noFill/>
+        </p:spPr>
+        <p:txBody>
+          <a:bodyPr wrap="square" lIns="0" rIns="0" tIns="0" bIns="0">
+            <a:spAutoFit/>
+          </a:bodyPr>
+          <a:lstStyle/>
+          <a:p>
+            <a:pPr algn="r">
+              <a:spcAft>
+                <a:spcPts val="600"/>
+              </a:spcAft>
+            </a:pPr>
+            <a:r>
+              <a:rPr sz="1100" b="0">
+                <a:solidFill>
+                  <a:srgbClr val="5F5E5A"/>
+                </a:solidFill>
+                <a:latin typeface="Calibri"/>
+              </a:rPr>
+              <a:t>6 / 11</a:t>
+            </a:r>
+          </a:p>
+        </p:txBody>
+      </p:sp>
     </p:spTree>
   </p:cSld>
   <p:clrMapOvr>
@@ -9932,6 +10244,45 @@
                 <a:latin typeface="Calibri"/>
               </a:rPr>
               <a:t>рёбер EN–RU: 4, общих узлов: 18</a:t>
+            </a:r>
+          </a:p>
+        </p:txBody>
+      </p:sp>
+      <p:sp>
+        <p:nvSpPr>
+          <p:cNvPr id="7" name="TextBox 6"/>
+          <p:cNvSpPr txBox="1"/>
+          <p:nvPr/>
+        </p:nvSpPr>
+        <p:spPr>
+          <a:xfrm>
+            <a:off x="10725912" y="6528816"/>
+            <a:ext cx="914400" cy="237744"/>
+          </a:xfrm>
+          <a:prstGeom prst="rect">
+            <a:avLst/>
+          </a:prstGeom>
+          <a:noFill/>
+        </p:spPr>
+        <p:txBody>
+          <a:bodyPr wrap="square" lIns="0" rIns="0" tIns="0" bIns="0">
+            <a:spAutoFit/>
+          </a:bodyPr>
+          <a:lstStyle/>
+          <a:p>
+            <a:pPr algn="r">
+              <a:spcAft>
+                <a:spcPts val="600"/>
+              </a:spcAft>
+            </a:pPr>
+            <a:r>
+              <a:rPr sz="1100" b="0">
+                <a:solidFill>
+                  <a:srgbClr val="5F5E5A"/>
+                </a:solidFill>
+                <a:latin typeface="Calibri"/>
+              </a:rPr>
+              <a:t>7 / 11</a:t>
             </a:r>
           </a:p>
         </p:txBody>
@@ -10677,6 +11028,45 @@
           </a:graphicData>
         </a:graphic>
       </p:graphicFrame>
+      <p:sp>
+        <p:nvSpPr>
+          <p:cNvPr id="5" name="TextBox 4"/>
+          <p:cNvSpPr txBox="1"/>
+          <p:nvPr/>
+        </p:nvSpPr>
+        <p:spPr>
+          <a:xfrm>
+            <a:off x="10725912" y="6528816"/>
+            <a:ext cx="914400" cy="237744"/>
+          </a:xfrm>
+          <a:prstGeom prst="rect">
+            <a:avLst/>
+          </a:prstGeom>
+          <a:noFill/>
+        </p:spPr>
+        <p:txBody>
+          <a:bodyPr wrap="square" lIns="0" rIns="0" tIns="0" bIns="0">
+            <a:spAutoFit/>
+          </a:bodyPr>
+          <a:lstStyle/>
+          <a:p>
+            <a:pPr algn="r">
+              <a:spcAft>
+                <a:spcPts val="600"/>
+              </a:spcAft>
+            </a:pPr>
+            <a:r>
+              <a:rPr sz="1100" b="0">
+                <a:solidFill>
+                  <a:srgbClr val="5F5E5A"/>
+                </a:solidFill>
+                <a:latin typeface="Calibri"/>
+              </a:rPr>
+              <a:t>8 / 11</a:t>
+            </a:r>
+          </a:p>
+        </p:txBody>
+      </p:sp>
     </p:spTree>
   </p:cSld>
   <p:clrMapOvr>
@@ -11003,7 +11393,7 @@
                 </a:solidFill>
                 <a:latin typeface="Calibri"/>
               </a:rPr>
-              <a:t>покрытие ПрО: 40 концептов найдено</a:t>
+              <a:t>покрытие ПрО: найдено из 40 ключевых понятий</a:t>
             </a:r>
           </a:p>
         </p:txBody>
@@ -11672,6 +12062,45 @@
                 <a:latin typeface="Calibri"/>
               </a:rPr>
               <a:t>GRAIN REFINEMENT  →  CONTROLLED ROLLING  →  REHEATING TEMPERATURE  →  SLAB</a:t>
+            </a:r>
+          </a:p>
+        </p:txBody>
+      </p:sp>
+      <p:sp>
+        <p:nvSpPr>
+          <p:cNvPr id="15" name="TextBox 14"/>
+          <p:cNvSpPr txBox="1"/>
+          <p:nvPr/>
+        </p:nvSpPr>
+        <p:spPr>
+          <a:xfrm>
+            <a:off x="10725912" y="6528816"/>
+            <a:ext cx="914400" cy="237744"/>
+          </a:xfrm>
+          <a:prstGeom prst="rect">
+            <a:avLst/>
+          </a:prstGeom>
+          <a:noFill/>
+        </p:spPr>
+        <p:txBody>
+          <a:bodyPr wrap="square" lIns="0" rIns="0" tIns="0" bIns="0">
+            <a:spAutoFit/>
+          </a:bodyPr>
+          <a:lstStyle/>
+          <a:p>
+            <a:pPr algn="r">
+              <a:spcAft>
+                <a:spcPts val="600"/>
+              </a:spcAft>
+            </a:pPr>
+            <a:r>
+              <a:rPr sz="1100" b="0">
+                <a:solidFill>
+                  <a:srgbClr val="5F5E5A"/>
+                </a:solidFill>
+                <a:latin typeface="Calibri"/>
+              </a:rPr>
+              <a:t>9 / 11</a:t>
             </a:r>
           </a:p>
         </p:txBody>

</xml_diff>

<commit_message>
Mark every lab-2 slide metric as LLM, deterministic or hybrid
Co-Authored-By: Claude Opus 5.5 <noreply@anthropic.com>
</commit_message>
<xml_diff>
--- a/1-graph/lab-2/results/presentation.pptx
+++ b/1-graph/lab-2/results/presentation.pptx
@@ -134,6 +134,14 @@
                 </a:solidFill>
               </a:rPr>
               <a:t>Размер чанка, токенов o200k (среднее)</a:t>
+            </a:r>
+            <a:r>
+              <a:rPr sz="1400" b="0">
+                <a:solidFill>
+                  <a:srgbClr val="008300"/>
+                </a:solidFill>
+              </a:rPr>
+              <a:t> ⋄</a:t>
             </a:r>
           </a:p>
         </c:rich>
@@ -386,6 +394,14 @@
                 </a:solidFill>
               </a:rPr>
               <a:t>Вершины по типам</a:t>
+            </a:r>
+            <a:r>
+              <a:rPr sz="1400" b="0">
+                <a:solidFill>
+                  <a:srgbClr val="008300"/>
+                </a:solidFill>
+              </a:rPr>
+              <a:t> ⋄</a:t>
             </a:r>
           </a:p>
         </c:rich>
@@ -5012,7 +5028,7 @@
                       </a:r>
                     </a:p>
                   </a:txBody>
-                  <a:tcPr marL="73152" marR="73152" marT="27432" marB="27432">
+                  <a:tcPr marL="73152" marR="73152" marT="27432" marB="27432" anchor="ctr">
                     <a:solidFill>
                       <a:srgbClr val="F1F4F8"/>
                     </a:solidFill>
@@ -5035,7 +5051,7 @@
                       </a:r>
                     </a:p>
                   </a:txBody>
-                  <a:tcPr marL="73152" marR="73152" marT="27432" marB="27432">
+                  <a:tcPr marL="73152" marR="73152" marT="27432" marB="27432" anchor="ctr">
                     <a:solidFill>
                       <a:srgbClr val="F1F4F8"/>
                     </a:solidFill>
@@ -5058,7 +5074,7 @@
                       </a:r>
                     </a:p>
                   </a:txBody>
-                  <a:tcPr marL="73152" marR="73152" marT="27432" marB="27432">
+                  <a:tcPr marL="73152" marR="73152" marT="27432" marB="27432" anchor="ctr">
                     <a:solidFill>
                       <a:srgbClr val="F1F4F8"/>
                     </a:solidFill>
@@ -5081,9 +5097,17 @@
                         </a:rPr>
                         <a:t>Полнота по тексту (1–5)</a:t>
                       </a:r>
+                      <a:r>
+                        <a:rPr sz="1500" b="0">
+                          <a:solidFill>
+                            <a:srgbClr val="008300"/>
+                          </a:solidFill>
+                        </a:rPr>
+                        <a:t> ⋆</a:t>
+                      </a:r>
                     </a:p>
                   </a:txBody>
-                  <a:tcPr marL="73152" marR="73152" marT="27432" marB="27432">
+                  <a:tcPr marL="73152" marR="73152" marT="27432" marB="27432" anchor="ctr">
                     <a:solidFill>
                       <a:srgbClr val="FFFFFF"/>
                     </a:solidFill>
@@ -5106,7 +5130,7 @@
                       </a:r>
                     </a:p>
                   </a:txBody>
-                  <a:tcPr marL="73152" marR="73152" marT="27432" marB="27432">
+                  <a:tcPr marL="73152" marR="73152" marT="27432" marB="27432" anchor="ctr">
                     <a:solidFill>
                       <a:srgbClr val="FFFFFF"/>
                     </a:solidFill>
@@ -5129,7 +5153,7 @@
                       </a:r>
                     </a:p>
                   </a:txBody>
-                  <a:tcPr marL="73152" marR="73152" marT="27432" marB="27432">
+                  <a:tcPr marL="73152" marR="73152" marT="27432" marB="27432" anchor="ctr">
                     <a:solidFill>
                       <a:srgbClr val="FFFFFF"/>
                     </a:solidFill>
@@ -5152,9 +5176,17 @@
                         </a:rPr>
                         <a:t>Покрытие понятий фрагмента (1–5)</a:t>
                       </a:r>
+                      <a:r>
+                        <a:rPr sz="1500" b="0">
+                          <a:solidFill>
+                            <a:srgbClr val="008300"/>
+                          </a:solidFill>
+                        </a:rPr>
+                        <a:t> ⋆</a:t>
+                      </a:r>
                     </a:p>
                   </a:txBody>
-                  <a:tcPr marL="73152" marR="73152" marT="27432" marB="27432">
+                  <a:tcPr marL="73152" marR="73152" marT="27432" marB="27432" anchor="ctr">
                     <a:solidFill>
                       <a:srgbClr val="FFFFFF"/>
                     </a:solidFill>
@@ -5177,7 +5209,7 @@
                       </a:r>
                     </a:p>
                   </a:txBody>
-                  <a:tcPr marL="73152" marR="73152" marT="27432" marB="27432">
+                  <a:tcPr marL="73152" marR="73152" marT="27432" marB="27432" anchor="ctr">
                     <a:solidFill>
                       <a:srgbClr val="FFFFFF"/>
                     </a:solidFill>
@@ -5200,7 +5232,7 @@
                       </a:r>
                     </a:p>
                   </a:txBody>
-                  <a:tcPr marL="73152" marR="73152" marT="27432" marB="27432">
+                  <a:tcPr marL="73152" marR="73152" marT="27432" marB="27432" anchor="ctr">
                     <a:solidFill>
                       <a:srgbClr val="FFFFFF"/>
                     </a:solidFill>
@@ -5223,9 +5255,17 @@
                         </a:rPr>
                         <a:t>Целостность формул и таблиц (1–5)</a:t>
                       </a:r>
+                      <a:r>
+                        <a:rPr sz="1500" b="0">
+                          <a:solidFill>
+                            <a:srgbClr val="008300"/>
+                          </a:solidFill>
+                        </a:rPr>
+                        <a:t> ⋆</a:t>
+                      </a:r>
                     </a:p>
                   </a:txBody>
-                  <a:tcPr marL="73152" marR="73152" marT="27432" marB="27432">
+                  <a:tcPr marL="73152" marR="73152" marT="27432" marB="27432" anchor="ctr">
                     <a:solidFill>
                       <a:srgbClr val="FFFFFF"/>
                     </a:solidFill>
@@ -5248,7 +5288,7 @@
                       </a:r>
                     </a:p>
                   </a:txBody>
-                  <a:tcPr marL="73152" marR="73152" marT="27432" marB="27432">
+                  <a:tcPr marL="73152" marR="73152" marT="27432" marB="27432" anchor="ctr">
                     <a:solidFill>
                       <a:srgbClr val="FFFFFF"/>
                     </a:solidFill>
@@ -5271,7 +5311,7 @@
                       </a:r>
                     </a:p>
                   </a:txBody>
-                  <a:tcPr marL="73152" marR="73152" marT="27432" marB="27432">
+                  <a:tcPr marL="73152" marR="73152" marT="27432" marB="27432" anchor="ctr">
                     <a:solidFill>
                       <a:srgbClr val="FFFFFF"/>
                     </a:solidFill>
@@ -5294,9 +5334,17 @@
                         </a:rPr>
                         <a:t>Противоречия тексту, шт.</a:t>
                       </a:r>
+                      <a:r>
+                        <a:rPr sz="1500" b="0">
+                          <a:solidFill>
+                            <a:srgbClr val="008300"/>
+                          </a:solidFill>
+                        </a:rPr>
+                        <a:t> ⋆</a:t>
+                      </a:r>
                     </a:p>
                   </a:txBody>
-                  <a:tcPr marL="73152" marR="73152" marT="27432" marB="27432">
+                  <a:tcPr marL="73152" marR="73152" marT="27432" marB="27432" anchor="ctr">
                     <a:solidFill>
                       <a:srgbClr val="FFFFFF"/>
                     </a:solidFill>
@@ -5319,7 +5367,7 @@
                       </a:r>
                     </a:p>
                   </a:txBody>
-                  <a:tcPr marL="73152" marR="73152" marT="27432" marB="27432">
+                  <a:tcPr marL="73152" marR="73152" marT="27432" marB="27432" anchor="ctr">
                     <a:solidFill>
                       <a:srgbClr val="FFFFFF"/>
                     </a:solidFill>
@@ -5342,7 +5390,7 @@
                       </a:r>
                     </a:p>
                   </a:txBody>
-                  <a:tcPr marL="73152" marR="73152" marT="27432" marB="27432">
+                  <a:tcPr marL="73152" marR="73152" marT="27432" marB="27432" anchor="ctr">
                     <a:solidFill>
                       <a:srgbClr val="FFFFFF"/>
                     </a:solidFill>
@@ -5365,9 +5413,17 @@
                         </a:rPr>
                         <a:t>Шумовые сущности во фрагментах</a:t>
                       </a:r>
+                      <a:r>
+                        <a:rPr sz="1500" b="0">
+                          <a:solidFill>
+                            <a:srgbClr val="008300"/>
+                          </a:solidFill>
+                        </a:rPr>
+                        <a:t> ⋆</a:t>
+                      </a:r>
                     </a:p>
                   </a:txBody>
-                  <a:tcPr marL="73152" marR="73152" marT="27432" marB="27432">
+                  <a:tcPr marL="73152" marR="73152" marT="27432" marB="27432" anchor="ctr">
                     <a:solidFill>
                       <a:srgbClr val="FFFFFF"/>
                     </a:solidFill>
@@ -5390,7 +5446,7 @@
                       </a:r>
                     </a:p>
                   </a:txBody>
-                  <a:tcPr marL="73152" marR="73152" marT="27432" marB="27432">
+                  <a:tcPr marL="73152" marR="73152" marT="27432" marB="27432" anchor="ctr">
                     <a:solidFill>
                       <a:srgbClr val="FFFFFF"/>
                     </a:solidFill>
@@ -5413,7 +5469,7 @@
                       </a:r>
                     </a:p>
                   </a:txBody>
-                  <a:tcPr marL="73152" marR="73152" marT="27432" marB="27432">
+                  <a:tcPr marL="73152" marR="73152" marT="27432" marB="27432" anchor="ctr">
                     <a:solidFill>
                       <a:srgbClr val="FFFFFF"/>
                     </a:solidFill>
@@ -5436,9 +5492,17 @@
                         </a:rPr>
                         <a:t>Шумовые вершины графа</a:t>
                       </a:r>
+                      <a:r>
+                        <a:rPr sz="1500" b="0">
+                          <a:solidFill>
+                            <a:srgbClr val="008300"/>
+                          </a:solidFill>
+                        </a:rPr>
+                        <a:t> ⋆</a:t>
+                      </a:r>
                     </a:p>
                   </a:txBody>
-                  <a:tcPr marL="73152" marR="73152" marT="27432" marB="27432">
+                  <a:tcPr marL="73152" marR="73152" marT="27432" marB="27432" anchor="ctr">
                     <a:solidFill>
                       <a:srgbClr val="FFFFFF"/>
                     </a:solidFill>
@@ -5461,7 +5525,7 @@
                       </a:r>
                     </a:p>
                   </a:txBody>
-                  <a:tcPr marL="73152" marR="73152" marT="27432" marB="27432">
+                  <a:tcPr marL="73152" marR="73152" marT="27432" marB="27432" anchor="ctr">
                     <a:solidFill>
                       <a:srgbClr val="FFFFFF"/>
                     </a:solidFill>
@@ -5484,7 +5548,7 @@
                       </a:r>
                     </a:p>
                   </a:txBody>
-                  <a:tcPr marL="73152" marR="73152" marT="27432" marB="27432">
+                  <a:tcPr marL="73152" marR="73152" marT="27432" marB="27432" anchor="ctr">
                     <a:solidFill>
                       <a:srgbClr val="FFFFFF"/>
                     </a:solidFill>
@@ -5507,9 +5571,17 @@
                         </a:rPr>
                         <a:t>Корреференции: дубликаты вершин</a:t>
                       </a:r>
+                      <a:r>
+                        <a:rPr sz="1500" b="0">
+                          <a:solidFill>
+                            <a:srgbClr val="008300"/>
+                          </a:solidFill>
+                        </a:rPr>
+                        <a:t> ⊹</a:t>
+                      </a:r>
                     </a:p>
                   </a:txBody>
-                  <a:tcPr marL="73152" marR="73152" marT="27432" marB="27432">
+                  <a:tcPr marL="73152" marR="73152" marT="27432" marB="27432" anchor="ctr">
                     <a:solidFill>
                       <a:srgbClr val="FFFFFF"/>
                     </a:solidFill>
@@ -5532,7 +5604,7 @@
                       </a:r>
                     </a:p>
                   </a:txBody>
-                  <a:tcPr marL="73152" marR="73152" marT="27432" marB="27432">
+                  <a:tcPr marL="73152" marR="73152" marT="27432" marB="27432" anchor="ctr">
                     <a:solidFill>
                       <a:srgbClr val="FFFFFF"/>
                     </a:solidFill>
@@ -5555,7 +5627,7 @@
                       </a:r>
                     </a:p>
                   </a:txBody>
-                  <a:tcPr marL="73152" marR="73152" marT="27432" marB="27432">
+                  <a:tcPr marL="73152" marR="73152" marT="27432" marB="27432" anchor="ctr">
                     <a:solidFill>
                       <a:srgbClr val="FFFFFF"/>
                     </a:solidFill>
@@ -5578,9 +5650,17 @@
                         </a:rPr>
                         <a:t>  из них межъязыковые</a:t>
                       </a:r>
+                      <a:r>
+                        <a:rPr sz="1500" b="0">
+                          <a:solidFill>
+                            <a:srgbClr val="008300"/>
+                          </a:solidFill>
+                        </a:rPr>
+                        <a:t> ⊹</a:t>
+                      </a:r>
                     </a:p>
                   </a:txBody>
-                  <a:tcPr marL="73152" marR="73152" marT="27432" marB="27432">
+                  <a:tcPr marL="73152" marR="73152" marT="27432" marB="27432" anchor="ctr">
                     <a:solidFill>
                       <a:srgbClr val="FFFFFF"/>
                     </a:solidFill>
@@ -5603,7 +5683,7 @@
                       </a:r>
                     </a:p>
                   </a:txBody>
-                  <a:tcPr marL="73152" marR="73152" marT="27432" marB="27432">
+                  <a:tcPr marL="73152" marR="73152" marT="27432" marB="27432" anchor="ctr">
                     <a:solidFill>
                       <a:srgbClr val="FFFFFF"/>
                     </a:solidFill>
@@ -5626,7 +5706,7 @@
                       </a:r>
                     </a:p>
                   </a:txBody>
-                  <a:tcPr marL="73152" marR="73152" marT="27432" marB="27432">
+                  <a:tcPr marL="73152" marR="73152" marT="27432" marB="27432" anchor="ctr">
                     <a:solidFill>
                       <a:srgbClr val="FFFFFF"/>
                     </a:solidFill>
@@ -5718,6 +5798,14 @@
                 <a:latin typeface="Calibri"/>
               </a:rPr>
               <a:t>Шум грязного графа</a:t>
+            </a:r>
+            <a:r>
+              <a:rPr sz="1300" b="0">
+                <a:solidFill>
+                  <a:srgbClr val="008300"/>
+                </a:solidFill>
+              </a:rPr>
+              <a:t> ⋆</a:t>
             </a:r>
           </a:p>
         </p:txBody>
@@ -6293,7 +6381,7 @@
           <a:p>
             <a:pPr algn="ctr"/>
             <a:r>
-              <a:rPr sz="1100">
+              <a:rPr sz="1000">
                 <a:solidFill>
                   <a:srgbClr val="1F2328"/>
                 </a:solidFill>
@@ -6389,13 +6477,21 @@
           <a:p>
             <a:pPr algn="ctr"/>
             <a:r>
-              <a:rPr sz="1100">
+              <a:rPr sz="1000">
                 <a:solidFill>
                   <a:srgbClr val="1F2328"/>
                 </a:solidFill>
                 <a:latin typeface="Calibri"/>
               </a:rPr>
               <a:t>GraphRAG</a:t>
+            </a:r>
+            <a:r>
+              <a:rPr sz="1100" b="0">
+                <a:solidFill>
+                  <a:srgbClr val="008300"/>
+                </a:solidFill>
+              </a:rPr>
+              <a:t> ⋆</a:t>
             </a:r>
           </a:p>
         </p:txBody>
@@ -6485,7 +6581,7 @@
           <a:p>
             <a:pPr algn="ctr"/>
             <a:r>
-              <a:rPr sz="1100">
+              <a:rPr sz="1000">
                 <a:solidFill>
                   <a:srgbClr val="1F2328"/>
                 </a:solidFill>
@@ -6581,13 +6677,21 @@
           <a:p>
             <a:pPr algn="ctr"/>
             <a:r>
-              <a:rPr sz="1100">
+              <a:rPr sz="1000">
                 <a:solidFill>
                   <a:srgbClr val="1F2328"/>
                 </a:solidFill>
                 <a:latin typeface="Calibri"/>
               </a:rPr>
               <a:t>Chunking</a:t>
+            </a:r>
+            <a:r>
+              <a:rPr sz="1100" b="0">
+                <a:solidFill>
+                  <a:srgbClr val="008300"/>
+                </a:solidFill>
+              </a:rPr>
+              <a:t> ⋄</a:t>
             </a:r>
           </a:p>
         </p:txBody>
@@ -6677,13 +6781,21 @@
           <a:p>
             <a:pPr algn="ctr"/>
             <a:r>
-              <a:rPr sz="1100">
+              <a:rPr sz="1000">
                 <a:solidFill>
                   <a:srgbClr val="1F2328"/>
                 </a:solidFill>
                 <a:latin typeface="Calibri"/>
               </a:rPr>
               <a:t>Очистка</a:t>
+            </a:r>
+            <a:r>
+              <a:rPr sz="1100" b="0">
+                <a:solidFill>
+                  <a:srgbClr val="008300"/>
+                </a:solidFill>
+              </a:rPr>
+              <a:t> ⋄</a:t>
             </a:r>
           </a:p>
         </p:txBody>
@@ -6773,13 +6885,21 @@
           <a:p>
             <a:pPr algn="ctr"/>
             <a:r>
-              <a:rPr sz="1100">
+              <a:rPr sz="1000">
                 <a:solidFill>
                   <a:srgbClr val="1F2328"/>
                 </a:solidFill>
                 <a:latin typeface="Calibri"/>
               </a:rPr>
               <a:t>Нормализация</a:t>
+            </a:r>
+            <a:r>
+              <a:rPr sz="1100" b="0">
+                <a:solidFill>
+                  <a:srgbClr val="008300"/>
+                </a:solidFill>
+              </a:rPr>
+              <a:t> ⋄</a:t>
             </a:r>
           </a:p>
         </p:txBody>
@@ -6869,13 +6989,21 @@
           <a:p>
             <a:pPr algn="ctr"/>
             <a:r>
-              <a:rPr sz="1100">
+              <a:rPr sz="1000">
                 <a:solidFill>
                   <a:srgbClr val="1F2328"/>
                 </a:solidFill>
                 <a:latin typeface="Calibri"/>
               </a:rPr>
               <a:t>Токенизация</a:t>
+            </a:r>
+            <a:r>
+              <a:rPr sz="1100" b="0">
+                <a:solidFill>
+                  <a:srgbClr val="008300"/>
+                </a:solidFill>
+              </a:rPr>
+              <a:t> ⋄</a:t>
             </a:r>
           </a:p>
         </p:txBody>
@@ -6965,13 +7093,21 @@
           <a:p>
             <a:pPr algn="ctr"/>
             <a:r>
-              <a:rPr sz="1100">
+              <a:rPr sz="1000">
                 <a:solidFill>
                   <a:srgbClr val="1F2328"/>
                 </a:solidFill>
                 <a:latin typeface="Calibri"/>
               </a:rPr>
               <a:t>Векторизация</a:t>
+            </a:r>
+            <a:r>
+              <a:rPr sz="1100" b="0">
+                <a:solidFill>
+                  <a:srgbClr val="008300"/>
+                </a:solidFill>
+              </a:rPr>
+              <a:t> ⋄</a:t>
             </a:r>
           </a:p>
         </p:txBody>
@@ -7061,13 +7197,21 @@
           <a:p>
             <a:pPr algn="ctr"/>
             <a:r>
-              <a:rPr sz="1100">
+              <a:rPr sz="1000">
                 <a:solidFill>
                   <a:srgbClr val="1F2328"/>
                 </a:solidFill>
                 <a:latin typeface="Calibri"/>
               </a:rPr>
               <a:t>GraphRAG</a:t>
+            </a:r>
+            <a:r>
+              <a:rPr sz="1100" b="0">
+                <a:solidFill>
+                  <a:srgbClr val="008300"/>
+                </a:solidFill>
+              </a:rPr>
+              <a:t> ⋆</a:t>
             </a:r>
           </a:p>
         </p:txBody>
@@ -7146,6 +7290,92 @@
       <p:sp>
         <p:nvSpPr>
           <p:cNvPr id="22" name="TextBox 21"/>
+          <p:cNvSpPr txBox="1"/>
+          <p:nvPr/>
+        </p:nvSpPr>
+        <p:spPr>
+          <a:xfrm>
+            <a:off x="548640" y="5669280"/>
+            <a:ext cx="11064240" cy="365760"/>
+          </a:xfrm>
+          <a:prstGeom prst="rect">
+            <a:avLst/>
+          </a:prstGeom>
+          <a:noFill/>
+        </p:spPr>
+        <p:txBody>
+          <a:bodyPr wrap="square" lIns="0" rIns="0" tIns="0" bIns="0">
+            <a:spAutoFit/>
+          </a:bodyPr>
+          <a:lstStyle/>
+          <a:p>
+            <a:pPr algn="l"/>
+            <a:r>
+              <a:rPr sz="1400">
+                <a:solidFill>
+                  <a:srgbClr val="5F5E5A"/>
+                </a:solidFill>
+                <a:latin typeface="Calibri"/>
+              </a:rPr>
+              <a:t>Метки у метрик:</a:t>
+            </a:r>
+            <a:r>
+              <a:rPr sz="1800" b="0">
+                <a:solidFill>
+                  <a:srgbClr val="008300"/>
+                </a:solidFill>
+              </a:rPr>
+              <a:t> ⋆</a:t>
+            </a:r>
+            <a:r>
+              <a:rPr sz="1400">
+                <a:solidFill>
+                  <a:srgbClr val="5F5E5A"/>
+                </a:solidFill>
+                <a:latin typeface="Calibri"/>
+              </a:rPr>
+              <a:t> — LLM   </a:t>
+            </a:r>
+            <a:r>
+              <a:rPr sz="1800" b="0">
+                <a:solidFill>
+                  <a:srgbClr val="008300"/>
+                </a:solidFill>
+              </a:rPr>
+              <a:t> ⋄</a:t>
+            </a:r>
+            <a:r>
+              <a:rPr sz="1400">
+                <a:solidFill>
+                  <a:srgbClr val="5F5E5A"/>
+                </a:solidFill>
+                <a:latin typeface="Calibri"/>
+              </a:rPr>
+              <a:t> — детерминированный алгоритм   </a:t>
+            </a:r>
+            <a:r>
+              <a:rPr sz="1800" b="0">
+                <a:solidFill>
+                  <a:srgbClr val="008300"/>
+                </a:solidFill>
+              </a:rPr>
+              <a:t> ⊹</a:t>
+            </a:r>
+            <a:r>
+              <a:rPr sz="1400">
+                <a:solidFill>
+                  <a:srgbClr val="5F5E5A"/>
+                </a:solidFill>
+                <a:latin typeface="Calibri"/>
+              </a:rPr>
+              <a:t> — гибрид   </a:t>
+            </a:r>
+          </a:p>
+        </p:txBody>
+      </p:sp>
+      <p:sp>
+        <p:nvSpPr>
+          <p:cNvPr id="23" name="TextBox 22"/>
           <p:cNvSpPr txBox="1"/>
           <p:nvPr/>
         </p:nvSpPr>
@@ -7346,7 +7576,7 @@
         <p:spPr>
           <a:xfrm>
             <a:off x="822959" y="2331720"/>
-            <a:ext cx="3017520" cy="640080"/>
+            <a:ext cx="3154680" cy="640080"/>
           </a:xfrm>
           <a:prstGeom prst="rect">
             <a:avLst/>
@@ -7372,6 +7602,14 @@
                 <a:latin typeface="Calibri"/>
               </a:rPr>
               <a:t>границ чанков режут предложение</a:t>
+            </a:r>
+            <a:r>
+              <a:rPr sz="1300" b="0">
+                <a:solidFill>
+                  <a:srgbClr val="008300"/>
+                </a:solidFill>
+              </a:rPr>
+              <a:t> ⋄</a:t>
             </a:r>
           </a:p>
         </p:txBody>
@@ -7483,7 +7721,7 @@
         <p:spPr>
           <a:xfrm>
             <a:off x="822959" y="4114800"/>
-            <a:ext cx="3017520" cy="640080"/>
+            <a:ext cx="3154680" cy="640080"/>
           </a:xfrm>
           <a:prstGeom prst="rect">
             <a:avLst/>
@@ -7509,6 +7747,14 @@
                 <a:latin typeface="Calibri"/>
               </a:rPr>
               <a:t>формул и таблиц разрезано границей</a:t>
+            </a:r>
+            <a:r>
+              <a:rPr sz="1300" b="0">
+                <a:solidFill>
+                  <a:srgbClr val="008300"/>
+                </a:solidFill>
+              </a:rPr>
+              <a:t> ⋄</a:t>
             </a:r>
           </a:p>
         </p:txBody>
@@ -7874,7 +8120,7 @@
         <p:spPr>
           <a:xfrm>
             <a:off x="822959" y="2331720"/>
-            <a:ext cx="3017520" cy="640080"/>
+            <a:ext cx="3154680" cy="640080"/>
           </a:xfrm>
           <a:prstGeom prst="rect">
             <a:avLst/>
@@ -7900,6 +8146,14 @@
                 <a:latin typeface="Calibri"/>
               </a:rPr>
               <a:t>доля шумовых символов</a:t>
+            </a:r>
+            <a:r>
+              <a:rPr sz="1300" b="0">
+                <a:solidFill>
+                  <a:srgbClr val="008300"/>
+                </a:solidFill>
+              </a:rPr>
+              <a:t> ⋄</a:t>
             </a:r>
           </a:p>
         </p:txBody>
@@ -8011,7 +8265,7 @@
         <p:spPr>
           <a:xfrm>
             <a:off x="4617720" y="2331720"/>
-            <a:ext cx="3017520" cy="640080"/>
+            <a:ext cx="3154680" cy="640080"/>
           </a:xfrm>
           <a:prstGeom prst="rect">
             <a:avLst/>
@@ -8037,6 +8291,14 @@
                 <a:latin typeface="Calibri"/>
               </a:rPr>
               <a:t>служебных меток</a:t>
+            </a:r>
+            <a:r>
+              <a:rPr sz="1300" b="0">
+                <a:solidFill>
+                  <a:srgbClr val="008300"/>
+                </a:solidFill>
+              </a:rPr>
+              <a:t> ⋄</a:t>
             </a:r>
           </a:p>
         </p:txBody>
@@ -8148,7 +8410,7 @@
         <p:spPr>
           <a:xfrm>
             <a:off x="8412480" y="2331720"/>
-            <a:ext cx="3017520" cy="640080"/>
+            <a:ext cx="3154680" cy="640080"/>
           </a:xfrm>
           <a:prstGeom prst="rect">
             <a:avLst/>
@@ -8174,6 +8436,14 @@
                 <a:latin typeface="Calibri"/>
               </a:rPr>
               <a:t>разорванных абзацев</a:t>
+            </a:r>
+            <a:r>
+              <a:rPr sz="1300" b="0">
+                <a:solidFill>
+                  <a:srgbClr val="008300"/>
+                </a:solidFill>
+              </a:rPr>
+              <a:t> ⋄</a:t>
             </a:r>
           </a:p>
         </p:txBody>
@@ -8347,6 +8617,14 @@
               </a:rPr>
               <a:t>PII (авторы, аффилиации): 127 → 0;  числа, формулы, ячейки таблиц: 100% / 100% / 100% сохранено</a:t>
             </a:r>
+            <a:r>
+              <a:rPr sz="1500" b="0">
+                <a:solidFill>
+                  <a:srgbClr val="008300"/>
+                </a:solidFill>
+              </a:rPr>
+              <a:t> ⋄</a:t>
+            </a:r>
           </a:p>
         </p:txBody>
       </p:sp>
@@ -8654,7 +8932,7 @@
         <p:spPr>
           <a:xfrm>
             <a:off x="822959" y="2331720"/>
-            <a:ext cx="3017520" cy="640080"/>
+            <a:ext cx="3154680" cy="640080"/>
           </a:xfrm>
           <a:prstGeom prst="rect">
             <a:avLst/>
@@ -8680,6 +8958,14 @@
                 <a:latin typeface="Calibri"/>
               </a:rPr>
               <a:t>единиц измерения в каноническом виде</a:t>
+            </a:r>
+            <a:r>
+              <a:rPr sz="1300" b="0">
+                <a:solidFill>
+                  <a:srgbClr val="008300"/>
+                </a:solidFill>
+              </a:rPr>
+              <a:t> ⋄</a:t>
             </a:r>
           </a:p>
         </p:txBody>
@@ -8791,7 +9077,7 @@
         <p:spPr>
           <a:xfrm>
             <a:off x="822959" y="4114800"/>
-            <a:ext cx="3017520" cy="640080"/>
+            <a:ext cx="3154680" cy="640080"/>
           </a:xfrm>
           <a:prstGeom prst="rect">
             <a:avLst/>
@@ -8817,6 +9103,14 @@
                 <a:latin typeface="Calibri"/>
               </a:rPr>
               <a:t>терминов глоссария в обеих книгах</a:t>
+            </a:r>
+            <a:r>
+              <a:rPr sz="1300" b="0">
+                <a:solidFill>
+                  <a:srgbClr val="008300"/>
+                </a:solidFill>
+              </a:rPr>
+              <a:t> ⋄</a:t>
             </a:r>
           </a:p>
         </p:txBody>
@@ -9300,7 +9594,7 @@
                       </a:r>
                     </a:p>
                   </a:txBody>
-                  <a:tcPr marL="73152" marR="73152" marT="27432" marB="27432">
+                  <a:tcPr marL="73152" marR="73152" marT="27432" marB="27432" anchor="ctr">
                     <a:solidFill>
                       <a:srgbClr val="F1F4F8"/>
                     </a:solidFill>
@@ -9323,7 +9617,7 @@
                       </a:r>
                     </a:p>
                   </a:txBody>
-                  <a:tcPr marL="73152" marR="73152" marT="27432" marB="27432">
+                  <a:tcPr marL="73152" marR="73152" marT="27432" marB="27432" anchor="ctr">
                     <a:solidFill>
                       <a:srgbClr val="F1F4F8"/>
                     </a:solidFill>
@@ -9346,7 +9640,7 @@
                       </a:r>
                     </a:p>
                   </a:txBody>
-                  <a:tcPr marL="73152" marR="73152" marT="27432" marB="27432">
+                  <a:tcPr marL="73152" marR="73152" marT="27432" marB="27432" anchor="ctr">
                     <a:solidFill>
                       <a:srgbClr val="F1F4F8"/>
                     </a:solidFill>
@@ -9369,9 +9663,17 @@
                         </a:rPr>
                         <a:t>OOV-rate (доля неизвестных слов)</a:t>
                       </a:r>
+                      <a:r>
+                        <a:rPr sz="1500" b="0">
+                          <a:solidFill>
+                            <a:srgbClr val="008300"/>
+                          </a:solidFill>
+                        </a:rPr>
+                        <a:t> ⋄</a:t>
+                      </a:r>
                     </a:p>
                   </a:txBody>
-                  <a:tcPr marL="73152" marR="73152" marT="27432" marB="27432">
+                  <a:tcPr marL="73152" marR="73152" marT="27432" marB="27432" anchor="ctr">
                     <a:solidFill>
                       <a:srgbClr val="FFFFFF"/>
                     </a:solidFill>
@@ -9394,7 +9696,7 @@
                       </a:r>
                     </a:p>
                   </a:txBody>
-                  <a:tcPr marL="73152" marR="73152" marT="27432" marB="27432">
+                  <a:tcPr marL="73152" marR="73152" marT="27432" marB="27432" anchor="ctr">
                     <a:solidFill>
                       <a:srgbClr val="FFFFFF"/>
                     </a:solidFill>
@@ -9417,7 +9719,7 @@
                       </a:r>
                     </a:p>
                   </a:txBody>
-                  <a:tcPr marL="73152" marR="73152" marT="27432" marB="27432">
+                  <a:tcPr marL="73152" marR="73152" marT="27432" marB="27432" anchor="ctr">
                     <a:solidFill>
                       <a:srgbClr val="FFFFFF"/>
                     </a:solidFill>
@@ -9440,9 +9742,17 @@
                         </a:rPr>
                         <a:t>Уникальных OOV</a:t>
                       </a:r>
+                      <a:r>
+                        <a:rPr sz="1500" b="0">
+                          <a:solidFill>
+                            <a:srgbClr val="008300"/>
+                          </a:solidFill>
+                        </a:rPr>
+                        <a:t> ⋄</a:t>
+                      </a:r>
                     </a:p>
                   </a:txBody>
-                  <a:tcPr marL="73152" marR="73152" marT="27432" marB="27432">
+                  <a:tcPr marL="73152" marR="73152" marT="27432" marB="27432" anchor="ctr">
                     <a:solidFill>
                       <a:srgbClr val="FFFFFF"/>
                     </a:solidFill>
@@ -9465,7 +9775,7 @@
                       </a:r>
                     </a:p>
                   </a:txBody>
-                  <a:tcPr marL="73152" marR="73152" marT="27432" marB="27432">
+                  <a:tcPr marL="73152" marR="73152" marT="27432" marB="27432" anchor="ctr">
                     <a:solidFill>
                       <a:srgbClr val="FFFFFF"/>
                     </a:solidFill>
@@ -9488,7 +9798,7 @@
                       </a:r>
                     </a:p>
                   </a:txBody>
-                  <a:tcPr marL="73152" marR="73152" marT="27432" marB="27432">
+                  <a:tcPr marL="73152" marR="73152" marT="27432" marB="27432" anchor="ctr">
                     <a:solidFill>
                       <a:srgbClr val="FFFFFF"/>
                     </a:solidFill>
@@ -9511,9 +9821,17 @@
                         </a:rPr>
                         <a:t>Неразобранные $ (обрывки формул)</a:t>
                       </a:r>
+                      <a:r>
+                        <a:rPr sz="1500" b="0">
+                          <a:solidFill>
+                            <a:srgbClr val="008300"/>
+                          </a:solidFill>
+                        </a:rPr>
+                        <a:t> ⋄</a:t>
+                      </a:r>
                     </a:p>
                   </a:txBody>
-                  <a:tcPr marL="73152" marR="73152" marT="27432" marB="27432">
+                  <a:tcPr marL="73152" marR="73152" marT="27432" marB="27432" anchor="ctr">
                     <a:solidFill>
                       <a:srgbClr val="FFFFFF"/>
                     </a:solidFill>
@@ -9536,7 +9854,7 @@
                       </a:r>
                     </a:p>
                   </a:txBody>
-                  <a:tcPr marL="73152" marR="73152" marT="27432" marB="27432">
+                  <a:tcPr marL="73152" marR="73152" marT="27432" marB="27432" anchor="ctr">
                     <a:solidFill>
                       <a:srgbClr val="FFFFFF"/>
                     </a:solidFill>
@@ -9559,7 +9877,7 @@
                       </a:r>
                     </a:p>
                   </a:txBody>
-                  <a:tcPr marL="73152" marR="73152" marT="27432" marB="27432">
+                  <a:tcPr marL="73152" marR="73152" marT="27432" marB="27432" anchor="ctr">
                     <a:solidFill>
                       <a:srgbClr val="FFFFFF"/>
                     </a:solidFill>
@@ -9582,9 +9900,17 @@
                         </a:rPr>
                         <a:t>LaTeX-обозначения → текст (γ, °C, Ar3)</a:t>
                       </a:r>
+                      <a:r>
+                        <a:rPr sz="1500" b="0">
+                          <a:solidFill>
+                            <a:srgbClr val="008300"/>
+                          </a:solidFill>
+                        </a:rPr>
+                        <a:t> ⋄</a:t>
+                      </a:r>
                     </a:p>
                   </a:txBody>
-                  <a:tcPr marL="73152" marR="73152" marT="27432" marB="27432">
+                  <a:tcPr marL="73152" marR="73152" marT="27432" marB="27432" anchor="ctr">
                     <a:solidFill>
                       <a:srgbClr val="FFFFFF"/>
                     </a:solidFill>
@@ -9607,7 +9933,7 @@
                       </a:r>
                     </a:p>
                   </a:txBody>
-                  <a:tcPr marL="73152" marR="73152" marT="27432" marB="27432">
+                  <a:tcPr marL="73152" marR="73152" marT="27432" marB="27432" anchor="ctr">
                     <a:solidFill>
                       <a:srgbClr val="FFFFFF"/>
                     </a:solidFill>
@@ -9630,7 +9956,7 @@
                       </a:r>
                     </a:p>
                   </a:txBody>
-                  <a:tcPr marL="73152" marR="73152" marT="27432" marB="27432">
+                  <a:tcPr marL="73152" marR="73152" marT="27432" marB="27432" anchor="ctr">
                     <a:solidFill>
                       <a:srgbClr val="FFFFFF"/>
                     </a:solidFill>
@@ -9653,9 +9979,17 @@
                         </a:rPr>
                         <a:t>Словарь TF-IDF, слов</a:t>
                       </a:r>
+                      <a:r>
+                        <a:rPr sz="1500" b="0">
+                          <a:solidFill>
+                            <a:srgbClr val="008300"/>
+                          </a:solidFill>
+                        </a:rPr>
+                        <a:t> ⋄</a:t>
+                      </a:r>
                     </a:p>
                   </a:txBody>
-                  <a:tcPr marL="73152" marR="73152" marT="27432" marB="27432">
+                  <a:tcPr marL="73152" marR="73152" marT="27432" marB="27432" anchor="ctr">
                     <a:solidFill>
                       <a:srgbClr val="FFFFFF"/>
                     </a:solidFill>
@@ -9678,7 +10012,7 @@
                       </a:r>
                     </a:p>
                   </a:txBody>
-                  <a:tcPr marL="73152" marR="73152" marT="27432" marB="27432">
+                  <a:tcPr marL="73152" marR="73152" marT="27432" marB="27432" anchor="ctr">
                     <a:solidFill>
                       <a:srgbClr val="FFFFFF"/>
                     </a:solidFill>
@@ -9701,7 +10035,7 @@
                       </a:r>
                     </a:p>
                   </a:txBody>
-                  <a:tcPr marL="73152" marR="73152" marT="27432" marB="27432">
+                  <a:tcPr marL="73152" marR="73152" marT="27432" marB="27432" anchor="ctr">
                     <a:solidFill>
                       <a:srgbClr val="FFFFFF"/>
                     </a:solidFill>
@@ -9724,9 +10058,17 @@
                         </a:rPr>
                         <a:t>Разреженность TF-IDF (окна по 300 слов)</a:t>
                       </a:r>
+                      <a:r>
+                        <a:rPr sz="1500" b="0">
+                          <a:solidFill>
+                            <a:srgbClr val="008300"/>
+                          </a:solidFill>
+                        </a:rPr>
+                        <a:t> ⋄</a:t>
+                      </a:r>
                     </a:p>
                   </a:txBody>
-                  <a:tcPr marL="73152" marR="73152" marT="27432" marB="27432">
+                  <a:tcPr marL="73152" marR="73152" marT="27432" marB="27432" anchor="ctr">
                     <a:solidFill>
                       <a:srgbClr val="FFFFFF"/>
                     </a:solidFill>
@@ -9749,7 +10091,7 @@
                       </a:r>
                     </a:p>
                   </a:txBody>
-                  <a:tcPr marL="73152" marR="73152" marT="27432" marB="27432">
+                  <a:tcPr marL="73152" marR="73152" marT="27432" marB="27432" anchor="ctr">
                     <a:solidFill>
                       <a:srgbClr val="FFFFFF"/>
                     </a:solidFill>
@@ -9772,7 +10114,7 @@
                       </a:r>
                     </a:p>
                   </a:txBody>
-                  <a:tcPr marL="73152" marR="73152" marT="27432" marB="27432">
+                  <a:tcPr marL="73152" marR="73152" marT="27432" marB="27432" anchor="ctr">
                     <a:solidFill>
                       <a:srgbClr val="FFFFFF"/>
                     </a:solidFill>
@@ -9795,9 +10137,17 @@
                         </a:rPr>
                         <a:t>Сходство RU→EN, лучший чанк (cos)</a:t>
                       </a:r>
+                      <a:r>
+                        <a:rPr sz="1500" b="0">
+                          <a:solidFill>
+                            <a:srgbClr val="008300"/>
+                          </a:solidFill>
+                        </a:rPr>
+                        <a:t> ⋄</a:t>
+                      </a:r>
                     </a:p>
                   </a:txBody>
-                  <a:tcPr marL="73152" marR="73152" marT="27432" marB="27432">
+                  <a:tcPr marL="73152" marR="73152" marT="27432" marB="27432" anchor="ctr">
                     <a:solidFill>
                       <a:srgbClr val="FFFFFF"/>
                     </a:solidFill>
@@ -9820,7 +10170,7 @@
                       </a:r>
                     </a:p>
                   </a:txBody>
-                  <a:tcPr marL="73152" marR="73152" marT="27432" marB="27432">
+                  <a:tcPr marL="73152" marR="73152" marT="27432" marB="27432" anchor="ctr">
                     <a:solidFill>
                       <a:srgbClr val="FFFFFF"/>
                     </a:solidFill>
@@ -9843,7 +10193,7 @@
                       </a:r>
                     </a:p>
                   </a:txBody>
-                  <a:tcPr marL="73152" marR="73152" marT="27432" marB="27432">
+                  <a:tcPr marL="73152" marR="73152" marT="27432" marB="27432" anchor="ctr">
                     <a:solidFill>
                       <a:srgbClr val="FFFFFF"/>
                     </a:solidFill>
@@ -10206,6 +10556,14 @@
               </a:rPr>
               <a:t>рёбер EN–RU: 0, общих узлов: 0</a:t>
             </a:r>
+            <a:r>
+              <a:rPr sz="1400" b="0">
+                <a:solidFill>
+                  <a:srgbClr val="008300"/>
+                </a:solidFill>
+              </a:rPr>
+              <a:t> ⋄</a:t>
+            </a:r>
           </a:p>
         </p:txBody>
       </p:sp>
@@ -10244,6 +10602,14 @@
                 <a:latin typeface="Calibri"/>
               </a:rPr>
               <a:t>рёбер EN–RU: 4, общих узлов: 18</a:t>
+            </a:r>
+            <a:r>
+              <a:rPr sz="1400" b="0">
+                <a:solidFill>
+                  <a:srgbClr val="008300"/>
+                </a:solidFill>
+              </a:rPr>
+              <a:t> ⋄</a:t>
             </a:r>
           </a:p>
         </p:txBody>
@@ -10385,7 +10751,7 @@
                       </a:r>
                     </a:p>
                   </a:txBody>
-                  <a:tcPr marL="73152" marR="73152" marT="27432" marB="27432">
+                  <a:tcPr marL="73152" marR="73152" marT="27432" marB="27432" anchor="ctr">
                     <a:solidFill>
                       <a:srgbClr val="F1F4F8"/>
                     </a:solidFill>
@@ -10408,7 +10774,7 @@
                       </a:r>
                     </a:p>
                   </a:txBody>
-                  <a:tcPr marL="73152" marR="73152" marT="27432" marB="27432">
+                  <a:tcPr marL="73152" marR="73152" marT="27432" marB="27432" anchor="ctr">
                     <a:solidFill>
                       <a:srgbClr val="F1F4F8"/>
                     </a:solidFill>
@@ -10431,7 +10797,7 @@
                       </a:r>
                     </a:p>
                   </a:txBody>
-                  <a:tcPr marL="73152" marR="73152" marT="27432" marB="27432">
+                  <a:tcPr marL="73152" marR="73152" marT="27432" marB="27432" anchor="ctr">
                     <a:solidFill>
                       <a:srgbClr val="F1F4F8"/>
                     </a:solidFill>
@@ -10454,9 +10820,17 @@
                         </a:rPr>
                         <a:t>Вершины / рёбра</a:t>
                       </a:r>
+                      <a:r>
+                        <a:rPr sz="1400" b="0">
+                          <a:solidFill>
+                            <a:srgbClr val="008300"/>
+                          </a:solidFill>
+                        </a:rPr>
+                        <a:t> ⋄</a:t>
+                      </a:r>
                     </a:p>
                   </a:txBody>
-                  <a:tcPr marL="73152" marR="73152" marT="27432" marB="27432">
+                  <a:tcPr marL="73152" marR="73152" marT="27432" marB="27432" anchor="ctr">
                     <a:solidFill>
                       <a:srgbClr val="FFFFFF"/>
                     </a:solidFill>
@@ -10479,7 +10853,7 @@
                       </a:r>
                     </a:p>
                   </a:txBody>
-                  <a:tcPr marL="73152" marR="73152" marT="27432" marB="27432">
+                  <a:tcPr marL="73152" marR="73152" marT="27432" marB="27432" anchor="ctr">
                     <a:solidFill>
                       <a:srgbClr val="FFFFFF"/>
                     </a:solidFill>
@@ -10502,7 +10876,7 @@
                       </a:r>
                     </a:p>
                   </a:txBody>
-                  <a:tcPr marL="73152" marR="73152" marT="27432" marB="27432">
+                  <a:tcPr marL="73152" marR="73152" marT="27432" marB="27432" anchor="ctr">
                     <a:solidFill>
                       <a:srgbClr val="FFFFFF"/>
                     </a:solidFill>
@@ -10523,11 +10897,19 @@
                           </a:solidFill>
                           <a:latin typeface="Calibri"/>
                         </a:rPr>
-                        <a:t>Компоненты связности (без изолированных)</a:t>
+                        <a:t>Компоненты (без изолированных)</a:t>
+                      </a:r>
+                      <a:r>
+                        <a:rPr sz="1400" b="0">
+                          <a:solidFill>
+                            <a:srgbClr val="008300"/>
+                          </a:solidFill>
+                        </a:rPr>
+                        <a:t> ⋄</a:t>
                       </a:r>
                     </a:p>
                   </a:txBody>
-                  <a:tcPr marL="73152" marR="73152" marT="27432" marB="27432">
+                  <a:tcPr marL="73152" marR="73152" marT="27432" marB="27432" anchor="ctr">
                     <a:solidFill>
                       <a:srgbClr val="FFFFFF"/>
                     </a:solidFill>
@@ -10550,7 +10932,7 @@
                       </a:r>
                     </a:p>
                   </a:txBody>
-                  <a:tcPr marL="73152" marR="73152" marT="27432" marB="27432">
+                  <a:tcPr marL="73152" marR="73152" marT="27432" marB="27432" anchor="ctr">
                     <a:solidFill>
                       <a:srgbClr val="FFFFFF"/>
                     </a:solidFill>
@@ -10573,7 +10955,7 @@
                       </a:r>
                     </a:p>
                   </a:txBody>
-                  <a:tcPr marL="73152" marR="73152" marT="27432" marB="27432">
+                  <a:tcPr marL="73152" marR="73152" marT="27432" marB="27432" anchor="ctr">
                     <a:solidFill>
                       <a:srgbClr val="FFFFFF"/>
                     </a:solidFill>
@@ -10596,9 +10978,17 @@
                         </a:rPr>
                         <a:t>Доля крупнейшей компоненты</a:t>
                       </a:r>
+                      <a:r>
+                        <a:rPr sz="1400" b="0">
+                          <a:solidFill>
+                            <a:srgbClr val="008300"/>
+                          </a:solidFill>
+                        </a:rPr>
+                        <a:t> ⋄</a:t>
+                      </a:r>
                     </a:p>
                   </a:txBody>
-                  <a:tcPr marL="73152" marR="73152" marT="27432" marB="27432">
+                  <a:tcPr marL="73152" marR="73152" marT="27432" marB="27432" anchor="ctr">
                     <a:solidFill>
                       <a:srgbClr val="FFFFFF"/>
                     </a:solidFill>
@@ -10621,7 +11011,7 @@
                       </a:r>
                     </a:p>
                   </a:txBody>
-                  <a:tcPr marL="73152" marR="73152" marT="27432" marB="27432">
+                  <a:tcPr marL="73152" marR="73152" marT="27432" marB="27432" anchor="ctr">
                     <a:solidFill>
                       <a:srgbClr val="FFFFFF"/>
                     </a:solidFill>
@@ -10644,7 +11034,7 @@
                       </a:r>
                     </a:p>
                   </a:txBody>
-                  <a:tcPr marL="73152" marR="73152" marT="27432" marB="27432">
+                  <a:tcPr marL="73152" marR="73152" marT="27432" marB="27432" anchor="ctr">
                     <a:solidFill>
                       <a:srgbClr val="FFFFFF"/>
                     </a:solidFill>
@@ -10667,9 +11057,17 @@
                         </a:rPr>
                         <a:t>Изолированные вершины</a:t>
                       </a:r>
+                      <a:r>
+                        <a:rPr sz="1400" b="0">
+                          <a:solidFill>
+                            <a:srgbClr val="008300"/>
+                          </a:solidFill>
+                        </a:rPr>
+                        <a:t> ⋄</a:t>
+                      </a:r>
                     </a:p>
                   </a:txBody>
-                  <a:tcPr marL="73152" marR="73152" marT="27432" marB="27432">
+                  <a:tcPr marL="73152" marR="73152" marT="27432" marB="27432" anchor="ctr">
                     <a:solidFill>
                       <a:srgbClr val="FFFFFF"/>
                     </a:solidFill>
@@ -10692,7 +11090,7 @@
                       </a:r>
                     </a:p>
                   </a:txBody>
-                  <a:tcPr marL="73152" marR="73152" marT="27432" marB="27432">
+                  <a:tcPr marL="73152" marR="73152" marT="27432" marB="27432" anchor="ctr">
                     <a:solidFill>
                       <a:srgbClr val="FFFFFF"/>
                     </a:solidFill>
@@ -10715,7 +11113,7 @@
                       </a:r>
                     </a:p>
                   </a:txBody>
-                  <a:tcPr marL="73152" marR="73152" marT="27432" marB="27432">
+                  <a:tcPr marL="73152" marR="73152" marT="27432" marB="27432" anchor="ctr">
                     <a:solidFill>
                       <a:srgbClr val="FFFFFF"/>
                     </a:solidFill>
@@ -10738,9 +11136,17 @@
                         </a:rPr>
                         <a:t>Мосты / точки сочленения</a:t>
                       </a:r>
+                      <a:r>
+                        <a:rPr sz="1400" b="0">
+                          <a:solidFill>
+                            <a:srgbClr val="008300"/>
+                          </a:solidFill>
+                        </a:rPr>
+                        <a:t> ⋄</a:t>
+                      </a:r>
                     </a:p>
                   </a:txBody>
-                  <a:tcPr marL="73152" marR="73152" marT="27432" marB="27432">
+                  <a:tcPr marL="73152" marR="73152" marT="27432" marB="27432" anchor="ctr">
                     <a:solidFill>
                       <a:srgbClr val="FFFFFF"/>
                     </a:solidFill>
@@ -10763,7 +11169,7 @@
                       </a:r>
                     </a:p>
                   </a:txBody>
-                  <a:tcPr marL="73152" marR="73152" marT="27432" marB="27432">
+                  <a:tcPr marL="73152" marR="73152" marT="27432" marB="27432" anchor="ctr">
                     <a:solidFill>
                       <a:srgbClr val="FFFFFF"/>
                     </a:solidFill>
@@ -10786,7 +11192,7 @@
                       </a:r>
                     </a:p>
                   </a:txBody>
-                  <a:tcPr marL="73152" marR="73152" marT="27432" marB="27432">
+                  <a:tcPr marL="73152" marR="73152" marT="27432" marB="27432" anchor="ctr">
                     <a:solidFill>
                       <a:srgbClr val="FFFFFF"/>
                     </a:solidFill>
@@ -10809,9 +11215,17 @@
                         </a:rPr>
                         <a:t>Независимые циклы (E − V + C)</a:t>
                       </a:r>
+                      <a:r>
+                        <a:rPr sz="1400" b="0">
+                          <a:solidFill>
+                            <a:srgbClr val="008300"/>
+                          </a:solidFill>
+                        </a:rPr>
+                        <a:t> ⋄</a:t>
+                      </a:r>
                     </a:p>
                   </a:txBody>
-                  <a:tcPr marL="73152" marR="73152" marT="27432" marB="27432">
+                  <a:tcPr marL="73152" marR="73152" marT="27432" marB="27432" anchor="ctr">
                     <a:solidFill>
                       <a:srgbClr val="FFFFFF"/>
                     </a:solidFill>
@@ -10834,7 +11248,7 @@
                       </a:r>
                     </a:p>
                   </a:txBody>
-                  <a:tcPr marL="73152" marR="73152" marT="27432" marB="27432">
+                  <a:tcPr marL="73152" marR="73152" marT="27432" marB="27432" anchor="ctr">
                     <a:solidFill>
                       <a:srgbClr val="FFFFFF"/>
                     </a:solidFill>
@@ -10857,7 +11271,7 @@
                       </a:r>
                     </a:p>
                   </a:txBody>
-                  <a:tcPr marL="73152" marR="73152" marT="27432" marB="27432">
+                  <a:tcPr marL="73152" marR="73152" marT="27432" marB="27432" anchor="ctr">
                     <a:solidFill>
                       <a:srgbClr val="FFFFFF"/>
                     </a:solidFill>
@@ -10880,9 +11294,17 @@
                         </a:rPr>
                         <a:t>Средняя / макс. степень</a:t>
                       </a:r>
+                      <a:r>
+                        <a:rPr sz="1400" b="0">
+                          <a:solidFill>
+                            <a:srgbClr val="008300"/>
+                          </a:solidFill>
+                        </a:rPr>
+                        <a:t> ⋄</a:t>
+                      </a:r>
                     </a:p>
                   </a:txBody>
-                  <a:tcPr marL="73152" marR="73152" marT="27432" marB="27432">
+                  <a:tcPr marL="73152" marR="73152" marT="27432" marB="27432" anchor="ctr">
                     <a:solidFill>
                       <a:srgbClr val="FFFFFF"/>
                     </a:solidFill>
@@ -10905,7 +11327,7 @@
                       </a:r>
                     </a:p>
                   </a:txBody>
-                  <a:tcPr marL="73152" marR="73152" marT="27432" marB="27432">
+                  <a:tcPr marL="73152" marR="73152" marT="27432" marB="27432" anchor="ctr">
                     <a:solidFill>
                       <a:srgbClr val="FFFFFF"/>
                     </a:solidFill>
@@ -10928,7 +11350,7 @@
                       </a:r>
                     </a:p>
                   </a:txBody>
-                  <a:tcPr marL="73152" marR="73152" marT="27432" marB="27432">
+                  <a:tcPr marL="73152" marR="73152" marT="27432" marB="27432" anchor="ctr">
                     <a:solidFill>
                       <a:srgbClr val="FFFFFF"/>
                     </a:solidFill>
@@ -10951,9 +11373,17 @@
                         </a:rPr>
                         <a:t>Кластеризация</a:t>
                       </a:r>
+                      <a:r>
+                        <a:rPr sz="1400" b="0">
+                          <a:solidFill>
+                            <a:srgbClr val="008300"/>
+                          </a:solidFill>
+                        </a:rPr>
+                        <a:t> ⋄</a:t>
+                      </a:r>
                     </a:p>
                   </a:txBody>
-                  <a:tcPr marL="73152" marR="73152" marT="27432" marB="27432">
+                  <a:tcPr marL="73152" marR="73152" marT="27432" marB="27432" anchor="ctr">
                     <a:solidFill>
                       <a:srgbClr val="FFFFFF"/>
                     </a:solidFill>
@@ -10976,7 +11406,7 @@
                       </a:r>
                     </a:p>
                   </a:txBody>
-                  <a:tcPr marL="73152" marR="73152" marT="27432" marB="27432">
+                  <a:tcPr marL="73152" marR="73152" marT="27432" marB="27432" anchor="ctr">
                     <a:solidFill>
                       <a:srgbClr val="FFFFFF"/>
                     </a:solidFill>
@@ -10999,7 +11429,7 @@
                       </a:r>
                     </a:p>
                   </a:txBody>
-                  <a:tcPr marL="73152" marR="73152" marT="27432" marB="27432">
+                  <a:tcPr marL="73152" marR="73152" marT="27432" marB="27432" anchor="ctr">
                     <a:solidFill>
                       <a:srgbClr val="FFFFFF"/>
                     </a:solidFill>
@@ -11231,7 +11661,7 @@
         <p:spPr>
           <a:xfrm>
             <a:off x="822959" y="2331720"/>
-            <a:ext cx="3017520" cy="640080"/>
+            <a:ext cx="3154680" cy="640080"/>
           </a:xfrm>
           <a:prstGeom prst="rect">
             <a:avLst/>
@@ -11257,6 +11687,14 @@
                 <a:latin typeface="Calibri"/>
               </a:rPr>
               <a:t>пар концептов связаны путём</a:t>
+            </a:r>
+            <a:r>
+              <a:rPr sz="1300" b="0">
+                <a:solidFill>
+                  <a:srgbClr val="008300"/>
+                </a:solidFill>
+              </a:rPr>
+              <a:t> ⋄</a:t>
             </a:r>
           </a:p>
         </p:txBody>
@@ -11368,7 +11806,7 @@
         <p:spPr>
           <a:xfrm>
             <a:off x="4617720" y="2331720"/>
-            <a:ext cx="3017520" cy="640080"/>
+            <a:ext cx="3154680" cy="640080"/>
           </a:xfrm>
           <a:prstGeom prst="rect">
             <a:avLst/>
@@ -11394,6 +11832,14 @@
                 <a:latin typeface="Calibri"/>
               </a:rPr>
               <a:t>покрытие ПрО: найдено из 40 ключевых понятий</a:t>
+            </a:r>
+            <a:r>
+              <a:rPr sz="1300" b="0">
+                <a:solidFill>
+                  <a:srgbClr val="008300"/>
+                </a:solidFill>
+              </a:rPr>
+              <a:t> ⋄</a:t>
             </a:r>
           </a:p>
         </p:txBody>
@@ -11505,7 +11951,7 @@
         <p:spPr>
           <a:xfrm>
             <a:off x="8412480" y="2331720"/>
-            <a:ext cx="3017520" cy="640080"/>
+            <a:ext cx="3154680" cy="640080"/>
           </a:xfrm>
           <a:prstGeom prst="rect">
             <a:avLst/>
@@ -11531,6 +11977,14 @@
                 <a:latin typeface="Calibri"/>
               </a:rPr>
               <a:t>узлов другого языка в BFS-2</a:t>
+            </a:r>
+            <a:r>
+              <a:rPr sz="1300" b="0">
+                <a:solidFill>
+                  <a:srgbClr val="008300"/>
+                </a:solidFill>
+              </a:rPr>
+              <a:t> ⋄</a:t>
             </a:r>
           </a:p>
         </p:txBody>
@@ -11576,7 +12030,7 @@
                       </a:r>
                     </a:p>
                   </a:txBody>
-                  <a:tcPr marL="73152" marR="73152" marT="27432" marB="27432">
+                  <a:tcPr marL="73152" marR="73152" marT="27432" marB="27432" anchor="ctr">
                     <a:solidFill>
                       <a:srgbClr val="F1F4F8"/>
                     </a:solidFill>
@@ -11599,7 +12053,7 @@
                       </a:r>
                     </a:p>
                   </a:txBody>
-                  <a:tcPr marL="73152" marR="73152" marT="27432" marB="27432">
+                  <a:tcPr marL="73152" marR="73152" marT="27432" marB="27432" anchor="ctr">
                     <a:solidFill>
                       <a:srgbClr val="F1F4F8"/>
                     </a:solidFill>
@@ -11622,7 +12076,7 @@
                       </a:r>
                     </a:p>
                   </a:txBody>
-                  <a:tcPr marL="73152" marR="73152" marT="27432" marB="27432">
+                  <a:tcPr marL="73152" marR="73152" marT="27432" marB="27432" anchor="ctr">
                     <a:solidFill>
                       <a:srgbClr val="F1F4F8"/>
                     </a:solidFill>
@@ -11645,9 +12099,17 @@
                         </a:rPr>
                         <a:t>BFS-1 / BFS-2 / BFS-3, узлов в среднем</a:t>
                       </a:r>
+                      <a:r>
+                        <a:rPr sz="1400" b="0">
+                          <a:solidFill>
+                            <a:srgbClr val="008300"/>
+                          </a:solidFill>
+                        </a:rPr>
+                        <a:t> ⋄</a:t>
+                      </a:r>
                     </a:p>
                   </a:txBody>
-                  <a:tcPr marL="73152" marR="73152" marT="27432" marB="27432">
+                  <a:tcPr marL="73152" marR="73152" marT="27432" marB="27432" anchor="ctr">
                     <a:solidFill>
                       <a:srgbClr val="FFFFFF"/>
                     </a:solidFill>
@@ -11670,7 +12132,7 @@
                       </a:r>
                     </a:p>
                   </a:txBody>
-                  <a:tcPr marL="73152" marR="73152" marT="27432" marB="27432">
+                  <a:tcPr marL="73152" marR="73152" marT="27432" marB="27432" anchor="ctr">
                     <a:solidFill>
                       <a:srgbClr val="FFFFFF"/>
                     </a:solidFill>
@@ -11693,7 +12155,7 @@
                       </a:r>
                     </a:p>
                   </a:txBody>
-                  <a:tcPr marL="73152" marR="73152" marT="27432" marB="27432">
+                  <a:tcPr marL="73152" marR="73152" marT="27432" marB="27432" anchor="ctr">
                     <a:solidFill>
                       <a:srgbClr val="FFFFFF"/>
                     </a:solidFill>
@@ -11716,9 +12178,17 @@
                         </a:rPr>
                         <a:t>Концептов ПрО в BFS-2</a:t>
                       </a:r>
+                      <a:r>
+                        <a:rPr sz="1400" b="0">
+                          <a:solidFill>
+                            <a:srgbClr val="008300"/>
+                          </a:solidFill>
+                        </a:rPr>
+                        <a:t> ⋄</a:t>
+                      </a:r>
                     </a:p>
                   </a:txBody>
-                  <a:tcPr marL="73152" marR="73152" marT="27432" marB="27432">
+                  <a:tcPr marL="73152" marR="73152" marT="27432" marB="27432" anchor="ctr">
                     <a:solidFill>
                       <a:srgbClr val="FFFFFF"/>
                     </a:solidFill>
@@ -11741,7 +12211,7 @@
                       </a:r>
                     </a:p>
                   </a:txBody>
-                  <a:tcPr marL="73152" marR="73152" marT="27432" marB="27432">
+                  <a:tcPr marL="73152" marR="73152" marT="27432" marB="27432" anchor="ctr">
                     <a:solidFill>
                       <a:srgbClr val="FFFFFF"/>
                     </a:solidFill>
@@ -11764,7 +12234,7 @@
                       </a:r>
                     </a:p>
                   </a:txBody>
-                  <a:tcPr marL="73152" marR="73152" marT="27432" marB="27432">
+                  <a:tcPr marL="73152" marR="73152" marT="27432" marB="27432" anchor="ctr">
                     <a:solidFill>
                       <a:srgbClr val="FFFFFF"/>
                     </a:solidFill>
@@ -11787,9 +12257,17 @@
                         </a:rPr>
                         <a:t>Шумовых узлов в BFS-2 (судья)</a:t>
                       </a:r>
+                      <a:r>
+                        <a:rPr sz="1400" b="0">
+                          <a:solidFill>
+                            <a:srgbClr val="008300"/>
+                          </a:solidFill>
+                        </a:rPr>
+                        <a:t> ⊹</a:t>
+                      </a:r>
                     </a:p>
                   </a:txBody>
-                  <a:tcPr marL="73152" marR="73152" marT="27432" marB="27432">
+                  <a:tcPr marL="73152" marR="73152" marT="27432" marB="27432" anchor="ctr">
                     <a:solidFill>
                       <a:srgbClr val="FFFFFF"/>
                     </a:solidFill>
@@ -11812,7 +12290,7 @@
                       </a:r>
                     </a:p>
                   </a:txBody>
-                  <a:tcPr marL="73152" marR="73152" marT="27432" marB="27432">
+                  <a:tcPr marL="73152" marR="73152" marT="27432" marB="27432" anchor="ctr">
                     <a:solidFill>
                       <a:srgbClr val="FFFFFF"/>
                     </a:solidFill>
@@ -11835,7 +12313,7 @@
                       </a:r>
                     </a:p>
                   </a:txBody>
-                  <a:tcPr marL="73152" marR="73152" marT="27432" marB="27432">
+                  <a:tcPr marL="73152" marR="73152" marT="27432" marB="27432" anchor="ctr">
                     <a:solidFill>
                       <a:srgbClr val="FFFFFF"/>
                     </a:solidFill>
@@ -11858,9 +12336,17 @@
                         </a:rPr>
                         <a:t>DFS: достижимо узлов</a:t>
                       </a:r>
+                      <a:r>
+                        <a:rPr sz="1400" b="0">
+                          <a:solidFill>
+                            <a:srgbClr val="008300"/>
+                          </a:solidFill>
+                        </a:rPr>
+                        <a:t> ⋄</a:t>
+                      </a:r>
                     </a:p>
                   </a:txBody>
-                  <a:tcPr marL="73152" marR="73152" marT="27432" marB="27432">
+                  <a:tcPr marL="73152" marR="73152" marT="27432" marB="27432" anchor="ctr">
                     <a:solidFill>
                       <a:srgbClr val="FFFFFF"/>
                     </a:solidFill>
@@ -11883,7 +12369,7 @@
                       </a:r>
                     </a:p>
                   </a:txBody>
-                  <a:tcPr marL="73152" marR="73152" marT="27432" marB="27432">
+                  <a:tcPr marL="73152" marR="73152" marT="27432" marB="27432" anchor="ctr">
                     <a:solidFill>
                       <a:srgbClr val="FFFFFF"/>
                     </a:solidFill>
@@ -11906,7 +12392,7 @@
                       </a:r>
                     </a:p>
                   </a:txBody>
-                  <a:tcPr marL="73152" marR="73152" marT="27432" marB="27432">
+                  <a:tcPr marL="73152" marR="73152" marT="27432" marB="27432" anchor="ctr">
                     <a:solidFill>
                       <a:srgbClr val="FFFFFF"/>
                     </a:solidFill>
@@ -11929,9 +12415,17 @@
                         </a:rPr>
                         <a:t>Средняя длина пути</a:t>
                       </a:r>
+                      <a:r>
+                        <a:rPr sz="1400" b="0">
+                          <a:solidFill>
+                            <a:srgbClr val="008300"/>
+                          </a:solidFill>
+                        </a:rPr>
+                        <a:t> ⋄</a:t>
+                      </a:r>
                     </a:p>
                   </a:txBody>
-                  <a:tcPr marL="73152" marR="73152" marT="27432" marB="27432">
+                  <a:tcPr marL="73152" marR="73152" marT="27432" marB="27432" anchor="ctr">
                     <a:solidFill>
                       <a:srgbClr val="FFFFFF"/>
                     </a:solidFill>
@@ -11954,7 +12448,7 @@
                       </a:r>
                     </a:p>
                   </a:txBody>
-                  <a:tcPr marL="73152" marR="73152" marT="27432" marB="27432">
+                  <a:tcPr marL="73152" marR="73152" marT="27432" marB="27432" anchor="ctr">
                     <a:solidFill>
                       <a:srgbClr val="FFFFFF"/>
                     </a:solidFill>
@@ -11977,7 +12471,7 @@
                       </a:r>
                     </a:p>
                   </a:txBody>
-                  <a:tcPr marL="73152" marR="73152" marT="27432" marB="27432">
+                  <a:tcPr marL="73152" marR="73152" marT="27432" marB="27432" anchor="ctr">
                     <a:solidFill>
                       <a:srgbClr val="FFFFFF"/>
                     </a:solidFill>
@@ -12023,6 +12517,14 @@
                 <a:latin typeface="Calibri"/>
               </a:rPr>
               <a:t>Пример пути в чистом графе</a:t>
+            </a:r>
+            <a:r>
+              <a:rPr sz="1300" b="0">
+                <a:solidFill>
+                  <a:srgbClr val="008300"/>
+                </a:solidFill>
+              </a:rPr>
+              <a:t> ⋄</a:t>
             </a:r>
           </a:p>
         </p:txBody>

</xml_diff>

<commit_message>
lab-2: honest cross-book metrics (Russian vertices in LCC, Russian-book share in BFS, pairs with found concepts), corrected noise interpretation, pydantic models for deck metrics (stage 4 review fixes)
Co-Authored-By: Claude Opus 5.5 <noreply@anthropic.com>
</commit_message>
<xml_diff>
--- a/1-graph/lab-2/results/presentation.pptx
+++ b/1-graph/lab-2/results/presentation.pptx
@@ -1070,7 +1070,7 @@
           <a:lstStyle/>
           <a:p>
             <a:r>
-              <a:t>Тема: как предобработка текста меняет граф знаний. Корпус — два учебника по контролируемой прокатке стали: английский обзор Tanaka (1981) и русская статья. Оба текста строят один общий граф. Сравниваем граф из сырого текста MinerU и граф после предобработки. Это вторая версия: этапы переставлены, все критерии считаются обходами графа.</a:t>
+              <a:t>Тема: как предобработка текста меняет граф знаний. Корпус — два учебника по контролируемой прокатке стали: английский обзор Tanaka (1981) и русская статья. Оба текста строят один общий граф. Сравниваем граф из сырого текста MinerU и граф после предобработки. Это вторая версия: этапы переставлены, качество этапов меряется на эталоне, все критерии считаются обходами графа.</a:t>
             </a:r>
           </a:p>
         </p:txBody>
@@ -1140,7 +1140,7 @@
           <a:lstStyle/>
           <a:p>
             <a:r>
-              <a:t>Стартуем BFS из ключевых понятий и ищем пути между 10 парами понятий из разных частей предметной области. В грязном графе связаны 3 пары из 10, в чистом — 8. BFS на 2 шага в чистом графе на 84% состоит из вершин другого языка: обход переходит из одной книги в другую. Покрытие 40 понятий выросло с 77,5% до 92,5% по названиям и с 57,5% до 65% по векторам вершин. Шум в окрестностях понятий низкий в обоих графах.</a:t>
+              <a:t>Ищем пути между 10 парами понятий из разных частей предметной области. В грязном графе для 4 пар одного из понятий нет совсем — это недостаток покрытия; из 6 оставшихся связаны 3. В чистом найдены все понятия, связаны 8 пар из 10. От ключевых понятий BFS на 2 шага достаёт вершины русской книги: 8% достигнутых вершин в грязном графе и 20% в чистом. Покрытие 40 понятий выросло с 77,5% до 92,5% по названиям и с 57,5% до 65,0% по векторам вершин. Шум в окрестностях понятий низкий в обоих графах.</a:t>
             </a:r>
           </a:p>
         </p:txBody>
@@ -1210,7 +1210,7 @@
           <a:lstStyle/>
           <a:p>
             <a:r>
-              <a:t>Шум — пять регулярных правил и проверка по словарю по всем вершинам. В грязном графе шум — опечатки OCR и номера страниц. В чистом его доля выше, но это другой шум: 23 из 32 — переменные формул вроде σ_LH, потому что формулы приходят в модель целиком. Корреференции: дубликаты по леммам и эмбеддингам названий; вершин-местоимений GraphRAG не создаёт ни в одном графе. Дубликатов в чистом больше — модель пишет одно понятие в ед. и мн. числе. Формулы: обозначения формулы ищем в вершине и в окне обхода 2 × 3 — ни одна формула не собирается целиком ни в одном графе.</a:t>
+              <a:t>Шум — пять регулярных правил и проверка по словарю по всем вершинам. Слова, которых нет ни в тексте, ни в словаре, — опечатки самой модели-экстрактора: их 7 в грязном графе и 9 в чистом, предобработка на них не влияет. Числа в грязном графе — индексы текстуры вроде {554}: модель сделала из них вершины. Шум в чистом графе выше из-за переменных формул: 23 из 32, потому что формулы приходят в модель целиком. Корреференции: дубликаты по леммам и эмбеддингам названий; вершин-местоимений GraphRAG не создаёт ни в одном графе. Дубликатов в чистом больше — модель пишет одно понятие в ед. и мн. числе. Формулы: обозначения формулы ищем в вершине и в окне обхода 2 × 3 — ни одна формула не собирается целиком.</a:t>
             </a:r>
           </a:p>
         </p:txBody>
@@ -1280,7 +1280,7 @@
           <a:lstStyle/>
           <a:p>
             <a:r>
-              <a:t>Для 120 вершин каждого графа собираем окно BFS-2: соседей, их описания и связи, плюс фрагмент текста, где название вершины встречается чаще всего. gpt-4.1 отвечает: определён ли термин полностью и сколько утверждений противоречат тексту. Готовых метрик судья не видит. В чистом графе вершин с противоречиями меньше, но разница в пределах погрешности: при 120 вершинах стандартная ошибка около 6 п. п. Типичная ошибка в обоих графах — модель-экстрактор обобщает частное утверждение текста.</a:t>
+              <a:t>Для 120 вершин каждого графа собираем окно BFS-2: соседей, их описания и связи, плюс фрагмент текста, где название вершины встречается чаще всего. gpt-4.1 отвечает: определён ли термин полностью и сколько утверждений противоречат тексту. Готовых метрик судья не видит. В чистом графе вершин с противоречиями 30,8% против 37,5%, но разница в пределах погрешности: стандартная ошибка около 6 п. п. Типичная ошибка в обоих графах — модель-экстрактор обобщает частное утверждение текста.</a:t>
             </a:r>
           </a:p>
         </p:txBody>
@@ -1350,7 +1350,7 @@
           <a:lstStyle/>
           <a:p>
             <a:r>
-              <a:t>Главное: предобработка сделала из двух изолированных частей один граф — обход переходит из английской книги в русскую, покрытие предметной области и связанность пар понятий выросли. Этапы предобработки хороши на эталоне. Не решено: дубликаты в ед. и мн. числе и вершины-обозначения из формул; формулы GraphRAG не сохраняет. Ограничения: ручной глоссарий, один прогон GraphRAG, судья — одна модель, эталон — 4 страницы. Следующий шаг — RAG на сохранённых чанках и векторах.</a:t>
+              <a:t>Главное: предобработка приблизила русскую книгу к английской — выросли покрытие предметной области, полнота и число связанных пар понятий. Этапы предобработки хороши на эталоне. Не решено: дубликаты в ед. и мн. числе и вершины-переменные из формул; формулы GraphRAG не сохраняет; большая часть русских вершин по-прежнему вне крупнейшей компоненты. Ограничения: ручной глоссарий, один прогон GraphRAG, судья — одна модель, эталон — 4 страницы. Следующий шаг — RAG на сохранённых чанках и векторах.</a:t>
             </a:r>
           </a:p>
         </p:txBody>
@@ -1560,7 +1560,7 @@
           <a:lstStyle/>
           <a:p>
             <a:r>
-              <a:t>Приводим величины к одному виду, расшифровываем аббревиатуры и ставим перед русским термином канонический английский — заново каждые 3000 символов, поэтому пометка не зависит от будущего разбиения. Английский в скобках после русского модель игнорирует, а английский первым — нет: так у двух книг появились 23 общих термина. Термины лемматизируются: существительные и пары «прилагательное + существительное» подряд. На эталоне все 7 величин и 10 терминов приведены верно — хорошо, но выборка маленькая.</a:t>
+              <a:t>Приводим величины к одному виду, расшифровываем аббревиатуры и ставим перед русским термином канонический английский — заново каждые 3000 символов, поэтому пометка не зависит от будущего разбиения. Английский в скобках после русского модель игнорирует, а английский первым — нет: так у двух книг появилось 23 общих терминов. Термины лемматизируются: существительные и пары «прилагательное + существительное» подряд. Цена — русский текст становится неграмматичным («со скорость»): для графа это нужно, чтобы формы слова склеились в одну вершину, но читать такой текст хуже. На эталоне все 7 величин и 10 терминов приведены верно — хорошо, но выборка маленькая.</a:t>
             </a:r>
           </a:p>
         </p:txBody>
@@ -1630,7 +1630,7 @@
           <a:lstStyle/>
           <a:p>
             <a:r>
-              <a:t>GraphRAG по умолчанию режет текст окнами по 1200 токенов: каждая граница рвёт предложение, таблица разрезана. Структурный разбивщик идёт по разделам и абзацам чистого текста, не режет формулы и таблицы и ставит границу на конце предложения. Осталась одна граница из 34 внутри предложения — длинный раздел без удобного места. Чанки мельче, поэтому GraphRAG их не перерезает; они сохранены для RAG.</a:t>
+              <a:t>GraphRAG по умолчанию режет текст окнами по 1200 токенов: каждая граница рвёт предложение, таблица разрезана. Структурный разбивщик идёт по разделам и абзацам чистого текста, не режет формулы и таблицы и ставит границу на конце предложения. Внутри предложения осталось 1 из 34 границ — длинный раздел без удобного места. Чанки мельче, поэтому GraphRAG их не перерезает; они сохранены для RAG. Обратная сторона: из мелких чанков модель извлекает больше вершин на токен — это видно дальше на графах.</a:t>
             </a:r>
           </a:p>
         </p:txBody>
@@ -1700,7 +1700,7 @@
           <a:lstStyle/>
           <a:p>
             <a:r>
-              <a:t>OOV считаем по исходным словам: вставленные глоссарием английские термины в знаменатель не входят. OOV упал за счёт склеенных переносов; остаток — редкие термины, которых нет в частотном словаре. Поиск по 26 вопросам на обоих языках разложен на вклад разбиения и вклад предобработки: каждый даёт около +0,1 MRR, вместе +0,18. На 10 вопросах одногруппника, написанных независимо, MRR 0,54 → 0,70.</a:t>
+              <a:t>OOV упал с 1,39% до 1,00% за счёт склеенных переносов; считаем по исходным словам, вставленные английские термины в знаменатель не входят. Остаток — редкие термины, которых нет в частотном словаре. Словарь TF-IDF уменьшился с 2416 до 2155: ушли обрывки слов и формы одного термина — это хорошо. Разреженность почти не изменилась, потому что окна одинаковые, по 300 слов. Сходство русских чанков с английскими выросло — частично за счёт вставленных английских терминов. Поиск по 26 вопросам на обоих языках разложен на вклад разбиения и вклад предобработки: MRR 0,59 → 0,77.</a:t>
             </a:r>
           </a:p>
         </p:txBody>
@@ -1770,7 +1770,7 @@
           <a:lstStyle/>
           <a:p>
             <a:r>
-              <a:t>Слева грязный граф: русский текст — отдельный остров, общих вершин у книг почти нет. Справа чистый: русские сущности висят на общих вершинах CONTROLLED ROLLING, AUSTENITE, NIOBIUM; такие вершины извлечены из обеих книг. Прямых рёбер между языками нет в обоих графах — книги связываются через общие вершины.</a:t>
+              <a:t>Слева грязный граф: в его крупнейшей компоненте 7 из 87 русских вершин, общих вершин у книг 5. Справа чистый: в крупнейшей компоненте 21 из 89 русских вершин, общих вершин 15 — CONTROLLED ROLLING, AUSTENITE, NIOBIUM. Улучшение заметное, но частичное: большая часть русских вершин всё ещё вне крупнейшей компоненты, а прямых рёбер между языками нет ни в одном графе — книги связываются только через общие вершины.</a:t>
             </a:r>
           </a:p>
         </p:txBody>
@@ -1840,7 +1840,7 @@
           <a:lstStyle/>
           <a:p>
             <a:r>
-              <a:t>Все девять критериев посчитаны по графу. Восемь — алгоритмом, без LLM; непротиворечивость — гибрид: контекст собирает обход BFS-2, оценивает gpt-4.1. Лучше стали полнота, связность, покрытие и обходы — предобработка склеила две книги. Хуже — корреференции (модель называет одно и то же по-разному) и шум: OCR-мусор ушёл, но целые формулы превратились в вершины-обозначения. Формулы не сохраняет ни один граф — это ограничение GraphRAG. Часть роста вершин — эффект более мелких чанков: 17 вершин на 1000 токенов против 10.</a:t>
+              <a:t>Все восемь критериев задания посчитаны по графу, последней строкой — обходы. Семь критериев — алгоритмом, без LLM; непротиворечивость — гибрид: контекст собирает обход BFS-2, оценивает gpt-4.1. Лучше стали полнота, связность, покрытие и обходы: предобработка приблизила русскую книгу к английской. Хуже — корреференции (модель называет одно понятие в ед. и мн. числе) и шум: в чистом графе появились вершины-переменные формул, потому что формулы приходят в модель целиком. Формулы не сохраняет ни один граф — это ограничение GraphRAG. Часть роста вершин — эффект более мелких чанков: 17,0 вершины на 1000 токенов против 10,2.</a:t>
             </a:r>
           </a:p>
         </p:txBody>
@@ -1910,7 +1910,7 @@
           <a:lstStyle/>
           <a:p>
             <a:r>
-              <a:t>Вершин и рёбер стало больше на треть, но на 1000 токенов входа — в 1,7 раза больше: чистый текст пришёл мелкими чанками, и модель извлекает из них больше. Крупнейшая компонента выросла с 55% до 66% вершин, независимых циклов больше — появились альтернативные связи. Компонент больше потому, что больше вершин, в том числе изолированных. Распределение по типам похожее; персон вдвое больше — мелкие чанки чаще выносят цитируемых авторов в вершины.</a:t>
+              <a:t>Вершин стало 424 вместо 324, но на 1000 токенов входа — 17,0 против 10,2: чистый текст пришёл мелкими чанками, и модель извлекает из них больше. Крупнейшая компонента выросла с 55% до 66% вершин, независимых циклов больше — появились альтернативные связи. Компонент и изолированных вершин больше, потому что больше вершин. Мостов и точек сочленения много в обоих графах: больше половины вершин — листья (164 и 215), граф GraphRAG — «звёзды» вокруг хабов. Максимальная степень 48 → 78: хаб CONTROLLED ROLLING собрал связи обеих книг. Распределение по типам похожее; персон больше — мелкие чанки чаще выносят цитируемых авторов в вершины.</a:t>
             </a:r>
           </a:p>
         </p:txBody>
@@ -5204,7 +5204,7 @@
                 </a:solidFill>
                 <a:latin typeface="Calibri"/>
               </a:rPr>
-              <a:t>3/10</a:t>
+              <a:t>3/6</a:t>
             </a:r>
             <a:r>
               <a:rPr sz="2200" b="1">
@@ -5261,7 +5261,7 @@
                 </a:solidFill>
                 <a:latin typeface="Calibri"/>
               </a:rPr>
-              <a:t>пар понятий связаны путём</a:t>
+              <a:t>пар связаны путём (из пар, где оба понятия найдены)</a:t>
             </a:r>
             <a:r>
               <a:rPr sz="1300" b="0">
@@ -5494,7 +5494,7 @@
                 </a:solidFill>
                 <a:latin typeface="Calibri"/>
               </a:rPr>
-              <a:t>24%</a:t>
+              <a:t>8%</a:t>
             </a:r>
             <a:r>
               <a:rPr sz="2200" b="1">
@@ -5512,7 +5512,7 @@
                 </a:solidFill>
                 <a:latin typeface="Calibri"/>
               </a:rPr>
-              <a:t>84%</a:t>
+              <a:t>20%</a:t>
             </a:r>
           </a:p>
         </p:txBody>
@@ -5551,7 +5551,7 @@
                 </a:solidFill>
                 <a:latin typeface="Calibri"/>
               </a:rPr>
-              <a:t>вершин другого языка в BFS-2</a:t>
+              <a:t>вершин русской книги в BFS-2 от ключевых понятий</a:t>
             </a:r>
             <a:r>
               <a:rPr sz="1300" b="0">
@@ -6426,7 +6426,7 @@
                           </a:solidFill>
                           <a:latin typeface="Calibri"/>
                         </a:rPr>
-                        <a:t>  из них переменные формул</a:t>
+                        <a:t>  переменные формул</a:t>
                       </a:r>
                       <a:r>
                         <a:rPr sz="1300" b="0">
@@ -6505,7 +6505,7 @@
                           </a:solidFill>
                           <a:latin typeface="Calibri"/>
                         </a:rPr>
-                        <a:t>  опечатки и неизвестные слова</a:t>
+                        <a:t>  слова не из текста и словаря</a:t>
                       </a:r>
                       <a:r>
                         <a:rPr sz="1300" b="0">
@@ -7049,7 +7049,7 @@
                 </a:solidFill>
                 <a:latin typeface="Calibri"/>
               </a:rPr>
-              <a:t>Шум грязного</a:t>
+              <a:t>Не из текста и словаря, грязный</a:t>
             </a:r>
             <a:r>
               <a:rPr sz="1300" b="0">
@@ -8333,8 +8333,8 @@
         </p:nvSpPr>
         <p:spPr>
           <a:xfrm>
-            <a:off x="548640" y="1463040"/>
-            <a:ext cx="10972800" cy="4389120"/>
+            <a:off x="548640" y="1371600"/>
+            <a:ext cx="10972800" cy="4754880"/>
           </a:xfrm>
           <a:prstGeom prst="rect">
             <a:avLst/>
@@ -8349,7 +8349,7 @@
           <a:p>
             <a:pPr algn="l">
               <a:spcAft>
-                <a:spcPts val="1200"/>
+                <a:spcPts val="1000"/>
               </a:spcAft>
             </a:pPr>
             <a:r>
@@ -8365,7 +8365,7 @@
           <a:p>
             <a:pPr algn="l">
               <a:spcAft>
-                <a:spcPts val="1200"/>
+                <a:spcPts val="1000"/>
               </a:spcAft>
             </a:pPr>
             <a:r>
@@ -8381,7 +8381,7 @@
           <a:p>
             <a:pPr algn="l">
               <a:spcAft>
-                <a:spcPts val="1200"/>
+                <a:spcPts val="1000"/>
               </a:spcAft>
             </a:pPr>
             <a:r>
@@ -8397,7 +8397,7 @@
           <a:p>
             <a:pPr algn="l">
               <a:spcAft>
-                <a:spcPts val="1200"/>
+                <a:spcPts val="1000"/>
               </a:spcAft>
             </a:pPr>
             <a:r>
@@ -8407,13 +8407,13 @@
                 </a:solidFill>
                 <a:latin typeface="Calibri"/>
               </a:rPr>
-              <a:t>Граф: 8 из 10 пар понятий связаны вместо 3, покрытие ПрО 92,5% вместо 77,5%, полнота 61% вместо 54%.</a:t>
+              <a:t>Граф: покрытие ПрО 77,5% → 92,5%, полнота 54% → 61%, связаны 3 из 6 → 8 из 10 пар понятий.</a:t>
             </a:r>
           </a:p>
           <a:p>
             <a:pPr algn="l">
               <a:spcAft>
-                <a:spcPts val="1200"/>
+                <a:spcPts val="1000"/>
               </a:spcAft>
             </a:pPr>
             <a:r>
@@ -8423,13 +8423,29 @@
                 </a:solidFill>
                 <a:latin typeface="Calibri"/>
               </a:rPr>
-              <a:t>Хуже: дубликаты ед./мн. числа и вершины-обозначения формул — нужна склейка вершин после извлечения.</a:t>
+              <a:t>Русская книга ближе: русских вершин в крупнейшей компоненте 7 из 87 → 21 из 89; связь частичная.</a:t>
             </a:r>
           </a:p>
           <a:p>
             <a:pPr algn="l">
               <a:spcAft>
-                <a:spcPts val="1200"/>
+                <a:spcPts val="1000"/>
+              </a:spcAft>
+            </a:pPr>
+            <a:r>
+              <a:rPr sz="1600" b="0">
+                <a:solidFill>
+                  <a:srgbClr val="1F2328"/>
+                </a:solidFill>
+                <a:latin typeface="Calibri"/>
+              </a:rPr>
+              <a:t>Хуже: дубликаты ед./мн. числа и вершины-переменные формул — нужна склейка вершин после извлечения.</a:t>
+            </a:r>
+          </a:p>
+          <a:p>
+            <a:pPr algn="l">
+              <a:spcAft>
+                <a:spcPts val="1000"/>
               </a:spcAft>
             </a:pPr>
             <a:r>
@@ -11303,7 +11319,7 @@
                 </a:solidFill>
                 <a:latin typeface="Calibri"/>
               </a:rPr>
-              <a:t>стало</a:t>
+              <a:t>стало (леммы терминов — ценой грамматики)</a:t>
             </a:r>
           </a:p>
         </p:txBody>
@@ -13250,7 +13266,7 @@
                 </a:solidFill>
                 <a:latin typeface="Calibri"/>
               </a:rPr>
-              <a:t>Графы: русская часть перестала быть островом</a:t>
+              <a:t>Графы: русская часть ближе к английской</a:t>
             </a:r>
           </a:p>
         </p:txBody>
@@ -13337,7 +13353,7 @@
                 </a:solidFill>
                 <a:latin typeface="Calibri"/>
               </a:rPr>
-              <a:t>вершин из обеих книг: 5, рёбер у них: 31</a:t>
+              <a:t>в крупнейшей компоненте 7 из 87 русских вершин</a:t>
             </a:r>
             <a:r>
               <a:rPr sz="1400" b="0">
@@ -13384,7 +13400,7 @@
                 </a:solidFill>
                 <a:latin typeface="Calibri"/>
               </a:rPr>
-              <a:t>вершин из обеих книг: 15, рёбер у них: 146</a:t>
+              <a:t>в крупнейшей компоненте 21 из 89 русских вершин</a:t>
             </a:r>
             <a:r>
               <a:rPr sz="1400" b="0">
@@ -13488,7 +13504,7 @@
                 </a:solidFill>
                 <a:latin typeface="Calibri"/>
               </a:rPr>
-              <a:t>Все критерии задания: грязный → чистый</a:t>
+              <a:t>8 критериев задания и обходы: грязный → чистый</a:t>
             </a:r>
           </a:p>
         </p:txBody>
@@ -13930,7 +13946,7 @@
                           </a:solidFill>
                           <a:latin typeface="Calibri"/>
                         </a:rPr>
-                        <a:t>дубликаты по леммам и cos названий ≥ 0,92; местоимения BFS-3</a:t>
+                        <a:t>вершин-дубликатов по леммам и cos ≥ 0,92; местоимений BFS-3</a:t>
                       </a:r>
                     </a:p>
                   </a:txBody>
@@ -14124,7 +14140,7 @@
                           </a:solidFill>
                           <a:latin typeface="Calibri"/>
                         </a:rPr>
-                        <a:t>OCR ушёл, пришли σ_x</a:t>
+                        <a:t>хуже: переменные формул</a:t>
                       </a:r>
                     </a:p>
                   </a:txBody>
@@ -14524,7 +14540,7 @@
                           </a:solidFill>
                           <a:latin typeface="Calibri"/>
                         </a:rPr>
-                        <a:t>Обходы</a:t>
+                        <a:t>Вершины и рёбра по типам</a:t>
                       </a:r>
                       <a:r>
                         <a:rPr sz="1200" b="0">
@@ -14555,7 +14571,7 @@
                           </a:solidFill>
                           <a:latin typeface="Calibri"/>
                         </a:rPr>
-                        <a:t>пары понятий, связанные путём; другой язык в BFS-2</a:t>
+                        <a:t>вершины / рёбра; типов вершин</a:t>
                       </a:r>
                     </a:p>
                   </a:txBody>
@@ -14578,7 +14594,7 @@
                           </a:solidFill>
                           <a:latin typeface="Calibri"/>
                         </a:rPr>
-                        <a:t>3/10; 24%</a:t>
+                        <a:t>324 / 336; 13</a:t>
                       </a:r>
                     </a:p>
                   </a:txBody>
@@ -14601,7 +14617,7 @@
                           </a:solidFill>
                           <a:latin typeface="Calibri"/>
                         </a:rPr>
-                        <a:t>8/10; 84%</a:t>
+                        <a:t>424 / 437; 12</a:t>
                       </a:r>
                     </a:p>
                   </a:txBody>
@@ -14624,7 +14640,7 @@
                           </a:solidFill>
                           <a:latin typeface="Calibri"/>
                         </a:rPr>
-                        <a:t>главный эффект</a:t>
+                        <a:t>больше, часть — мелкие чанки</a:t>
                       </a:r>
                     </a:p>
                   </a:txBody>
@@ -14649,7 +14665,7 @@
                           </a:solidFill>
                           <a:latin typeface="Calibri"/>
                         </a:rPr>
-                        <a:t>Вершины и рёбра по типам</a:t>
+                        <a:t>+ обходы</a:t>
                       </a:r>
                       <a:r>
                         <a:rPr sz="1200" b="0">
@@ -14680,7 +14696,7 @@
                           </a:solidFill>
                           <a:latin typeface="Calibri"/>
                         </a:rPr>
-                        <a:t>вершины / рёбра; типов вершин</a:t>
+                        <a:t>пары понятий, связанные путём; вершины русской книги в BFS-2</a:t>
                       </a:r>
                     </a:p>
                   </a:txBody>
@@ -14703,7 +14719,7 @@
                           </a:solidFill>
                           <a:latin typeface="Calibri"/>
                         </a:rPr>
-                        <a:t>324 / 336; 13</a:t>
+                        <a:t>3 из 6; 8%</a:t>
                       </a:r>
                     </a:p>
                   </a:txBody>
@@ -14726,7 +14742,7 @@
                           </a:solidFill>
                           <a:latin typeface="Calibri"/>
                         </a:rPr>
-                        <a:t>424 / 437; 12</a:t>
+                        <a:t>8 из 10; 20%</a:t>
                       </a:r>
                     </a:p>
                   </a:txBody>
@@ -14749,7 +14765,7 @@
                           </a:solidFill>
                           <a:latin typeface="Calibri"/>
                         </a:rPr>
-                        <a:t>+31%, часть — мелкие чанки</a:t>
+                        <a:t>лучше</a:t>
                       </a:r>
                     </a:p>
                   </a:txBody>

</xml_diff>

<commit_message>
lab-2: mark gold pages as unverified by the team, show table integrity, clarify deletion card (stage 5 review fixes)
Co-Authored-By: Claude Opus 5.5 <noreply@anthropic.com>
</commit_message>
<xml_diff>
--- a/1-graph/lab-2/results/presentation.pptx
+++ b/1-graph/lab-2/results/presentation.pptx
@@ -1420,7 +1420,7 @@
           <a:lstStyle/>
           <a:p>
             <a:r>
-              <a:t>Оба графа строит GraphRAG с одинаковыми настройками: gpt-4o-mini, bge-m3, те же промпты и типы сущностей. Грязный граф — из markdown MinerU, из которого убран только список литературы, иначе сравнение нечестное. Чистый — после пяти этапов. Очистка и нормализация работают с книгой целиком, chunking режет уже чистый текст. Качество этапов меряем на четырёх страницах, выверенных вручную по PDF. Критерии сравнения графов считаем обходами графа; LLM — только для непротиворечивости.</a:t>
+              <a:t>Оба графа строит GraphRAG с одинаковыми настройками: gpt-4o-mini, bge-m3, те же промпты и типы сущностей. Грязный граф — из markdown MinerU, из которого убран только список литературы, иначе сравнение нечестное. Чистый — после пяти этапов. Очистка и нормализация работают с книгой целиком, chunking режет уже чистый текст. Качество этапов меряем на четырёх страницах, которые автор выверил вручную по PDF; проверка эталона командой ещё не завершена, поэтому цифры на эталоне предварительные. Критерии сравнения графов считаем обходами графа; LLM — только для непротиворечивости.</a:t>
             </a:r>
           </a:p>
         </p:txBody>
@@ -6249,7 +6249,7 @@
         </p:nvGraphicFramePr>
         <p:xfrm>
           <a:off x="548640" y="1280160"/>
-          <a:ext cx="7772400" cy="3127248"/>
+          <a:ext cx="7772400" cy="3474720"/>
         </p:xfrm>
         <a:graphic>
           <a:graphicData uri="http://schemas.openxmlformats.org/drawingml/2006/table">
@@ -6955,6 +6955,85 @@
                           <a:latin typeface="Calibri"/>
                         </a:rPr>
                         <a:t>0 из 12</a:t>
+                      </a:r>
+                    </a:p>
+                  </a:txBody>
+                  <a:tcPr marL="73152" marR="73152" marT="27432" marB="27432" anchor="ctr">
+                    <a:solidFill>
+                      <a:srgbClr val="FFFFFF"/>
+                    </a:solidFill>
+                  </a:tcPr>
+                </a:tc>
+              </a:tr>
+              <a:tr h="347472">
+                <a:tc>
+                  <a:txBody>
+                    <a:bodyPr/>
+                    <a:lstStyle/>
+                    <a:p>
+                      <a:pPr algn="l"/>
+                      <a:r>
+                        <a:rPr sz="1300" b="0">
+                          <a:solidFill>
+                            <a:srgbClr val="1F2328"/>
+                          </a:solidFill>
+                          <a:latin typeface="Calibri"/>
+                        </a:rPr>
+                        <a:t>Таблица: целиком в вершине или окне</a:t>
+                      </a:r>
+                      <a:r>
+                        <a:rPr sz="1300" b="0">
+                          <a:solidFill>
+                            <a:srgbClr val="008300"/>
+                          </a:solidFill>
+                        </a:rPr>
+                        <a:t> ⋄</a:t>
+                      </a:r>
+                    </a:p>
+                  </a:txBody>
+                  <a:tcPr marL="73152" marR="73152" marT="27432" marB="27432" anchor="ctr">
+                    <a:solidFill>
+                      <a:srgbClr val="FFFFFF"/>
+                    </a:solidFill>
+                  </a:tcPr>
+                </a:tc>
+                <a:tc>
+                  <a:txBody>
+                    <a:bodyPr/>
+                    <a:lstStyle/>
+                    <a:p>
+                      <a:pPr algn="r"/>
+                      <a:r>
+                        <a:rPr sz="1300" b="0">
+                          <a:solidFill>
+                            <a:srgbClr val="EB6834"/>
+                          </a:solidFill>
+                          <a:latin typeface="Calibri"/>
+                        </a:rPr>
+                        <a:t>0 из 1</a:t>
+                      </a:r>
+                    </a:p>
+                  </a:txBody>
+                  <a:tcPr marL="73152" marR="73152" marT="27432" marB="27432" anchor="ctr">
+                    <a:solidFill>
+                      <a:srgbClr val="FFFFFF"/>
+                    </a:solidFill>
+                  </a:tcPr>
+                </a:tc>
+                <a:tc>
+                  <a:txBody>
+                    <a:bodyPr/>
+                    <a:lstStyle/>
+                    <a:p>
+                      <a:pPr algn="r"/>
+                      <a:r>
+                        <a:rPr sz="1300" b="0">
+                          <a:solidFill>
+                            <a:srgbClr val="2A78D6"/>
+                          </a:solidFill>
+                          <a:latin typeface="Calibri"/>
+                        </a:rPr>
+                        <a:t>0 из 1</a:t>
                       </a:r>
                     </a:p>
                   </a:txBody>
@@ -7049,7 +7128,7 @@
                 </a:solidFill>
                 <a:latin typeface="Calibri"/>
               </a:rPr>
-              <a:t>Не из текста и словаря, грязный</a:t>
+              <a:t>Не из текста, грязный</a:t>
             </a:r>
             <a:r>
               <a:rPr sz="1300" b="0">
@@ -9622,7 +9701,7 @@
                 </a:solidFill>
                 <a:latin typeface="Calibri"/>
               </a:rPr>
-              <a:t>Эталон: 4 страницы (по 2 из книги), выверенные по PDF, — CER/WER, точность и полнота удалений, точность приведения величин и терминов.</a:t>
+              <a:t>Эталон: 4 страницы (по 2 из книги), выверенные автором по PDF, проверка командой не завершена — CER/WER, точность и полнота удалений, точность приведения величин и терминов.</a:t>
             </a:r>
           </a:p>
           <a:p>
@@ -10190,25 +10269,25 @@
                 </a:solidFill>
                 <a:latin typeface="Calibri"/>
               </a:rPr>
+              <a:t>—</a:t>
+            </a:r>
+            <a:r>
+              <a:rPr sz="2200" b="1">
+                <a:solidFill>
+                  <a:srgbClr val="5F5E5A"/>
+                </a:solidFill>
+                <a:latin typeface="Calibri"/>
+              </a:rPr>
+              <a:t>  →  </a:t>
+            </a:r>
+            <a:r>
+              <a:rPr sz="3400" b="1">
+                <a:solidFill>
+                  <a:srgbClr val="2A78D6"/>
+                </a:solidFill>
+                <a:latin typeface="Calibri"/>
+              </a:rPr>
               <a:t>13/13</a:t>
-            </a:r>
-            <a:r>
-              <a:rPr sz="2200" b="1">
-                <a:solidFill>
-                  <a:srgbClr val="5F5E5A"/>
-                </a:solidFill>
-                <a:latin typeface="Calibri"/>
-              </a:rPr>
-              <a:t>  →  </a:t>
-            </a:r>
-            <a:r>
-              <a:rPr sz="3400" b="1">
-                <a:solidFill>
-                  <a:srgbClr val="2A78D6"/>
-                </a:solidFill>
-                <a:latin typeface="Calibri"/>
-              </a:rPr>
-              <a:t>100%</a:t>
             </a:r>
           </a:p>
         </p:txBody>
@@ -10247,7 +10326,7 @@
                 </a:solidFill>
                 <a:latin typeface="Calibri"/>
               </a:rPr>
-              <a:t>удалено нужных блоков → F1 удалений</a:t>
+              <a:t>удалено нужных блоков, лишних 0; F1 100%</a:t>
             </a:r>
             <a:r>
               <a:rPr sz="1300" b="0">
@@ -14196,7 +14275,7 @@
                           </a:solidFill>
                           <a:latin typeface="Calibri"/>
                         </a:rPr>
-                        <a:t>доля обозначений формулы в лучшем окне 2 × 3</a:t>
+                        <a:t>доля обозначений формулы в лучшем окне 2 × 3; таблиц целы</a:t>
                       </a:r>
                     </a:p>
                   </a:txBody>
@@ -14219,7 +14298,7 @@
                           </a:solidFill>
                           <a:latin typeface="Calibri"/>
                         </a:rPr>
-                        <a:t>2,8%</a:t>
+                        <a:t>2,8%; 0 из 1</a:t>
                       </a:r>
                     </a:p>
                   </a:txBody>
@@ -14242,7 +14321,7 @@
                           </a:solidFill>
                           <a:latin typeface="Calibri"/>
                         </a:rPr>
-                        <a:t>11,2%</a:t>
+                        <a:t>11,2%; 0 из 1</a:t>
                       </a:r>
                     </a:p>
                   </a:txBody>

</xml_diff>

<commit_message>
lab-2: final review fixes
- move the LLM API address out of the repo (env var for lab2 and GraphRAG)
- reference terms: n-grams and contextual nouns instead of POS of isolated lemmas
- keep Greek letters in lemma keys; resolve concepts by lemmas, deterministically, any language variant for paths
- pydantic models for the comparison report, judge answers and graph summary; split run_compare
- embed server in the repo, configurable index script, scipy dependency, dead code removed
- reports, README, glossary and deck updated with new numbers and caveats

Co-Authored-By: Claude Opus 5.5 <noreply@anthropic.com>
</commit_message>
<xml_diff>
--- a/1-graph/lab-2/results/presentation.pptx
+++ b/1-graph/lab-2/results/presentation.pptx
@@ -1140,7 +1140,7 @@
           <a:lstStyle/>
           <a:p>
             <a:r>
-              <a:t>Ищем пути между 10 парами понятий из разных частей предметной области. В грязном графе для 4 пар одного из понятий нет совсем — это недостаток покрытия; из 6 оставшихся связаны 3. В чистом найдены все понятия, связаны 8 пар из 10. От ключевых понятий BFS на 2 шага достаёт вершины русской книги: 8% достигнутых вершин в грязном графе и 20% в чистом. Покрытие 40 понятий выросло с 77,5% до 92,5% по названиям и с 57,5% до 65,0% по векторам вершин. Шум в окрестностях понятий низкий в обоих графах.</a:t>
+              <a:t>Ищем пути между 10 парами понятий из разных частей предметной области. В грязном графе для 4 пар одного из понятий нет совсем — это недостаток покрытия; из 6 оставшихся связаны 5. В чистом найдены все понятия, связаны 9 пар из 10. От ключевых понятий BFS на 2 шага достаёт вершины русской книги: 8% достигнутых вершин в грязном графе и 20% в чистом. Покрытие 40 понятий выросло с 80,0% до 92,5% по названиям и с 57,5% до 65,0% по векторам названий вершин. Рост отчасти по построению: новые понятия чистого графа — термины глоссария, которые нормализация вставила в текст; а pearlite, который был в грязном графе, в чистом потерян. Шум в окрестностях понятий низкий в обоих графах.</a:t>
             </a:r>
           </a:p>
         </p:txBody>
@@ -1280,7 +1280,7 @@
           <a:lstStyle/>
           <a:p>
             <a:r>
-              <a:t>Для 120 вершин каждого графа собираем окно BFS-2: соседей, их описания и связи, плюс фрагмент текста, где название вершины встречается чаще всего. gpt-4.1 отвечает: определён ли термин полностью и сколько утверждений противоречат тексту. Готовых метрик судья не видит. В чистом графе вершин с противоречиями 30,8% против 37,5%, но разница в пределах погрешности: стандартная ошибка около 6 п. п. Типичная ошибка в обоих графах — модель-экстрактор обобщает частное утверждение текста.</a:t>
+              <a:t>Для 120 вершин каждого графа собираем окно BFS-2: соседей, их описания и связи, плюс фрагмент текста, где название вершины встречается чаще всего. gpt-4.1 отвечает: определён ли термин полностью и сколько утверждений противоречат тексту. Готовых метрик судья не видит. В чистом графе вершин с противоречиями 30,8% против 41,7%: разница 11 п. п. при стандартной ошибке около 6 п. п. — на границе погрешности. Типичная ошибка в обоих графах — модель-экстрактор обобщает частное утверждение текста.</a:t>
             </a:r>
           </a:p>
         </p:txBody>
@@ -1840,7 +1840,7 @@
           <a:lstStyle/>
           <a:p>
             <a:r>
-              <a:t>Все восемь критериев задания посчитаны по графу, последней строкой — обходы. Семь критериев — алгоритмом, без LLM; непротиворечивость — гибрид: контекст собирает обход BFS-2, оценивает gpt-4.1. Лучше стали полнота, связность, покрытие и обходы: предобработка приблизила русскую книгу к английской. Хуже — корреференции (модель называет одно понятие в ед. и мн. числе) и шум: в чистом графе появились вершины-переменные формул, потому что формулы приходят в модель целиком. Формулы не сохраняет ни один граф — это ограничение GraphRAG. Часть роста вершин — эффект более мелких чанков: 17,0 вершины на 1000 токенов против 10,2.</a:t>
+              <a:t>Все восемь критериев задания посчитаны по графу, последней строкой — обходы. Семь критериев — алгоритмом, без LLM; непротиворечивость — гибрид: контекст собирает обход BFS-2, оценивает gpt-4.1. Лучше стали полнота, связность, покрытие и обходы: предобработка приблизила русскую книгу к английской. Хуже — корреференции (модель называет одно понятие в ед. и мн. числе) и шум: в чистом графе появились вершины-переменные формул, потому что формулы приходят в модель целиком. Формулы не сохраняет ни один граф — это ограничение GraphRAG. Рост покрытия отчасти по построению: 33 из 40 понятий — термины глоссария, которые нормализация вставляет в чистый текст. Часть роста вершин — эффект более мелких чанков: 17,0 вершины на 1000 токенов против 10,2.</a:t>
             </a:r>
           </a:p>
         </p:txBody>
@@ -5204,7 +5204,7 @@
                 </a:solidFill>
                 <a:latin typeface="Calibri"/>
               </a:rPr>
-              <a:t>3/6</a:t>
+              <a:t>5/6</a:t>
             </a:r>
             <a:r>
               <a:rPr sz="2200" b="1">
@@ -5222,7 +5222,7 @@
                 </a:solidFill>
                 <a:latin typeface="Calibri"/>
               </a:rPr>
-              <a:t>8/10</a:t>
+              <a:t>9/10</a:t>
             </a:r>
           </a:p>
         </p:txBody>
@@ -5349,7 +5349,7 @@
                 </a:solidFill>
                 <a:latin typeface="Calibri"/>
               </a:rPr>
-              <a:t>77,5%</a:t>
+              <a:t>80,0%</a:t>
             </a:r>
             <a:r>
               <a:rPr sz="2200" b="1">
@@ -5782,7 +5782,7 @@
                           </a:solidFill>
                           <a:latin typeface="Calibri"/>
                         </a:rPr>
-                        <a:t>10,6</a:t>
+                        <a:t>11,3</a:t>
                       </a:r>
                     </a:p>
                   </a:txBody>
@@ -5909,7 +5909,7 @@
                           </a:solidFill>
                           <a:latin typeface="Calibri"/>
                         </a:rPr>
-                        <a:t>Покрытие ПрО по векторам вершин</a:t>
+                        <a:t>Покрытие ПрО по векторам названий</a:t>
                       </a:r>
                       <a:r>
                         <a:rPr sz="1400" b="0">
@@ -6694,7 +6694,7 @@
                           </a:solidFill>
                           <a:latin typeface="Calibri"/>
                         </a:rPr>
-                        <a:t>17</a:t>
+                        <a:t>14</a:t>
                       </a:r>
                     </a:p>
                   </a:txBody>
@@ -6717,7 +6717,7 @@
                           </a:solidFill>
                           <a:latin typeface="Calibri"/>
                         </a:rPr>
-                        <a:t>40</a:t>
+                        <a:t>21</a:t>
                       </a:r>
                     </a:p>
                   </a:txBody>
@@ -7475,7 +7475,7 @@
                 </a:solidFill>
                 <a:latin typeface="Calibri"/>
               </a:rPr>
-              <a:t>Γ-GRAIN = Α-GRAIN</a:t>
+              <a:t>NB(C,N) = NB(C, N)</a:t>
             </a:r>
           </a:p>
           <a:p>
@@ -7491,7 +7491,7 @@
                 </a:solidFill>
                 <a:latin typeface="Calibri"/>
               </a:rPr>
-              <a:t>FERRITE = Α (FERRITE)</a:t>
+              <a:t>N_{S} = N_S</a:t>
             </a:r>
           </a:p>
           <a:p>
@@ -7507,7 +7507,7 @@
                 </a:solidFill>
                 <a:latin typeface="Calibri"/>
               </a:rPr>
-              <a:t>NB(C,N) = NB(C, N)</a:t>
+              <a:t>ПРОКАТ = ПРОКАТЫ</a:t>
             </a:r>
           </a:p>
         </p:txBody>
@@ -7683,7 +7683,7 @@
                 </a:solidFill>
                 <a:latin typeface="Calibri"/>
               </a:rPr>
-              <a:t>37,5%</a:t>
+              <a:t>41,7%</a:t>
             </a:r>
             <a:r>
               <a:rPr sz="2200" b="1">
@@ -7973,7 +7973,7 @@
                 </a:solidFill>
                 <a:latin typeface="Calibri"/>
               </a:rPr>
-              <a:t>46</a:t>
+              <a:t>51</a:t>
             </a:r>
             <a:r>
               <a:rPr sz="2200" b="1">
@@ -8486,7 +8486,7 @@
                 </a:solidFill>
                 <a:latin typeface="Calibri"/>
               </a:rPr>
-              <a:t>Граф: покрытие ПрО 77,5% → 92,5%, полнота 54% → 61%, связаны 3 из 6 → 8 из 10 пар понятий.</a:t>
+              <a:t>Граф: покрытие ПрО 80,0% → 92,5% (отчасти по построению — понятия из глоссария), полнота 58% → 66%, связаны 5 из 6 → 9 из 10 пар понятий.</a:t>
             </a:r>
           </a:p>
           <a:p>
@@ -13798,7 +13798,7 @@
                           </a:solidFill>
                           <a:latin typeface="Calibri"/>
                         </a:rPr>
-                        <a:t>53,9%</a:t>
+                        <a:t>57,8%</a:t>
                       </a:r>
                     </a:p>
                   </a:txBody>
@@ -13821,7 +13821,7 @@
                           </a:solidFill>
                           <a:latin typeface="Calibri"/>
                         </a:rPr>
-                        <a:t>60,6%</a:t>
+                        <a:t>65,6%</a:t>
                       </a:r>
                     </a:p>
                   </a:txBody>
@@ -13923,7 +13923,7 @@
                           </a:solidFill>
                           <a:latin typeface="Calibri"/>
                         </a:rPr>
-                        <a:t>37,5%</a:t>
+                        <a:t>41,7%</a:t>
                       </a:r>
                     </a:p>
                   </a:txBody>
@@ -13969,7 +13969,7 @@
                           </a:solidFill>
                           <a:latin typeface="Calibri"/>
                         </a:rPr>
-                        <a:t>в пределах погрешности</a:t>
+                        <a:t>лучше, на границе погрешности</a:t>
                       </a:r>
                     </a:p>
                   </a:txBody>
@@ -14048,7 +14048,7 @@
                           </a:solidFill>
                           <a:latin typeface="Calibri"/>
                         </a:rPr>
-                        <a:t>17 / 0</a:t>
+                        <a:t>14 / 0</a:t>
                       </a:r>
                     </a:p>
                   </a:txBody>
@@ -14071,7 +14071,7 @@
                           </a:solidFill>
                           <a:latin typeface="Calibri"/>
                         </a:rPr>
-                        <a:t>40 / 0</a:t>
+                        <a:t>21 / 0</a:t>
                       </a:r>
                     </a:p>
                   </a:txBody>
@@ -14525,7 +14525,7 @@
                           </a:solidFill>
                           <a:latin typeface="Calibri"/>
                         </a:rPr>
-                        <a:t>40 понятий: по названиям / по векторам вершин</a:t>
+                        <a:t>40 понятий: по названиям и леммам / по векторам названий</a:t>
                       </a:r>
                     </a:p>
                   </a:txBody>
@@ -14548,7 +14548,7 @@
                           </a:solidFill>
                           <a:latin typeface="Calibri"/>
                         </a:rPr>
-                        <a:t>77,5% / 57,5%</a:t>
+                        <a:t>80,0% / 57,5%</a:t>
                       </a:r>
                     </a:p>
                   </a:txBody>
@@ -14594,7 +14594,7 @@
                           </a:solidFill>
                           <a:latin typeface="Calibri"/>
                         </a:rPr>
-                        <a:t>лучше</a:t>
+                        <a:t>лучше, отчасти по построению</a:t>
                       </a:r>
                     </a:p>
                   </a:txBody>
@@ -14798,7 +14798,7 @@
                           </a:solidFill>
                           <a:latin typeface="Calibri"/>
                         </a:rPr>
-                        <a:t>3 из 6; 8%</a:t>
+                        <a:t>5 из 6; 8%</a:t>
                       </a:r>
                     </a:p>
                   </a:txBody>
@@ -14821,7 +14821,7 @@
                           </a:solidFill>
                           <a:latin typeface="Calibri"/>
                         </a:rPr>
-                        <a:t>8 из 10; 20%</a:t>
+                        <a:t>9 из 10; 20%</a:t>
                       </a:r>
                     </a:p>
                   </a:txBody>

</xml_diff>

<commit_message>
lab-2: gold pages checked by the team: typography and OCR fixes from the PDF, complete unit and term lists, metrics and docs updated
Co-Authored-By: Claude Opus 5.5 <noreply@anthropic.com>
</commit_message>
<xml_diff>
--- a/1-graph/lab-2/results/presentation.pptx
+++ b/1-graph/lab-2/results/presentation.pptx
@@ -1420,7 +1420,7 @@
           <a:lstStyle/>
           <a:p>
             <a:r>
-              <a:t>Оба графа строит GraphRAG с одинаковыми настройками: gpt-4o-mini, bge-m3, те же промпты и типы сущностей. Грязный граф — из markdown MinerU, из которого убран только список литературы, иначе сравнение нечестное. Чистый — после пяти этапов. Очистка и нормализация работают с книгой целиком, chunking режет уже чистый текст. Качество этапов меряем на четырёх страницах, которые автор выверил вручную по PDF; проверка эталона командой ещё не завершена, поэтому цифры на эталоне предварительные. Критерии сравнения графов считаем обходами графа; LLM — только для непротиворечивости.</a:t>
+              <a:t>Оба графа строит GraphRAG с одинаковыми настройками: gpt-4o-mini, bge-m3, те же промпты и типы сущностей. Грязный граф — из markdown MinerU, из которого убран только список литературы, иначе сравнение нечестное. Чистый — после пяти этапов. Очистка и нормализация работают с книгой целиком, chunking режет уже чистый текст. Качество этапов меряем на четырёх страницах, которые автор выверил вручную по PDF, а затем проверила команда. Критерии сравнения графов считаем обходами графа; LLM — только для непротиворечивости.</a:t>
             </a:r>
           </a:p>
         </p:txBody>
@@ -1490,7 +1490,7 @@
           <a:lstStyle/>
           <a:p>
             <a:r>
-              <a:t>Удаляем колонтитулы, номера страниц, ссылки на картинки, HTML-сноски, маркеры цитат и шапку с авторами, склеиваем абзацы, разорванные страницей, и переносы. Качество — на эталонных страницах: CER упал с 9,7% до 0,2%, удалено 13 из 13 блоков, которые должны были уйти, и ни одного лишнего. Это хорошо: остаток CER — OCR-ошибки в индексах таблицы, которые очистка не исправляет. Числа, формулы и ячейки таблиц сохранены на 100%.</a:t>
+              <a:t>Удаляем колонтитулы, номера страниц, ссылки на картинки, HTML-сноски, маркеры цитат и шапку с авторами, склеиваем абзацы, разорванные страницей, и переносы. Качество — на эталонных страницах: CER упал с 9,8% до 0,3%, удалено 13 из 13 блоков, которые должны были уйти, и ни одного лишнего. Это хорошо: остаток CER — OCR-ошибки в индексах таблицы, которые очистка не исправляет. Числа, формулы и ячейки таблиц сохранены на 100%.</a:t>
             </a:r>
           </a:p>
         </p:txBody>
@@ -1560,7 +1560,7 @@
           <a:lstStyle/>
           <a:p>
             <a:r>
-              <a:t>Приводим величины к одному виду, расшифровываем аббревиатуры и ставим перед русским термином канонический английский — заново каждые 3000 символов, поэтому пометка не зависит от будущего разбиения. Английский в скобках после русского модель игнорирует, а английский первым — нет: так у двух книг появилось 23 общих терминов. Термины лемматизируются: существительные и пары «прилагательное + существительное» подряд. Цена — русский текст становится неграмматичным («со скорость»): для графа это нужно, чтобы формы слова склеились в одну вершину, но читать такой текст хуже. На эталоне все 7 величин и 10 терминов приведены верно — хорошо, но выборка маленькая.</a:t>
+              <a:t>Приводим величины к одному виду, расшифровываем аббревиатуры и ставим перед русским термином канонический английский — заново каждые 3000 символов, поэтому пометка не зависит от будущего разбиения. Английский в скобках после русского модель игнорирует, а английский первым — нет: так у двух книг появилось 23 общих терминов. Термины лемматизируются: существительные и пары «прилагательное + существительное» подряд. Цена — русский текст становится неграмматичным («со скорость»): для графа это нужно, чтобы формы слова склеились в одну вершину, но читать такой текст хуже. На эталоне все 9 величин и 25 терминов приведены верно — хорошо, но выборка маленькая.</a:t>
             </a:r>
           </a:p>
         </p:txBody>
@@ -8438,7 +8438,7 @@
                 </a:solidFill>
                 <a:latin typeface="Calibri"/>
               </a:rPr>
-              <a:t>Очистка на эталоне: CER 9,7% → 0,2%, удалено 13 из 13 нужных блоков и ни одного лишнего.</a:t>
+              <a:t>Очистка на эталоне: CER 9,8% → 0,3%, удалено 13 из 13 нужных блоков и ни одного лишнего.</a:t>
             </a:r>
           </a:p>
           <a:p>
@@ -8454,7 +8454,7 @@
                 </a:solidFill>
                 <a:latin typeface="Calibri"/>
               </a:rPr>
-              <a:t>Нормализация «английский канон первым» дала 23 общих термина двух книг; эталон 7/7 и 10/10.</a:t>
+              <a:t>Нормализация «английский канон первым» дала 23 общих термина двух книг; эталон 9/9 и 25/25.</a:t>
             </a:r>
           </a:p>
           <a:p>
@@ -9701,7 +9701,7 @@
                 </a:solidFill>
                 <a:latin typeface="Calibri"/>
               </a:rPr>
-              <a:t>Эталон: 4 страницы (по 2 из книги), выверенные автором по PDF, проверка командой не завершена — CER/WER, точность и полнота удалений, точность приведения величин и терминов.</a:t>
+              <a:t>Эталон: 4 страницы (по 2 из книги), выверенные по PDF и проверенные командой — CER/WER, точность и полнота удалений, точность приведения величин и терминов.</a:t>
             </a:r>
           </a:p>
           <a:p>
@@ -9979,7 +9979,7 @@
                 </a:solidFill>
                 <a:latin typeface="Calibri"/>
               </a:rPr>
-              <a:t>9,7%</a:t>
+              <a:t>9,8%</a:t>
             </a:r>
             <a:r>
               <a:rPr sz="2200" b="1">
@@ -9997,7 +9997,7 @@
                 </a:solidFill>
                 <a:latin typeface="Calibri"/>
               </a:rPr>
-              <a:t>0,2%</a:t>
+              <a:t>0,3%</a:t>
             </a:r>
           </a:p>
         </p:txBody>
@@ -10124,7 +10124,7 @@
                 </a:solidFill>
                 <a:latin typeface="Calibri"/>
               </a:rPr>
-              <a:t>14,4%</a:t>
+              <a:t>15,1%</a:t>
             </a:r>
             <a:r>
               <a:rPr sz="2200" b="1">
@@ -10142,7 +10142,7 @@
                 </a:solidFill>
                 <a:latin typeface="Calibri"/>
               </a:rPr>
-              <a:t>2,0%</a:t>
+              <a:t>3,1%</a:t>
             </a:r>
           </a:p>
         </p:txBody>
@@ -11476,7 +11476,7 @@
                 </a:solidFill>
                 <a:latin typeface="Calibri"/>
               </a:rPr>
-              <a:t>Эталон: величины 7/7, термины 10/10; лемматизировано 6,8% слов (полная лемматизация — 24%)</a:t>
+              <a:t>Эталон: величины 9/9, термины 25/25; лемматизировано 6,8% слов (полная лемматизация — 24%)</a:t>
             </a:r>
             <a:r>
               <a:rPr sz="1400" b="0">

</xml_diff>

<commit_message>
lab-2: drop the metric marks legend, retitle the summary slide
Co-Authored-By: Claude Opus 5.5 <noreply@anthropic.com>
</commit_message>
<xml_diff>
--- a/1-graph/lab-2/results/presentation.pptx
+++ b/1-graph/lab-2/results/presentation.pptx
@@ -9730,92 +9730,6 @@
         </p:nvSpPr>
         <p:spPr>
           <a:xfrm>
-            <a:off x="548640" y="5760720"/>
-            <a:ext cx="11064240" cy="365760"/>
-          </a:xfrm>
-          <a:prstGeom prst="rect">
-            <a:avLst/>
-          </a:prstGeom>
-          <a:noFill/>
-        </p:spPr>
-        <p:txBody>
-          <a:bodyPr wrap="square" lIns="0" rIns="0" tIns="0" bIns="0">
-            <a:spAutoFit/>
-          </a:bodyPr>
-          <a:lstStyle/>
-          <a:p>
-            <a:pPr algn="l"/>
-            <a:r>
-              <a:rPr sz="1400">
-                <a:solidFill>
-                  <a:srgbClr val="5F5E5A"/>
-                </a:solidFill>
-                <a:latin typeface="Calibri"/>
-              </a:rPr>
-              <a:t>Метки у метрик:</a:t>
-            </a:r>
-            <a:r>
-              <a:rPr sz="1800" b="0">
-                <a:solidFill>
-                  <a:srgbClr val="008300"/>
-                </a:solidFill>
-              </a:rPr>
-              <a:t> ⋆</a:t>
-            </a:r>
-            <a:r>
-              <a:rPr sz="1400">
-                <a:solidFill>
-                  <a:srgbClr val="5F5E5A"/>
-                </a:solidFill>
-                <a:latin typeface="Calibri"/>
-              </a:rPr>
-              <a:t> — LLM   </a:t>
-            </a:r>
-            <a:r>
-              <a:rPr sz="1800" b="0">
-                <a:solidFill>
-                  <a:srgbClr val="008300"/>
-                </a:solidFill>
-              </a:rPr>
-              <a:t> ⋄</a:t>
-            </a:r>
-            <a:r>
-              <a:rPr sz="1400">
-                <a:solidFill>
-                  <a:srgbClr val="5F5E5A"/>
-                </a:solidFill>
-                <a:latin typeface="Calibri"/>
-              </a:rPr>
-              <a:t> — алгоритм   </a:t>
-            </a:r>
-            <a:r>
-              <a:rPr sz="1800" b="0">
-                <a:solidFill>
-                  <a:srgbClr val="008300"/>
-                </a:solidFill>
-              </a:rPr>
-              <a:t> ⊹</a:t>
-            </a:r>
-            <a:r>
-              <a:rPr sz="1400">
-                <a:solidFill>
-                  <a:srgbClr val="5F5E5A"/>
-                </a:solidFill>
-                <a:latin typeface="Calibri"/>
-              </a:rPr>
-              <a:t> — гибрид: обход графа + LLM   </a:t>
-            </a:r>
-          </a:p>
-        </p:txBody>
-      </p:sp>
-      <p:sp>
-        <p:nvSpPr>
-          <p:cNvPr id="25" name="TextBox 24"/>
-          <p:cNvSpPr txBox="1"/>
-          <p:nvPr/>
-        </p:nvSpPr>
-        <p:spPr>
-          <a:xfrm>
             <a:off x="10725912" y="6528816"/>
             <a:ext cx="914400" cy="237744"/>
           </a:xfrm>
@@ -13583,7 +13497,7 @@
                 </a:solidFill>
                 <a:latin typeface="Calibri"/>
               </a:rPr>
-              <a:t>8 критериев задания и обходы: грязный → чистый</a:t>
+              <a:t>Обходы: грязный → чистый</a:t>
             </a:r>
           </a:p>
         </p:txBody>
@@ -14862,92 +14776,6 @@
       <p:sp>
         <p:nvSpPr>
           <p:cNvPr id="4" name="TextBox 3"/>
-          <p:cNvSpPr txBox="1"/>
-          <p:nvPr/>
-        </p:nvSpPr>
-        <p:spPr>
-          <a:xfrm>
-            <a:off x="548640" y="6080760"/>
-            <a:ext cx="11064240" cy="365760"/>
-          </a:xfrm>
-          <a:prstGeom prst="rect">
-            <a:avLst/>
-          </a:prstGeom>
-          <a:noFill/>
-        </p:spPr>
-        <p:txBody>
-          <a:bodyPr wrap="square" lIns="0" rIns="0" tIns="0" bIns="0">
-            <a:spAutoFit/>
-          </a:bodyPr>
-          <a:lstStyle/>
-          <a:p>
-            <a:pPr algn="l"/>
-            <a:r>
-              <a:rPr sz="1400">
-                <a:solidFill>
-                  <a:srgbClr val="5F5E5A"/>
-                </a:solidFill>
-                <a:latin typeface="Calibri"/>
-              </a:rPr>
-              <a:t>Метки у метрик:</a:t>
-            </a:r>
-            <a:r>
-              <a:rPr sz="1800" b="0">
-                <a:solidFill>
-                  <a:srgbClr val="008300"/>
-                </a:solidFill>
-              </a:rPr>
-              <a:t> ⋆</a:t>
-            </a:r>
-            <a:r>
-              <a:rPr sz="1400">
-                <a:solidFill>
-                  <a:srgbClr val="5F5E5A"/>
-                </a:solidFill>
-                <a:latin typeface="Calibri"/>
-              </a:rPr>
-              <a:t> — LLM   </a:t>
-            </a:r>
-            <a:r>
-              <a:rPr sz="1800" b="0">
-                <a:solidFill>
-                  <a:srgbClr val="008300"/>
-                </a:solidFill>
-              </a:rPr>
-              <a:t> ⋄</a:t>
-            </a:r>
-            <a:r>
-              <a:rPr sz="1400">
-                <a:solidFill>
-                  <a:srgbClr val="5F5E5A"/>
-                </a:solidFill>
-                <a:latin typeface="Calibri"/>
-              </a:rPr>
-              <a:t> — алгоритм   </a:t>
-            </a:r>
-            <a:r>
-              <a:rPr sz="1800" b="0">
-                <a:solidFill>
-                  <a:srgbClr val="008300"/>
-                </a:solidFill>
-              </a:rPr>
-              <a:t> ⊹</a:t>
-            </a:r>
-            <a:r>
-              <a:rPr sz="1400">
-                <a:solidFill>
-                  <a:srgbClr val="5F5E5A"/>
-                </a:solidFill>
-                <a:latin typeface="Calibri"/>
-              </a:rPr>
-              <a:t> — гибрид: обход графа + LLM   </a:t>
-            </a:r>
-          </a:p>
-        </p:txBody>
-      </p:sp>
-      <p:sp>
-        <p:nvSpPr>
-          <p:cNvPr id="5" name="TextBox 4"/>
           <p:cNvSpPr txBox="1"/>
           <p:nvPr/>
         </p:nvSpPr>

</xml_diff>

<commit_message>
lab-2: rework after the 12.10 review
- formula vertices marked by regex and moved to a separate subgraph; noise counted without them
- coreference split into word forms, same-language and RU-EN translation pairs with a cosine sweep
- cycle profile: per 100 vertices, basis lengths, through the hub and across both books
- lab2 criteria recomputes non-LLM criteria with saved judge verdicts; CPU float32 in the embed server
- deck, report, README, glossary and speech updated; two slides on the fixes; TASK3.md

Co-Authored-By: Claude Opus 5.5 <noreply@anthropic.com>
</commit_message>
<xml_diff>
--- a/1-graph/lab-2/results/presentation.pptx
+++ b/1-graph/lab-2/results/presentation.pptx
@@ -1210,7 +1210,7 @@
           <a:lstStyle/>
           <a:p>
             <a:r>
-              <a:t>Шум — пять регулярных правил и проверка по словарю по всем вершинам. Слова, которых нет ни в тексте, ни в словаре, — опечатки самой модели-экстрактора: их 7 в грязном графе и 9 в чистом, предобработка на них не влияет. Числа в грязном графе — индексы текстуры вроде {554}: модель сделала из них вершины. Шум в чистом графе выше из-за переменных формул: 23 из 32, потому что формулы приходят в модель целиком. Корреференции: дубликаты по леммам и эмбеддингам названий; вершин-местоимений GraphRAG не создаёт ни в одном графе. Дубликатов в чистом больше — модель пишет одно понятие в ед. и мн. числе. Формулы: обозначения формулы ищем в вершине и в окне обхода 2 × 3 — ни одна формула не собирается целиком.</a:t>
+              <a:t>Вершины-формулы — обозначения вроде σ_LH, T_rs, Т_0 — размечаются регулярными выражениями и выносятся в отдельный подграф: 8 в грязном и 23 в чистом графе, в чистом они висят на YIELD STRESS и TRANSITION TEMPERATURE. Шум считается по остальным вершинам: 3,5% → 2,5%. Остаток — опечатки самой модели и номера индексов текстуры. Корреференции трёх видов: формы одного слова по леммам, синонимы на одном языке по косинусу ≥ 0,92 и переводы RU–EN по косинусу ≥ 0,85. Переводов в чистом графе меньше — их убрал «английский канон первым»; форм слова больше — модель пишет одно понятие в ед. и мн. числе. Вершин-местоимений GraphRAG не создаёт. Формулы целиком не собираются ни в одном графе.</a:t>
             </a:r>
           </a:p>
         </p:txBody>
@@ -1350,7 +1350,7 @@
           <a:lstStyle/>
           <a:p>
             <a:r>
-              <a:t>Главное: предобработка приблизила русскую книгу к английской — выросли покрытие предметной области, полнота и число связанных пар понятий. Этапы предобработки хороши на эталоне. Не решено: дубликаты в ед. и мн. числе и вершины-переменные из формул; формулы GraphRAG не сохраняет; большая часть русских вершин по-прежнему вне крупнейшей компоненты. Ограничения: ручной глоссарий, один прогон GraphRAG, судья — одна модель, эталон — 4 страницы. Следующий шаг — RAG на сохранённых чанках и векторах.</a:t>
+              <a:t>Главное: предобработка приблизила русскую книгу к английской — выросли покрытие предметной области, полнота и число связанных пар понятий. Этапы предобработки хороши на эталоне. Не решено: дубликаты в ед. и мн. числе; вершины-формулы вынесены в подграф, но сами формулы GraphRAG не сохраняет; большая часть русских вершин по-прежнему вне крупнейшей компоненты. Ограничения: ручной глоссарий, один прогон GraphRAG, судья — одна модель, эталон — 4 страницы. Следующий шаг — RAG на сохранённых чанках и векторах.</a:t>
             </a:r>
           </a:p>
         </p:txBody>
@@ -1840,7 +1840,7 @@
           <a:lstStyle/>
           <a:p>
             <a:r>
-              <a:t>Все восемь критериев задания посчитаны по графу, последней строкой — обходы. Семь критериев — алгоритмом, без LLM; непротиворечивость — гибрид: контекст собирает обход BFS-2, оценивает gpt-4.1. Лучше стали полнота, связность, покрытие и обходы: предобработка приблизила русскую книгу к английской. Хуже — корреференции (модель называет одно понятие в ед. и мн. числе) и шум: в чистом графе появились вершины-переменные формул, потому что формулы приходят в модель целиком. Формулы не сохраняет ни один граф — это ограничение GraphRAG. Рост покрытия отчасти по построению: 33 из 40 понятий — термины глоссария, которые нормализация вставляет в чистый текст. Часть роста вершин — эффект более мелких чанков: 17,0 вершины на 1000 токенов против 10,2.</a:t>
+              <a:t>Все восемь критериев задания посчитаны по графу, последней строкой — обходы. Семь критериев — алгоритмом, без LLM; непротиворечивость — гибрид: контекст собирает обход BFS-2, оценивает gpt-4.1. Лучше стали полнота, связность, покрытие, обходы и шум: вершины-формулы вынесены в отдельный подграф, без них шума меньше. Дубликатов-переводов стало меньше, а дубликатов-форм слова больше — модель пишет одно понятие в ед. и мн. числе. Формулы не сохраняет ни один граф — это ограничение GraphRAG. Рост покрытия отчасти по построению: 33 из 40 понятий — термины глоссария, которые нормализация вставляет в чистый текст. Часть роста вершин — эффект более мелких чанков: 17,0 вершины на 1000 токенов против 10,2.</a:t>
             </a:r>
           </a:p>
         </p:txBody>
@@ -1910,7 +1910,7 @@
           <a:lstStyle/>
           <a:p>
             <a:r>
-              <a:t>Вершин стало 424 вместо 324, но на 1000 токенов входа — 17,0 против 10,2: чистый текст пришёл мелкими чанками, и модель извлекает из них больше. Крупнейшая компонента выросла с 55% до 66% вершин, независимых циклов больше — появились альтернативные связи. Компонент и изолированных вершин больше, потому что больше вершин. Мостов и точек сочленения много в обоих графах: больше половины вершин — листья (164 и 215), граф GraphRAG — «звёзды» вокруг хабов. Максимальная степень 48 → 78: хаб CONTROLLED ROLLING собрал связи обеих книг. Распределение по типам похожее; персон больше — мелкие чанки чаще выносят цитируемых авторов в вершины.</a:t>
+              <a:t>Вершин стало 424 вместо 324, но на 1000 токенов входа — 17,0 против 10,2: чистый текст пришёл мелкими чанками, и модель извлекает из них больше. Крупнейшая компонента выросла с 55% до 66% вершин. Независимых циклов больше ровно пропорционально размеру: 22,8 и 22,9 на 100 вершин, рёбер на вершину 1,21 в обоих — плотность не изменилась. Новые циклы сшивают книги: через вершины обеих книг их 29 → 71. Компонент и изолированных вершин больше, потому что больше вершин. Мостов и точек сочленения много в обоих графах: больше половины вершин — листья (164 и 215), граф GraphRAG — «звёзды» вокруг хабов. Максимальная степень 48 → 78: хаб CONTROLLED ROLLING собрал связи обеих книг. Распределение по типам похожее; персон больше — мелкие чанки чаще выносят цитируемых авторов в вершины.</a:t>
             </a:r>
           </a:p>
         </p:txBody>
@@ -5861,7 +5861,7 @@
                           </a:solidFill>
                           <a:latin typeface="Calibri"/>
                         </a:rPr>
-                        <a:t>1,0%</a:t>
+                        <a:t>0,5%</a:t>
                       </a:r>
                     </a:p>
                   </a:txBody>
@@ -5884,7 +5884,7 @@
                           </a:solidFill>
                           <a:latin typeface="Calibri"/>
                         </a:rPr>
-                        <a:t>2,1%</a:t>
+                        <a:t>1,1%</a:t>
                       </a:r>
                     </a:p>
                   </a:txBody>
@@ -6347,7 +6347,7 @@
                           </a:solidFill>
                           <a:latin typeface="Calibri"/>
                         </a:rPr>
-                        <a:t>Шумовые вершины</a:t>
+                        <a:t>Вершины-формулы → подграф</a:t>
                       </a:r>
                       <a:r>
                         <a:rPr sz="1300" b="0">
@@ -6378,7 +6378,7 @@
                           </a:solidFill>
                           <a:latin typeface="Calibri"/>
                         </a:rPr>
-                        <a:t>17 (5,2%)</a:t>
+                        <a:t>8</a:t>
                       </a:r>
                     </a:p>
                   </a:txBody>
@@ -6401,7 +6401,7 @@
                           </a:solidFill>
                           <a:latin typeface="Calibri"/>
                         </a:rPr>
-                        <a:t>32 (7,5%)</a:t>
+                        <a:t>23</a:t>
                       </a:r>
                     </a:p>
                   </a:txBody>
@@ -6426,7 +6426,7 @@
                           </a:solidFill>
                           <a:latin typeface="Calibri"/>
                         </a:rPr>
-                        <a:t>  переменные формул</a:t>
+                        <a:t>Шумовые вершины без формул</a:t>
                       </a:r>
                       <a:r>
                         <a:rPr sz="1300" b="0">
@@ -6457,7 +6457,7 @@
                           </a:solidFill>
                           <a:latin typeface="Calibri"/>
                         </a:rPr>
-                        <a:t>6</a:t>
+                        <a:t>11 (3,5%)</a:t>
                       </a:r>
                     </a:p>
                   </a:txBody>
@@ -6480,7 +6480,7 @@
                           </a:solidFill>
                           <a:latin typeface="Calibri"/>
                         </a:rPr>
-                        <a:t>23</a:t>
+                        <a:t>10 (2,5%)</a:t>
                       </a:r>
                     </a:p>
                   </a:txBody>
@@ -6615,7 +6615,7 @@
                           </a:solidFill>
                           <a:latin typeface="Calibri"/>
                         </a:rPr>
-                        <a:t>5</a:t>
+                        <a:t>4</a:t>
                       </a:r>
                     </a:p>
                   </a:txBody>
@@ -6638,7 +6638,7 @@
                           </a:solidFill>
                           <a:latin typeface="Calibri"/>
                         </a:rPr>
-                        <a:t>1</a:t>
+                        <a:t>0</a:t>
                       </a:r>
                     </a:p>
                   </a:txBody>
@@ -6663,7 +6663,7 @@
                           </a:solidFill>
                           <a:latin typeface="Calibri"/>
                         </a:rPr>
-                        <a:t>Вершин в группах дубликатов по леммам</a:t>
+                        <a:t>  остатки LaTeX в названиях</a:t>
                       </a:r>
                       <a:r>
                         <a:rPr sz="1300" b="0">
@@ -6694,7 +6694,7 @@
                           </a:solidFill>
                           <a:latin typeface="Calibri"/>
                         </a:rPr>
-                        <a:t>14</a:t>
+                        <a:t>0</a:t>
                       </a:r>
                     </a:p>
                   </a:txBody>
@@ -6717,7 +6717,7 @@
                           </a:solidFill>
                           <a:latin typeface="Calibri"/>
                         </a:rPr>
-                        <a:t>21</a:t>
+                        <a:t>1</a:t>
                       </a:r>
                     </a:p>
                   </a:txBody>
@@ -6742,7 +6742,7 @@
                           </a:solidFill>
                           <a:latin typeface="Calibri"/>
                         </a:rPr>
-                        <a:t>Пар-дубликатов по эмбеддингам</a:t>
+                        <a:t>Дубликаты: формы слова, вершин</a:t>
                       </a:r>
                       <a:r>
                         <a:rPr sz="1300" b="0">
@@ -6773,7 +6773,7 @@
                           </a:solidFill>
                           <a:latin typeface="Calibri"/>
                         </a:rPr>
-                        <a:t>8</a:t>
+                        <a:t>14</a:t>
                       </a:r>
                     </a:p>
                   </a:txBody>
@@ -6796,7 +6796,7 @@
                           </a:solidFill>
                           <a:latin typeface="Calibri"/>
                         </a:rPr>
-                        <a:t>13</a:t>
+                        <a:t>19</a:t>
                       </a:r>
                     </a:p>
                   </a:txBody>
@@ -6821,7 +6821,7 @@
                           </a:solidFill>
                           <a:latin typeface="Calibri"/>
                         </a:rPr>
-                        <a:t>Вершин-местоимений (BFS-3)</a:t>
+                        <a:t>Дубликаты: один язык, cos ≥ 0,92</a:t>
                       </a:r>
                       <a:r>
                         <a:rPr sz="1300" b="0">
@@ -6852,7 +6852,7 @@
                           </a:solidFill>
                           <a:latin typeface="Calibri"/>
                         </a:rPr>
-                        <a:t>0</a:t>
+                        <a:t>6</a:t>
                       </a:r>
                     </a:p>
                   </a:txBody>
@@ -6875,7 +6875,7 @@
                           </a:solidFill>
                           <a:latin typeface="Calibri"/>
                         </a:rPr>
-                        <a:t>0</a:t>
+                        <a:t>11</a:t>
                       </a:r>
                     </a:p>
                   </a:txBody>
@@ -6900,7 +6900,7 @@
                           </a:solidFill>
                           <a:latin typeface="Calibri"/>
                         </a:rPr>
-                        <a:t>Формулы: целиком в вершине или окне</a:t>
+                        <a:t>Дубликаты: переводы RU–EN, cos ≥ 0,85</a:t>
                       </a:r>
                       <a:r>
                         <a:rPr sz="1300" b="0">
@@ -6931,7 +6931,7 @@
                           </a:solidFill>
                           <a:latin typeface="Calibri"/>
                         </a:rPr>
-                        <a:t>0 из 12</a:t>
+                        <a:t>5</a:t>
                       </a:r>
                     </a:p>
                   </a:txBody>
@@ -6954,7 +6954,7 @@
                           </a:solidFill>
                           <a:latin typeface="Calibri"/>
                         </a:rPr>
-                        <a:t>0 из 12</a:t>
+                        <a:t>2</a:t>
                       </a:r>
                     </a:p>
                   </a:txBody>
@@ -6979,7 +6979,7 @@
                           </a:solidFill>
                           <a:latin typeface="Calibri"/>
                         </a:rPr>
-                        <a:t>Таблица: целиком в вершине или окне</a:t>
+                        <a:t>Формулы целиком в вершине / окне</a:t>
                       </a:r>
                       <a:r>
                         <a:rPr sz="1300" b="0">
@@ -7010,7 +7010,7 @@
                           </a:solidFill>
                           <a:latin typeface="Calibri"/>
                         </a:rPr>
-                        <a:t>0 из 1</a:t>
+                        <a:t>0 из 12</a:t>
                       </a:r>
                     </a:p>
                   </a:txBody>
@@ -7033,7 +7033,7 @@
                           </a:solidFill>
                           <a:latin typeface="Calibri"/>
                         </a:rPr>
-                        <a:t>0 из 1</a:t>
+                        <a:t>0 из 12</a:t>
                       </a:r>
                     </a:p>
                   </a:txBody>
@@ -7124,11 +7124,11 @@
             <a:r>
               <a:rPr sz="1300" b="1">
                 <a:solidFill>
-                  <a:srgbClr val="EB6834"/>
+                  <a:srgbClr val="2A78D6"/>
                 </a:solidFill>
                 <a:latin typeface="Calibri"/>
               </a:rPr>
-              <a:t>Не из текста, грязный</a:t>
+              <a:t>Подграф формул, чистый</a:t>
             </a:r>
             <a:r>
               <a:rPr sz="1300" b="0">
@@ -7150,7 +7150,7 @@
         <p:spPr>
           <a:xfrm>
             <a:off x="8823960" y="1783080"/>
-            <a:ext cx="2743200" cy="1645920"/>
+            <a:ext cx="2743200" cy="1463040"/>
           </a:xfrm>
           <a:prstGeom prst="rect">
             <a:avLst/>
@@ -7175,7 +7175,7 @@
                 </a:solidFill>
                 <a:latin typeface="Calibri"/>
               </a:rPr>
-              <a:t>UNDERCOOLING</a:t>
+              <a:t>Σ_{LH}</a:t>
             </a:r>
           </a:p>
           <a:p>
@@ -7191,7 +7191,7 @@
                 </a:solidFill>
                 <a:latin typeface="Calibri"/>
               </a:rPr>
-              <a:t>UNIALAXIAL YIELD STRESS</a:t>
+              <a:t>Σ_{PH}</a:t>
             </a:r>
           </a:p>
           <a:p>
@@ -7207,7 +7207,7 @@
                 </a:solidFill>
                 <a:latin typeface="Calibri"/>
               </a:rPr>
-              <a:t>ПЛАТОФОРМА</a:t>
+              <a:t>Σ_{SH}</a:t>
             </a:r>
           </a:p>
           <a:p>
@@ -7223,7 +7223,7 @@
                 </a:solidFill>
                 <a:latin typeface="Calibri"/>
               </a:rPr>
-              <a:t>ПРОСОЧИВАНИЕ</a:t>
+              <a:t>Σ_{SUB}</a:t>
             </a:r>
           </a:p>
           <a:p>
@@ -7239,7 +7239,7 @@
                 </a:solidFill>
                 <a:latin typeface="Calibri"/>
               </a:rPr>
-              <a:t>ТЕПЕРАТУРНЫЕ ПАРАМЕТРЫ</a:t>
+              <a:t>YIELD STRESS (9)</a:t>
             </a:r>
           </a:p>
         </p:txBody>
@@ -7252,7 +7252,7 @@
         </p:nvSpPr>
         <p:spPr>
           <a:xfrm>
-            <a:off x="8823960" y="3429000"/>
+            <a:off x="8823960" y="3291840"/>
             <a:ext cx="2743200" cy="365760"/>
           </a:xfrm>
           <a:prstGeom prst="rect">
@@ -7299,7 +7299,7 @@
         </p:nvSpPr>
         <p:spPr>
           <a:xfrm>
-            <a:off x="8823960" y="3794760"/>
+            <a:off x="8823960" y="3657600"/>
             <a:ext cx="2743200" cy="914400"/>
           </a:xfrm>
           <a:prstGeom prst="rect">
@@ -7325,7 +7325,7 @@
                 </a:solidFill>
                 <a:latin typeface="Calibri"/>
               </a:rPr>
-              <a:t>D_C</a:t>
+              <a:t>BIMITE</a:t>
             </a:r>
           </a:p>
           <a:p>
@@ -7341,7 +7341,7 @@
                 </a:solidFill>
                 <a:latin typeface="Calibri"/>
               </a:rPr>
-              <a:t>F_C</a:t>
+              <a:t>DOUGLAS^2</a:t>
             </a:r>
           </a:p>
           <a:p>
@@ -7357,38 +7357,6 @@
                 </a:solidFill>
                 <a:latin typeface="Calibri"/>
               </a:rPr>
-              <a:t>BIMITE</a:t>
-            </a:r>
-          </a:p>
-          <a:p>
-            <a:pPr algn="l">
-              <a:spcAft>
-                <a:spcPts val="200"/>
-              </a:spcAft>
-            </a:pPr>
-            <a:r>
-              <a:rPr sz="1100" b="0">
-                <a:solidFill>
-                  <a:srgbClr val="1F2328"/>
-                </a:solidFill>
-                <a:latin typeface="Calibri"/>
-              </a:rPr>
-              <a:t>DOUGLAS^2</a:t>
-            </a:r>
-          </a:p>
-          <a:p>
-            <a:pPr algn="l">
-              <a:spcAft>
-                <a:spcPts val="200"/>
-              </a:spcAft>
-            </a:pPr>
-            <a:r>
-              <a:rPr sz="1100" b="0">
-                <a:solidFill>
-                  <a:srgbClr val="1F2328"/>
-                </a:solidFill>
-                <a:latin typeface="Calibri"/>
-              </a:rPr>
               <a:t>GHGR</a:t>
             </a:r>
           </a:p>
@@ -7402,7 +7370,7 @@
         </p:nvSpPr>
         <p:spPr>
           <a:xfrm>
-            <a:off x="8823960" y="4892040"/>
+            <a:off x="8823960" y="4663440"/>
             <a:ext cx="2743200" cy="365760"/>
           </a:xfrm>
           <a:prstGeom prst="rect">
@@ -7424,11 +7392,11 @@
             <a:r>
               <a:rPr sz="1300" b="1">
                 <a:solidFill>
-                  <a:srgbClr val="2A78D6"/>
+                  <a:srgbClr val="EB6834"/>
                 </a:solidFill>
                 <a:latin typeface="Calibri"/>
               </a:rPr>
-              <a:t>Дубликаты чистого</a:t>
+              <a:t>Переводы, грязный</a:t>
             </a:r>
             <a:r>
               <a:rPr sz="1300" b="0">
@@ -7449,7 +7417,7 @@
         </p:nvSpPr>
         <p:spPr>
           <a:xfrm>
-            <a:off x="8823960" y="5257800"/>
+            <a:off x="8823960" y="5029200"/>
             <a:ext cx="2743200" cy="914400"/>
           </a:xfrm>
           <a:prstGeom prst="rect">
@@ -7475,7 +7443,7 @@
                 </a:solidFill>
                 <a:latin typeface="Calibri"/>
               </a:rPr>
-              <a:t>NB(C,N) = NB(C, N)</a:t>
+              <a:t>ДЕФОРМАЦИЯ = DEFORMATION</a:t>
             </a:r>
           </a:p>
           <a:p>
@@ -7491,7 +7459,7 @@
                 </a:solidFill>
                 <a:latin typeface="Calibri"/>
               </a:rPr>
-              <a:t>N_{S} = N_S</a:t>
+              <a:t>НОРМАЛИЗАЦИЯ = NORMALIZING</a:t>
             </a:r>
           </a:p>
           <a:p>
@@ -7507,7 +7475,7 @@
                 </a:solidFill>
                 <a:latin typeface="Calibri"/>
               </a:rPr>
-              <a:t>ПРОКАТ = ПРОКАТЫ</a:t>
+              <a:t>КАРБОН = CARBON</a:t>
             </a:r>
           </a:p>
         </p:txBody>
@@ -8518,7 +8486,7 @@
                 </a:solidFill>
                 <a:latin typeface="Calibri"/>
               </a:rPr>
-              <a:t>Хуже: дубликаты ед./мн. числа и вершины-переменные формул — нужна склейка вершин после извлечения.</a:t>
+              <a:t>Шум без вершин-формул 3,5% → 2,5%; формулы — в отдельном подграфе. Хуже: дубликаты ед./мн. числа — нужна склейка вершин после извлечения.</a:t>
             </a:r>
           </a:p>
           <a:p>
@@ -13939,7 +13907,7 @@
                           </a:solidFill>
                           <a:latin typeface="Calibri"/>
                         </a:rPr>
-                        <a:t>вершин-дубликатов по леммам и cos ≥ 0,92; местоимений BFS-3</a:t>
+                        <a:t>формы слова (леммы) / переводы RU–EN (cos ≥ 0,85); местоимений 0</a:t>
                       </a:r>
                     </a:p>
                   </a:txBody>
@@ -13962,7 +13930,7 @@
                           </a:solidFill>
                           <a:latin typeface="Calibri"/>
                         </a:rPr>
-                        <a:t>14 / 0</a:t>
+                        <a:t>14 / 5</a:t>
                       </a:r>
                     </a:p>
                   </a:txBody>
@@ -13985,7 +13953,7 @@
                           </a:solidFill>
                           <a:latin typeface="Calibri"/>
                         </a:rPr>
-                        <a:t>21 / 0</a:t>
+                        <a:t>19 / 2</a:t>
                       </a:r>
                     </a:p>
                   </a:txBody>
@@ -14008,7 +13976,7 @@
                           </a:solidFill>
                           <a:latin typeface="Calibri"/>
                         </a:rPr>
-                        <a:t>хуже: ед./мн. число</a:t>
+                        <a:t>переводы ↓, формы слова ↑</a:t>
                       </a:r>
                     </a:p>
                   </a:txBody>
@@ -14064,7 +14032,7 @@
                           </a:solidFill>
                           <a:latin typeface="Calibri"/>
                         </a:rPr>
-                        <a:t>5 регулярных правил + словарь по всем вершинам</a:t>
+                        <a:t>5 регулярных правил + словарь; формулы — в отдельный подграф</a:t>
                       </a:r>
                     </a:p>
                   </a:txBody>
@@ -14087,7 +14055,7 @@
                           </a:solidFill>
                           <a:latin typeface="Calibri"/>
                         </a:rPr>
-                        <a:t>5,2%</a:t>
+                        <a:t>3,5%</a:t>
                       </a:r>
                     </a:p>
                   </a:txBody>
@@ -14110,7 +14078,7 @@
                           </a:solidFill>
                           <a:latin typeface="Calibri"/>
                         </a:rPr>
-                        <a:t>7,5%</a:t>
+                        <a:t>2,5%</a:t>
                       </a:r>
                     </a:p>
                   </a:txBody>
@@ -14133,7 +14101,7 @@
                           </a:solidFill>
                           <a:latin typeface="Calibri"/>
                         </a:rPr>
-                        <a:t>хуже: переменные формул</a:t>
+                        <a:t>лучше</a:t>
                       </a:r>
                     </a:p>
                   </a:txBody>
@@ -14383,7 +14351,7 @@
                           </a:solidFill>
                           <a:latin typeface="Calibri"/>
                         </a:rPr>
-                        <a:t>связнее</a:t>
+                        <a:t>связнее; циклов ∝ размеру</a:t>
                       </a:r>
                     </a:p>
                   </a:txBody>
@@ -14879,7 +14847,7 @@
         </p:nvGraphicFramePr>
         <p:xfrm>
           <a:off x="548640" y="1417320"/>
-          <a:ext cx="7132320" cy="3127248"/>
+          <a:ext cx="7132320" cy="3474720"/>
         </p:xfrm>
         <a:graphic>
           <a:graphicData uri="http://schemas.openxmlformats.org/drawingml/2006/table">
@@ -15372,7 +15340,7 @@
                           </a:solidFill>
                           <a:latin typeface="Calibri"/>
                         </a:rPr>
-                        <a:t>Независимые циклы (E − V + C)</a:t>
+                        <a:t>Циклы (E − V + C) / на 100 вершин</a:t>
                       </a:r>
                       <a:r>
                         <a:rPr sz="1400" b="0">
@@ -15403,7 +15371,7 @@
                           </a:solidFill>
                           <a:latin typeface="Calibri"/>
                         </a:rPr>
-                        <a:t>74</a:t>
+                        <a:t>74 / 22,8</a:t>
                       </a:r>
                     </a:p>
                   </a:txBody>
@@ -15426,7 +15394,86 @@
                           </a:solidFill>
                           <a:latin typeface="Calibri"/>
                         </a:rPr>
-                        <a:t>97</a:t>
+                        <a:t>97 / 22,9</a:t>
+                      </a:r>
+                    </a:p>
+                  </a:txBody>
+                  <a:tcPr marL="73152" marR="73152" marT="27432" marB="27432" anchor="ctr">
+                    <a:solidFill>
+                      <a:srgbClr val="FFFFFF"/>
+                    </a:solidFill>
+                  </a:tcPr>
+                </a:tc>
+              </a:tr>
+              <a:tr h="347472">
+                <a:tc>
+                  <a:txBody>
+                    <a:bodyPr/>
+                    <a:lstStyle/>
+                    <a:p>
+                      <a:pPr algn="l"/>
+                      <a:r>
+                        <a:rPr sz="1400" b="0">
+                          <a:solidFill>
+                            <a:srgbClr val="1F2328"/>
+                          </a:solidFill>
+                          <a:latin typeface="Calibri"/>
+                        </a:rPr>
+                        <a:t>Циклы через вершины обеих книг</a:t>
+                      </a:r>
+                      <a:r>
+                        <a:rPr sz="1400" b="0">
+                          <a:solidFill>
+                            <a:srgbClr val="008300"/>
+                          </a:solidFill>
+                        </a:rPr>
+                        <a:t> ⋄</a:t>
+                      </a:r>
+                    </a:p>
+                  </a:txBody>
+                  <a:tcPr marL="73152" marR="73152" marT="27432" marB="27432" anchor="ctr">
+                    <a:solidFill>
+                      <a:srgbClr val="FFFFFF"/>
+                    </a:solidFill>
+                  </a:tcPr>
+                </a:tc>
+                <a:tc>
+                  <a:txBody>
+                    <a:bodyPr/>
+                    <a:lstStyle/>
+                    <a:p>
+                      <a:pPr algn="r"/>
+                      <a:r>
+                        <a:rPr sz="1400" b="0">
+                          <a:solidFill>
+                            <a:srgbClr val="EB6834"/>
+                          </a:solidFill>
+                          <a:latin typeface="Calibri"/>
+                        </a:rPr>
+                        <a:t>29</a:t>
+                      </a:r>
+                    </a:p>
+                  </a:txBody>
+                  <a:tcPr marL="73152" marR="73152" marT="27432" marB="27432" anchor="ctr">
+                    <a:solidFill>
+                      <a:srgbClr val="FFFFFF"/>
+                    </a:solidFill>
+                  </a:tcPr>
+                </a:tc>
+                <a:tc>
+                  <a:txBody>
+                    <a:bodyPr/>
+                    <a:lstStyle/>
+                    <a:p>
+                      <a:pPr algn="r"/>
+                      <a:r>
+                        <a:rPr sz="1400" b="0">
+                          <a:solidFill>
+                            <a:srgbClr val="2A78D6"/>
+                          </a:solidFill>
+                          <a:latin typeface="Calibri"/>
+                        </a:rPr>
+                        <a:t>71</a:t>
                       </a:r>
                     </a:p>
                   </a:txBody>

</xml_diff>